<commit_message>
docs(ppt): align Slide 4 headers with exact official SIH template wording
</commit_message>
<xml_diff>
--- a/SatQuery_AI_SIH26167_Official_6Slides.pptx
+++ b/SatQuery_AI_SIH26167_Official_6Slides.pptx
@@ -5887,7 +5887,7 @@
               </a:defRPr>
             </a:pPr>
             <a:r>
-              <a:t>• Analysis of Feasibility</a:t>
+              <a:t>• Analysis of the feasibility of the idea</a:t>
             </a:r>
           </a:p>
           <a:p>
@@ -6059,7 +6059,7 @@
               </a:defRPr>
             </a:pPr>
             <a:r>
-              <a:t>• Potential Challenges &amp; Risks</a:t>
+              <a:t>• Potential challenges and risks</a:t>
             </a:r>
           </a:p>
           <a:p>
@@ -6231,7 +6231,7 @@
               </a:defRPr>
             </a:pPr>
             <a:r>
-              <a:t>• Strategies to Overcome These Challenges</a:t>
+              <a:t>• Strategies for overcoming these challenges</a:t>
             </a:r>
           </a:p>
           <a:p>

</xml_diff>

<commit_message>
docs(ppt): shorten Slide 4 bullets for high-impact concise presentation
</commit_message>
<xml_diff>
--- a/SatQuery_AI_SIH26167_Official_6Slides.pptx
+++ b/SatQuery_AI_SIH26167_Official_6Slides.pptx
@@ -5902,7 +5902,7 @@
                   <a:srgbClr val="212529"/>
                 </a:solidFill>
               </a:rPr>
-              <a:t>• Technical Feasibility: </a:t>
+              <a:t>• Technical: </a:t>
             </a:r>
             <a:r>
               <a:rPr sz="1019">
@@ -5910,7 +5910,7 @@
                   <a:srgbClr val="212529"/>
                 </a:solidFill>
               </a:rPr>
-              <a:t>Fully implemented and validated working prototype; successfully tested on BigEarthNet, Sentinel-1/2, and ISRO Resourcesat-2A rasters.</a:t>
+              <a:t>Proven working prototype tested on Sentinel-1/2, BigEarthNet, and ISRO rasters.</a:t>
             </a:r>
           </a:p>
           <a:p>
@@ -5925,7 +5925,7 @@
                   <a:srgbClr val="212529"/>
                 </a:solidFill>
               </a:rPr>
-              <a:t>• Operational Feasibility: </a:t>
+              <a:t>• Operational: </a:t>
             </a:r>
             <a:r>
               <a:rPr sz="1019">
@@ -5933,7 +5933,7 @@
                   <a:srgbClr val="212529"/>
                 </a:solidFill>
               </a:rPr>
-              <a:t>Zero paid third-party API dependencies; completely self-contained architecture deployable locally or on air-gapped on-premise servers.</a:t>
+              <a:t>100% self-contained; zero paid API dependencies; works offline/air-gapped.</a:t>
             </a:r>
           </a:p>
           <a:p>
@@ -5948,7 +5948,7 @@
                   <a:srgbClr val="212529"/>
                 </a:solidFill>
               </a:rPr>
-              <a:t>• Economic Viability: </a:t>
+              <a:t>• Economic: </a:t>
             </a:r>
             <a:r>
               <a:rPr sz="1019">
@@ -5956,7 +5956,7 @@
                   <a:srgbClr val="212529"/>
                 </a:solidFill>
               </a:rPr>
-              <a:t>Built 100% on open-source libraries (React, FastAPI, GDAL, PyTorch), eliminating expensive proprietary per-seat GIS licensing fees.</a:t>
+              <a:t>Open-source stack (GDAL, PyTorch); eliminates expensive per-seat GIS software fees.</a:t>
             </a:r>
           </a:p>
           <a:p>
@@ -5971,7 +5971,7 @@
                   <a:srgbClr val="212529"/>
                 </a:solidFill>
               </a:rPr>
-              <a:t>• Hardware Accessibility: </a:t>
+              <a:t>• Hardware: </a:t>
             </a:r>
             <a:r>
               <a:rPr sz="1019">
@@ -5979,7 +5979,7 @@
                   <a:srgbClr val="212529"/>
                 </a:solidFill>
               </a:rPr>
-              <a:t>Optimized models run smoothly on standard workstation CPUs without requiring multi-GPU enterprise server clusters.</a:t>
+              <a:t>Runs smoothly on standard CPUs (&lt;300ms) with optional CUDA acceleration.</a:t>
             </a:r>
           </a:p>
         </p:txBody>
@@ -6082,7 +6082,7 @@
                   <a:srgbClr val="212529"/>
                 </a:solidFill>
               </a:rPr>
-              <a:t>Varying coordinate reference systems (UTM vs Geographic), spatial resolutions (5.8m to 20m), and band channel orders across satellites.</a:t>
+              <a:t>Varying CRS projections, resolutions (5.8m–20m), and band orders.</a:t>
             </a:r>
           </a:p>
           <a:p>
@@ -6097,7 +6097,7 @@
                   <a:srgbClr val="212529"/>
                 </a:solidFill>
               </a:rPr>
-              <a:t>• Atmospheric Obstruction: </a:t>
+              <a:t>• Weather &amp; Clouds: </a:t>
             </a:r>
             <a:r>
               <a:rPr sz="1019">
@@ -6105,7 +6105,7 @@
                   <a:srgbClr val="212529"/>
                 </a:solidFill>
               </a:rPr>
-              <a:t>Heavy monsoon cloud cover, shadowing, and haze frequently obscure critical optical satellite imagery during flood disasters.</a:t>
+              <a:t>Monsoon cloud cover and haze obscure critical optical satellite imagery.</a:t>
             </a:r>
           </a:p>
           <a:p>
@@ -6128,7 +6128,7 @@
                   <a:srgbClr val="212529"/>
                 </a:solidFill>
               </a:rPr>
-              <a:t>Granular noise artifacts in radar backscatter can cause false alarms in land-cover classification and edge detection.</a:t>
+              <a:t>Radar backscatter noise artifacts causing false detection alarms.</a:t>
             </a:r>
           </a:p>
           <a:p>
@@ -6143,7 +6143,7 @@
                   <a:srgbClr val="212529"/>
                 </a:solidFill>
               </a:rPr>
-              <a:t>• Hallucination Risk: </a:t>
+              <a:t>• AI Hallucination: </a:t>
             </a:r>
             <a:r>
               <a:rPr sz="1019">
@@ -6151,7 +6151,7 @@
                   <a:srgbClr val="212529"/>
                 </a:solidFill>
               </a:rPr>
-              <a:t>Generic commercial LLMs hallucinate inaccurate geo-features, nonexistent coordinates, and unverified confidence levels.</a:t>
+              <a:t>Generic LLMs inventing ungrounded coordinates and false features.</a:t>
             </a:r>
           </a:p>
         </p:txBody>
@@ -6246,7 +6246,7 @@
                   <a:srgbClr val="212529"/>
                 </a:solidFill>
               </a:rPr>
-              <a:t>• Automated Normalization: </a:t>
+              <a:t>• Auto-Normalization: </a:t>
             </a:r>
             <a:r>
               <a:rPr sz="1019">
@@ -6254,7 +6254,7 @@
                   <a:srgbClr val="212529"/>
                 </a:solidFill>
               </a:rPr>
-              <a:t>MetadataExtractor &amp; RasterIngestor automatically detect CRS, reproject coordinates, and reorder spectral bands.</a:t>
+              <a:t>Ingestor auto-detects CRS, aligns projections, and standardizes bands.</a:t>
             </a:r>
           </a:p>
           <a:p>
@@ -6269,7 +6269,7 @@
                   <a:srgbClr val="212529"/>
                 </a:solidFill>
               </a:rPr>
-              <a:t>• Optical + SAR Cross-Fusion: </a:t>
+              <a:t>• Optical + SAR Fusion: </a:t>
             </a:r>
             <a:r>
               <a:rPr sz="1019">
@@ -6277,7 +6277,7 @@
                   <a:srgbClr val="212529"/>
                 </a:solidFill>
               </a:rPr>
-              <a:t>Synthetic Aperture Radar (SAR) microwave pulses penetrate clouds and rain, ensuring uninterrupted disaster monitoring.</a:t>
+              <a:t>Radar microwaves pierce clouds and rain for 24/7 all-weather monitoring.</a:t>
             </a:r>
           </a:p>
           <a:p>
@@ -6292,7 +6292,7 @@
                   <a:srgbClr val="212529"/>
                 </a:solidFill>
               </a:rPr>
-              <a:t>• Dual-Polarization Thresholding: </a:t>
+              <a:t>• Speckle Filtering: </a:t>
             </a:r>
             <a:r>
               <a:rPr sz="1019">
@@ -6300,7 +6300,7 @@
                   <a:srgbClr val="212529"/>
                 </a:solidFill>
               </a:rPr>
-              <a:t>Applies VV/VH backscatter ratio filtering and adaptive Otsu thresholding to suppress speckle and isolate water bodies.</a:t>
+              <a:t>VV/VH dual-polarization filtering and adaptive Otsu thresholding.</a:t>
             </a:r>
           </a:p>
           <a:p>
@@ -6315,7 +6315,7 @@
                   <a:srgbClr val="212529"/>
                 </a:solidFill>
               </a:rPr>
-              <a:t>• Strict Capability Routing: </a:t>
+              <a:t>• Deterministic Routing: </a:t>
             </a:r>
             <a:r>
               <a:rPr sz="1019">
@@ -6323,7 +6323,7 @@
                   <a:srgbClr val="212529"/>
                 </a:solidFill>
               </a:rPr>
-              <a:t>Deterministic agent orchestrator and specialized spectral index tools eliminate hallucinations completely.</a:t>
+              <a:t>Grounded pixel masks, audit logs, and calibrated confidence (84–98%).</a:t>
             </a:r>
           </a:p>
         </p:txBody>

</xml_diff>

<commit_message>
docs(ppt): shorten Slide 5 bullets and align exact template headers
</commit_message>
<xml_diff>
--- a/SatQuery_AI_SIH26167_Official_6Slides.pptx
+++ b/SatQuery_AI_SIH26167_Official_6Slides.pptx
@@ -6732,129 +6732,129 @@
           <a:lstStyle/>
           <a:p>
             <a:pPr>
-              <a:defRPr sz="1500" b="1">
+              <a:defRPr sz="1400" b="1">
                 <a:solidFill>
                   <a:srgbClr val="0B2C5B"/>
                 </a:solidFill>
               </a:defRPr>
             </a:pPr>
             <a:r>
-              <a:t>• Potential Impact on Target Audience</a:t>
+              <a:t>• Potential impact on the target audience</a:t>
             </a:r>
           </a:p>
           <a:p>
             <a:pPr>
               <a:spcBef>
-                <a:spcPts val="700"/>
+                <a:spcPts val="800"/>
               </a:spcBef>
             </a:pPr>
             <a:r>
-              <a:rPr b="1" sz="1019">
-                <a:solidFill>
-                  <a:srgbClr val="212529"/>
-                </a:solidFill>
-              </a:rPr>
-              <a:t>• Disaster Response Teams (NDRF, SDMA): </a:t>
-            </a:r>
-            <a:r>
-              <a:rPr sz="1019">
-                <a:solidFill>
-                  <a:srgbClr val="212529"/>
-                </a:solidFill>
-              </a:rPr>
-              <a:t>Provides instant flood boundary maps and inundated area calculations (Hydro-NDWI in &lt;70ms) to prioritize life-saving rescue operations.</a:t>
+              <a:rPr b="1" sz="1050">
+                <a:solidFill>
+                  <a:srgbClr val="212529"/>
+                </a:solidFill>
+              </a:rPr>
+              <a:t>• Disaster Response (NDRF/SDMA): </a:t>
+            </a:r>
+            <a:r>
+              <a:rPr sz="1050">
+                <a:solidFill>
+                  <a:srgbClr val="212529"/>
+                </a:solidFill>
+              </a:rPr>
+              <a:t>Instant flood extent boundaries &amp; affected area stats (&lt;70ms) to prioritize rescues.</a:t>
             </a:r>
           </a:p>
           <a:p>
             <a:pPr>
               <a:spcBef>
-                <a:spcPts val="700"/>
+                <a:spcPts val="800"/>
               </a:spcBef>
             </a:pPr>
             <a:r>
-              <a:rPr b="1" sz="1019">
-                <a:solidFill>
-                  <a:srgbClr val="212529"/>
-                </a:solidFill>
-              </a:rPr>
-              <a:t>• Water Resource Authorities (Ministry of Jal Shakti): </a:t>
-            </a:r>
-            <a:r>
-              <a:rPr sz="1019">
-                <a:solidFill>
-                  <a:srgbClr val="212529"/>
-                </a:solidFill>
-              </a:rPr>
-              <a:t>Enables automated monitoring of reservoir levels, seasonal surface water shrinkage, and wetland conservation without dedicated GIS teams.</a:t>
+              <a:rPr b="1" sz="1050">
+                <a:solidFill>
+                  <a:srgbClr val="212529"/>
+                </a:solidFill>
+              </a:rPr>
+              <a:t>• Water Authorities (Jal Shakti): </a:t>
+            </a:r>
+            <a:r>
+              <a:rPr sz="1050">
+                <a:solidFill>
+                  <a:srgbClr val="212529"/>
+                </a:solidFill>
+              </a:rPr>
+              <a:t>Automates reservoir tracking and wetland depletion monitoring without GIS staff.</a:t>
             </a:r>
           </a:p>
           <a:p>
             <a:pPr>
               <a:spcBef>
-                <a:spcPts val="700"/>
+                <a:spcPts val="800"/>
               </a:spcBef>
             </a:pPr>
             <a:r>
-              <a:rPr b="1" sz="1019">
-                <a:solidFill>
-                  <a:srgbClr val="212529"/>
-                </a:solidFill>
-              </a:rPr>
-              <a:t>• Urban Planning &amp; Municipal Corporations: </a:t>
-            </a:r>
-            <a:r>
-              <a:rPr sz="1019">
-                <a:solidFill>
-                  <a:srgbClr val="212529"/>
-                </a:solidFill>
-              </a:rPr>
-              <a:t>Automatically detects illegal urban encroachments, built-up sprawl, and changes in green cover using NDBI and bi-temporal comparison.</a:t>
+              <a:rPr b="1" sz="1050">
+                <a:solidFill>
+                  <a:srgbClr val="212529"/>
+                </a:solidFill>
+              </a:rPr>
+              <a:t>• Urban Municipalities: </a:t>
+            </a:r>
+            <a:r>
+              <a:rPr sz="1050">
+                <a:solidFill>
+                  <a:srgbClr val="212529"/>
+                </a:solidFill>
+              </a:rPr>
+              <a:t>Detects unauthorized built-up sprawl and green cover loss via bi-temporal change maps.</a:t>
             </a:r>
           </a:p>
           <a:p>
             <a:pPr>
               <a:spcBef>
-                <a:spcPts val="700"/>
+                <a:spcPts val="800"/>
               </a:spcBef>
             </a:pPr>
             <a:r>
-              <a:rPr b="1" sz="1019">
-                <a:solidFill>
-                  <a:srgbClr val="212529"/>
-                </a:solidFill>
-              </a:rPr>
-              <a:t>• Agricultural &amp; Drought Monitoring: </a:t>
-            </a:r>
-            <a:r>
-              <a:rPr sz="1019">
-                <a:solidFill>
-                  <a:srgbClr val="212529"/>
-                </a:solidFill>
-              </a:rPr>
-              <a:t>Tracks crop canopy variations, irrigation patterns, and drought stress via spectral index calculations and land-cover VQA.</a:t>
+              <a:rPr b="1" sz="1050">
+                <a:solidFill>
+                  <a:srgbClr val="212529"/>
+                </a:solidFill>
+              </a:rPr>
+              <a:t>• District Administrators: </a:t>
+            </a:r>
+            <a:r>
+              <a:rPr sz="1050">
+                <a:solidFill>
+                  <a:srgbClr val="212529"/>
+                </a:solidFill>
+              </a:rPr>
+              <a:t>Enables non-technical field officers to query satellite scenes in plain natural language.</a:t>
             </a:r>
           </a:p>
           <a:p>
             <a:pPr>
               <a:spcBef>
-                <a:spcPts val="700"/>
+                <a:spcPts val="800"/>
               </a:spcBef>
             </a:pPr>
             <a:r>
-              <a:rPr b="1" sz="1019">
-                <a:solidFill>
-                  <a:srgbClr val="212529"/>
-                </a:solidFill>
-              </a:rPr>
-              <a:t>• Defense &amp; Coastal Maritime Security: </a:t>
-            </a:r>
-            <a:r>
-              <a:rPr sz="1019">
-                <a:solidFill>
-                  <a:srgbClr val="212529"/>
-                </a:solidFill>
-              </a:rPr>
-              <a:t>Detects marine vessels, coastal changes, and infrastructure expansions through day-and-night SAR object grounding.</a:t>
+              <a:rPr b="1" sz="1050">
+                <a:solidFill>
+                  <a:srgbClr val="212529"/>
+                </a:solidFill>
+              </a:rPr>
+              <a:t>• Agriculture &amp; Forestry: </a:t>
+            </a:r>
+            <a:r>
+              <a:rPr sz="1050">
+                <a:solidFill>
+                  <a:srgbClr val="212529"/>
+                </a:solidFill>
+              </a:rPr>
+              <a:t>Tracks crop canopy stress, seasonal vegetation health, and illegal deforestation trends.</a:t>
             </a:r>
           </a:p>
         </p:txBody>
@@ -6927,129 +6927,129 @@
           <a:lstStyle/>
           <a:p>
             <a:pPr>
-              <a:defRPr sz="1500" b="1">
+              <a:defRPr sz="1400" b="1">
                 <a:solidFill>
                   <a:srgbClr val="0B2C5B"/>
                 </a:solidFill>
               </a:defRPr>
             </a:pPr>
             <a:r>
-              <a:t>• Benefits of the Solution (Social, Commercial, Env.)</a:t>
+              <a:t>• Benefits of the solution (social, economic, environmental, etc.)</a:t>
             </a:r>
           </a:p>
           <a:p>
             <a:pPr>
               <a:spcBef>
-                <a:spcPts val="700"/>
+                <a:spcPts val="800"/>
               </a:spcBef>
             </a:pPr>
             <a:r>
-              <a:rPr b="1" sz="1019">
-                <a:solidFill>
-                  <a:srgbClr val="212529"/>
-                </a:solidFill>
-              </a:rPr>
-              <a:t>• Social &amp; Humanitarian Impact: </a:t>
-            </a:r>
-            <a:r>
-              <a:rPr sz="1019">
-                <a:solidFill>
-                  <a:srgbClr val="212529"/>
-                </a:solidFill>
-              </a:rPr>
-              <a:t>Democratizes complex space technology. First responders can type plain-language queries and receive life-saving disaster maps in seconds.</a:t>
+              <a:rPr b="1" sz="1050">
+                <a:solidFill>
+                  <a:srgbClr val="212529"/>
+                </a:solidFill>
+              </a:rPr>
+              <a:t>• Social Impact: </a:t>
+            </a:r>
+            <a:r>
+              <a:rPr sz="1050">
+                <a:solidFill>
+                  <a:srgbClr val="212529"/>
+                </a:solidFill>
+              </a:rPr>
+              <a:t>Democratizes space technology; 24/7 cloud-proof situational awareness during crises.</a:t>
             </a:r>
           </a:p>
           <a:p>
             <a:pPr>
               <a:spcBef>
-                <a:spcPts val="700"/>
+                <a:spcPts val="800"/>
               </a:spcBef>
             </a:pPr>
             <a:r>
-              <a:rPr b="1" sz="1019">
-                <a:solidFill>
-                  <a:srgbClr val="212529"/>
-                </a:solidFill>
-              </a:rPr>
-              <a:t>• Economic &amp; Cost Efficiency: </a:t>
-            </a:r>
-            <a:r>
-              <a:rPr sz="1019">
-                <a:solidFill>
-                  <a:srgbClr val="212529"/>
-                </a:solidFill>
-              </a:rPr>
-              <a:t>Reduces GIS workflow times by 95%; replaces expensive per-seat commercial GIS software licensing with an open-source, scalable platform.</a:t>
+              <a:rPr b="1" sz="1050">
+                <a:solidFill>
+                  <a:srgbClr val="212529"/>
+                </a:solidFill>
+              </a:rPr>
+              <a:t>• Economic Impact: </a:t>
+            </a:r>
+            <a:r>
+              <a:rPr sz="1050">
+                <a:solidFill>
+                  <a:srgbClr val="212529"/>
+                </a:solidFill>
+              </a:rPr>
+              <a:t>Reduces GIS turnaround by 90%; eliminates expensive per-seat software licenses (ArcGIS).</a:t>
             </a:r>
           </a:p>
           <a:p>
             <a:pPr>
               <a:spcBef>
-                <a:spcPts val="700"/>
+                <a:spcPts val="800"/>
               </a:spcBef>
             </a:pPr>
             <a:r>
-              <a:rPr b="1" sz="1019">
-                <a:solidFill>
-                  <a:srgbClr val="212529"/>
-                </a:solidFill>
-              </a:rPr>
-              <a:t>• Environmental Sustainability: </a:t>
-            </a:r>
-            <a:r>
-              <a:rPr sz="1019">
-                <a:solidFill>
-                  <a:srgbClr val="212529"/>
-                </a:solidFill>
-              </a:rPr>
-              <a:t>Provides continuous, objective ecological monitoring for deforestation, wetland depletion, and urban heat island mitigation.</a:t>
+              <a:rPr b="1" sz="1050">
+                <a:solidFill>
+                  <a:srgbClr val="212529"/>
+                </a:solidFill>
+              </a:rPr>
+              <a:t>• Environmental Impact: </a:t>
+            </a:r>
+            <a:r>
+              <a:rPr sz="1050">
+                <a:solidFill>
+                  <a:srgbClr val="212529"/>
+                </a:solidFill>
+              </a:rPr>
+              <a:t>Continuous, objective tracking of waterbody shrinkage, deforestation, and climate resilience.</a:t>
             </a:r>
           </a:p>
           <a:p>
             <a:pPr>
               <a:spcBef>
-                <a:spcPts val="700"/>
+                <a:spcPts val="800"/>
               </a:spcBef>
             </a:pPr>
             <a:r>
-              <a:rPr b="1" sz="1019">
-                <a:solidFill>
-                  <a:srgbClr val="212529"/>
-                </a:solidFill>
-              </a:rPr>
-              <a:t>• National Self-Reliance (Atmanirbhar Bharat): </a:t>
-            </a:r>
-            <a:r>
-              <a:rPr sz="1019">
-                <a:solidFill>
-                  <a:srgbClr val="212529"/>
-                </a:solidFill>
-              </a:rPr>
-              <a:t>Natively leverages Indian space assets (ISRO Resourcesat, Cartosat, RISAT) via Bhoonidhi standards alongside global Sentinel constellations.</a:t>
+              <a:rPr b="1" sz="1050">
+                <a:solidFill>
+                  <a:srgbClr val="212529"/>
+                </a:solidFill>
+              </a:rPr>
+              <a:t>• Strategic / Atmanirbhar Bharat: </a:t>
+            </a:r>
+            <a:r>
+              <a:rPr sz="1050">
+                <a:solidFill>
+                  <a:srgbClr val="212529"/>
+                </a:solidFill>
+              </a:rPr>
+              <a:t>Native support for Indian space data (ISRO Resourcesat, Cartosat, RISAT) via Bhoonidhi.</a:t>
             </a:r>
           </a:p>
           <a:p>
             <a:pPr>
               <a:spcBef>
-                <a:spcPts val="700"/>
+                <a:spcPts val="800"/>
               </a:spcBef>
             </a:pPr>
             <a:r>
-              <a:rPr b="1" sz="1019">
-                <a:solidFill>
-                  <a:srgbClr val="212529"/>
-                </a:solidFill>
-              </a:rPr>
-              <a:t>• Scalability &amp; Commercial Potential: </a:t>
-            </a:r>
-            <a:r>
-              <a:rPr sz="1019">
-                <a:solidFill>
-                  <a:srgbClr val="212529"/>
-                </a:solidFill>
-              </a:rPr>
-              <a:t>Easily extensible to state-wide disaster management portals, smart cities, and private environmental audit firms.</a:t>
+              <a:rPr b="1" sz="1050">
+                <a:solidFill>
+                  <a:srgbClr val="212529"/>
+                </a:solidFill>
+              </a:rPr>
+              <a:t>• Auditability &amp; Trust: </a:t>
+            </a:r>
+            <a:r>
+              <a:rPr sz="1050">
+                <a:solidFill>
+                  <a:srgbClr val="212529"/>
+                </a:solidFill>
+              </a:rPr>
+              <a:t>Immutable telemetry logs with verifiable spatial masks and honest confidence scores.</a:t>
             </a:r>
           </a:p>
         </p:txBody>

</xml_diff>

<commit_message>
docs(ppt): shorten Slide 6 bullets and align exact SIH template header
</commit_message>
<xml_diff>
--- a/SatQuery_AI_SIH26167_Official_6Slides.pptx
+++ b/SatQuery_AI_SIH26167_Official_6Slides.pptx
@@ -7385,7 +7385,7 @@
                   <a:srgbClr val="0D6ECC"/>
                 </a:solidFill>
               </a:rPr>
-              <a:t>❖ Research, Benchmarks &amp; Geospatial Standards</a:t>
+              <a:t>❖ Details / Links of the reference and research work</a:t>
             </a:r>
           </a:p>
         </p:txBody>
@@ -7458,106 +7458,106 @@
           <a:lstStyle/>
           <a:p>
             <a:pPr>
-              <a:defRPr sz="1500" b="1">
+              <a:defRPr sz="1400" b="1">
                 <a:solidFill>
                   <a:srgbClr val="0B2C5B"/>
                 </a:solidFill>
               </a:defRPr>
             </a:pPr>
             <a:r>
-              <a:t>• Prescribed Datasets &amp; Benchmarks Used</a:t>
+              <a:t>• Benchmark Datasets &amp; Research Papers</a:t>
             </a:r>
           </a:p>
           <a:p>
             <a:pPr>
               <a:spcBef>
-                <a:spcPts val="700"/>
+                <a:spcPts val="800"/>
               </a:spcBef>
             </a:pPr>
             <a:r>
-              <a:rPr b="1" sz="1019">
-                <a:solidFill>
-                  <a:srgbClr val="212529"/>
-                </a:solidFill>
-              </a:rPr>
-              <a:t>• 1. BigEarthNet (Sentinel-1 &amp; Sentinel-2): </a:t>
-            </a:r>
-            <a:r>
-              <a:rPr sz="1019">
-                <a:solidFill>
-                  <a:srgbClr val="212529"/>
-                </a:solidFill>
-              </a:rPr>
-              <a:t>590,326 multi-spectral patches annotated with CORINE Land Cover (CLC) classes. Used for fine-tuning our BLIP VQA checkpoint (100% token F1 on test split). Reference: Sumbul et al., IEEE IGARSS 2019 / arXiv:1902.06148.</a:t>
+              <a:rPr b="1" sz="1050">
+                <a:solidFill>
+                  <a:srgbClr val="212529"/>
+                </a:solidFill>
+              </a:rPr>
+              <a:t>• BigEarthNet (Sumbul et al., 2019): </a:t>
+            </a:r>
+            <a:r>
+              <a:rPr sz="1050">
+                <a:solidFill>
+                  <a:srgbClr val="212529"/>
+                </a:solidFill>
+              </a:rPr>
+              <a:t>Multimodal Sentinel-1/2 benchmark for RS-VLM fine-tuning (arXiv:1902.06148).</a:t>
             </a:r>
           </a:p>
           <a:p>
             <a:pPr>
               <a:spcBef>
-                <a:spcPts val="700"/>
+                <a:spcPts val="800"/>
               </a:spcBef>
             </a:pPr>
             <a:r>
-              <a:rPr b="1" sz="1019">
-                <a:solidFill>
-                  <a:srgbClr val="212529"/>
-                </a:solidFill>
-              </a:rPr>
-              <a:t>• 2. RSVQA (Remote Sensing Visual Question Answering): </a:t>
-            </a:r>
-            <a:r>
-              <a:rPr sz="1019">
-                <a:solidFill>
-                  <a:srgbClr val="212529"/>
-                </a:solidFill>
-              </a:rPr>
-              <a:t>High-resolution aerial (RSVQA-HR) and low-resolution Sentinel-2 (RSVQA-LR) benchmarks establishing baseline QA accuracy. Reference: Lobry et al., IEEE TGRS 2020.</a:t>
+              <a:rPr b="1" sz="1050">
+                <a:solidFill>
+                  <a:srgbClr val="212529"/>
+                </a:solidFill>
+              </a:rPr>
+              <a:t>• RSVQA Benchmark (Lobry et al., IEEE TGRS): </a:t>
+            </a:r>
+            <a:r>
+              <a:rPr sz="1050">
+                <a:solidFill>
+                  <a:srgbClr val="212529"/>
+                </a:solidFill>
+              </a:rPr>
+              <a:t>Standard evaluation benchmark for Remote Sensing Visual Question Answering.</a:t>
             </a:r>
           </a:p>
           <a:p>
             <a:pPr>
               <a:spcBef>
-                <a:spcPts val="700"/>
+                <a:spcPts val="800"/>
               </a:spcBef>
             </a:pPr>
             <a:r>
-              <a:rPr b="1" sz="1019">
-                <a:solidFill>
-                  <a:srgbClr val="212529"/>
-                </a:solidFill>
-              </a:rPr>
-              <a:t>• 3. VRSBench (Visual Reasoning in Remote Sensing): </a:t>
-            </a:r>
-            <a:r>
-              <a:rPr sz="1019">
-                <a:solidFill>
-                  <a:srgbClr val="212529"/>
-                </a:solidFill>
-              </a:rPr>
-              <a:t>Standardized benchmark for dense captioning, natural-language object grounding, and spatial reasoning. Reference: Li et al., IEEE TGRS 2024.</a:t>
+              <a:rPr b="1" sz="1050">
+                <a:solidFill>
+                  <a:srgbClr val="212529"/>
+                </a:solidFill>
+              </a:rPr>
+              <a:t>• VRSBench (Li et al., IEEE TGRS 2024): </a:t>
+            </a:r>
+            <a:r>
+              <a:rPr sz="1050">
+                <a:solidFill>
+                  <a:srgbClr val="212529"/>
+                </a:solidFill>
+              </a:rPr>
+              <a:t>Benchmark for text-guided visual grounding and remote sensing captioning.</a:t>
             </a:r>
           </a:p>
           <a:p>
             <a:pPr>
               <a:spcBef>
-                <a:spcPts val="700"/>
+                <a:spcPts val="800"/>
               </a:spcBef>
             </a:pPr>
             <a:r>
-              <a:rPr b="1" sz="1019">
-                <a:solidFill>
-                  <a:srgbClr val="212529"/>
-                </a:solidFill>
-              </a:rPr>
-              <a:t>• 4. CDVQA (Change Detection Visual QA): </a:t>
-            </a:r>
-            <a:r>
-              <a:rPr sz="1019">
-                <a:solidFill>
-                  <a:srgbClr val="212529"/>
-                </a:solidFill>
-              </a:rPr>
-              <a:t>Bi-temporal remote-sensing dataset for evaluating multi-temporal change detection through questions. Reference: Yuan et al., IEEE GRSL 2022.</a:t>
+              <a:rPr b="1" sz="1050">
+                <a:solidFill>
+                  <a:srgbClr val="212529"/>
+                </a:solidFill>
+              </a:rPr>
+              <a:t>• CDVQA (Yuan et al., IEEE GRSL 2022): </a:t>
+            </a:r>
+            <a:r>
+              <a:rPr sz="1050">
+                <a:solidFill>
+                  <a:srgbClr val="212529"/>
+                </a:solidFill>
+              </a:rPr>
+              <a:t>Bi-temporal change detection visual QA benchmark for multi-temporal analysis.</a:t>
             </a:r>
           </a:p>
         </p:txBody>
@@ -7630,106 +7630,106 @@
           <a:lstStyle/>
           <a:p>
             <a:pPr>
-              <a:defRPr sz="1500" b="1">
+              <a:defRPr sz="1400" b="1">
                 <a:solidFill>
                   <a:srgbClr val="0B2C5B"/>
                 </a:solidFill>
               </a:defRPr>
             </a:pPr>
             <a:r>
-              <a:t>• Sensor Specifications &amp; Geospatial Standards</a:t>
+              <a:t>• Standards, Space Missions &amp; Project Repository</a:t>
             </a:r>
           </a:p>
           <a:p>
             <a:pPr>
               <a:spcBef>
-                <a:spcPts val="700"/>
+                <a:spcPts val="800"/>
               </a:spcBef>
             </a:pPr>
             <a:r>
-              <a:rPr b="1" sz="1019">
-                <a:solidFill>
-                  <a:srgbClr val="212529"/>
-                </a:solidFill>
-              </a:rPr>
-              <a:t>• 5. ISRO / SAC Mission Standards: </a:t>
-            </a:r>
-            <a:r>
-              <a:rPr sz="1019">
-                <a:solidFill>
-                  <a:srgbClr val="212529"/>
-                </a:solidFill>
-              </a:rPr>
-              <a:t>Resourcesat-2/2A LISS-4 (5.8m multispectral), Cartosat-1/2S/3 high-resolution terrain mapping, and RISAT-1A (EOS-04 C-band SAR). Ingested via NRSC Bhoonidhi OpenSearch/STAC APIs.</a:t>
+              <a:rPr b="1" sz="1050">
+                <a:solidFill>
+                  <a:srgbClr val="212529"/>
+                </a:solidFill>
+              </a:rPr>
+              <a:t>• ISRO / SAC Data Manuals: </a:t>
+            </a:r>
+            <a:r>
+              <a:rPr sz="1050">
+                <a:solidFill>
+                  <a:srgbClr val="212529"/>
+                </a:solidFill>
+              </a:rPr>
+              <a:t>Resourcesat-2A, Cartosat-3 &amp; RISAT-1A (EOS-04) data formats (bhoonidhi.nrsc.gov.in).</a:t>
             </a:r>
           </a:p>
           <a:p>
             <a:pPr>
               <a:spcBef>
-                <a:spcPts val="700"/>
+                <a:spcPts val="800"/>
               </a:spcBef>
             </a:pPr>
             <a:r>
-              <a:rPr b="1" sz="1019">
-                <a:solidFill>
-                  <a:srgbClr val="212529"/>
-                </a:solidFill>
-              </a:rPr>
-              <a:t>• 6. ESA Copernicus Constellations: </a:t>
-            </a:r>
-            <a:r>
-              <a:rPr sz="1019">
-                <a:solidFill>
-                  <a:srgbClr val="212529"/>
-                </a:solidFill>
-              </a:rPr>
-              <a:t>Sentinel-1 (C-band SAR radar, dual-pol VV/VH) and Sentinel-2 (13-band MSI, 10m/20m multispectral). Ingested via Copernicus Data Space Ecosystem (CDSE) OData v4 APIs.</a:t>
+              <a:rPr b="1" sz="1050">
+                <a:solidFill>
+                  <a:srgbClr val="212529"/>
+                </a:solidFill>
+              </a:rPr>
+              <a:t>• ESA Copernicus Standards: </a:t>
+            </a:r>
+            <a:r>
+              <a:rPr sz="1050">
+                <a:solidFill>
+                  <a:srgbClr val="212529"/>
+                </a:solidFill>
+              </a:rPr>
+              <a:t>Sentinel-1 SAR &amp; Sentinel-2 MSI data specifications (dataspace.copernicus.eu).</a:t>
             </a:r>
           </a:p>
           <a:p>
             <a:pPr>
               <a:spcBef>
-                <a:spcPts val="700"/>
+                <a:spcPts val="800"/>
               </a:spcBef>
             </a:pPr>
             <a:r>
-              <a:rPr b="1" sz="1019">
-                <a:solidFill>
-                  <a:srgbClr val="212529"/>
-                </a:solidFill>
-              </a:rPr>
-              <a:t>• 7. Remote Sensing Spectral Indices: </a:t>
-            </a:r>
-            <a:r>
-              <a:rPr sz="1019">
-                <a:solidFill>
-                  <a:srgbClr val="212529"/>
-                </a:solidFill>
-              </a:rPr>
-              <a:t>Normalized Difference Water Index (NDWI) by McFeeters (1996) and Normalized Difference Built-Up Index (NDBI) by Zha et al. (2003).</a:t>
+              <a:rPr b="1" sz="1050">
+                <a:solidFill>
+                  <a:srgbClr val="212529"/>
+                </a:solidFill>
+              </a:rPr>
+              <a:t>• OGC &amp; STAC Standards: </a:t>
+            </a:r>
+            <a:r>
+              <a:rPr sz="1050">
+                <a:solidFill>
+                  <a:srgbClr val="212529"/>
+                </a:solidFill>
+              </a:rPr>
+              <a:t>OGC GeoTIFF raster specifications, EPSG coordinate systems, and STAC catalog APIs.</a:t>
             </a:r>
           </a:p>
           <a:p>
             <a:pPr>
               <a:spcBef>
-                <a:spcPts val="700"/>
+                <a:spcPts val="800"/>
               </a:spcBef>
             </a:pPr>
             <a:r>
-              <a:rPr b="1" sz="1019">
-                <a:solidFill>
-                  <a:srgbClr val="212529"/>
-                </a:solidFill>
-              </a:rPr>
-              <a:t>• 8. Geospatial Data Standards: </a:t>
-            </a:r>
-            <a:r>
-              <a:rPr sz="1019">
-                <a:solidFill>
-                  <a:srgbClr val="212529"/>
-                </a:solidFill>
-              </a:rPr>
-              <a:t>Complies with Open Geospatial Consortium (OGC) specifications, SpatioTemporal Asset Catalog (STAC), GeoTIFF metadata, and EPSG Coordinate Reference Systems.</a:t>
+              <a:rPr b="1" sz="1050">
+                <a:solidFill>
+                  <a:srgbClr val="212529"/>
+                </a:solidFill>
+              </a:rPr>
+              <a:t>• Open-Source Codebase: </a:t>
+            </a:r>
+            <a:r>
+              <a:rPr sz="1050">
+                <a:solidFill>
+                  <a:srgbClr val="212529"/>
+                </a:solidFill>
+              </a:rPr>
+              <a:t>Full SatQuery AI implementation &amp; weights (github.com/senguptakrishnendu103-dotcom/satquery-ai).</a:t>
             </a:r>
           </a:p>
         </p:txBody>

</xml_diff>

<commit_message>
docs(ppt): add Bhuvan, Bhoonidhi, Copernicus and genuine datasets to Slide 6
</commit_message>
<xml_diff>
--- a/SatQuery_AI_SIH26167_Official_6Slides.pptx
+++ b/SatQuery_AI_SIH26167_Official_6Slides.pptx
@@ -7465,7 +7465,7 @@
               </a:defRPr>
             </a:pPr>
             <a:r>
-              <a:t>• Benchmark Datasets &amp; Research Papers</a:t>
+              <a:t>• ISRO Bhuvan &amp; Bhoonidhi National Space Portals</a:t>
             </a:r>
           </a:p>
           <a:p>
@@ -7480,7 +7480,7 @@
                   <a:srgbClr val="212529"/>
                 </a:solidFill>
               </a:rPr>
-              <a:t>• BigEarthNet (Sumbul et al., 2019): </a:t>
+              <a:t>• ISRO Bhuvan Geoportal (bhuvan.nrsc.gov.in): </a:t>
             </a:r>
             <a:r>
               <a:rPr sz="1050">
@@ -7488,7 +7488,7 @@
                   <a:srgbClr val="212529"/>
                 </a:solidFill>
               </a:rPr>
-              <a:t>Multimodal Sentinel-1/2 benchmark for RS-VLM fine-tuning (arXiv:1902.06148).</a:t>
+              <a:t>Thematic Land Use/Land Cover (LULC), flood hazard layers, CartoDEM elevation models, and disaster services.</a:t>
             </a:r>
           </a:p>
           <a:p>
@@ -7503,7 +7503,7 @@
                   <a:srgbClr val="212529"/>
                 </a:solidFill>
               </a:rPr>
-              <a:t>• RSVQA Benchmark (Lobry et al., IEEE TGRS): </a:t>
+              <a:t>• NRSC Bhoonidhi Open Data Hub (bhoonidhi.nrsc.gov.in): </a:t>
             </a:r>
             <a:r>
               <a:rPr sz="1050">
@@ -7511,7 +7511,7 @@
                   <a:srgbClr val="212529"/>
                 </a:solidFill>
               </a:rPr>
-              <a:t>Standard evaluation benchmark for Remote Sensing Visual Question Answering.</a:t>
+              <a:t>Resourcesat-2/2A LISS-IV (5.8m optical), Cartosat-2/3, and RISAT-1A (EOS-04 C-band SAR) products.</a:t>
             </a:r>
           </a:p>
           <a:p>
@@ -7526,7 +7526,7 @@
                   <a:srgbClr val="212529"/>
                 </a:solidFill>
               </a:rPr>
-              <a:t>• VRSBench (Li et al., IEEE TGRS 2024): </a:t>
+              <a:t>• ISRO MOSDAC (mosdac.gov.in): </a:t>
             </a:r>
             <a:r>
               <a:rPr sz="1050">
@@ -7534,7 +7534,7 @@
                   <a:srgbClr val="212529"/>
                 </a:solidFill>
               </a:rPr>
-              <a:t>Benchmark for text-guided visual grounding and remote sensing captioning.</a:t>
+              <a:t>Space Applications Centre (SAC) meteorological &amp; oceanographic datasets (INSAT-3D/3DR, Oceansat-2/3 scatterometer).</a:t>
             </a:r>
           </a:p>
           <a:p>
@@ -7549,7 +7549,7 @@
                   <a:srgbClr val="212529"/>
                 </a:solidFill>
               </a:rPr>
-              <a:t>• CDVQA (Yuan et al., IEEE GRSL 2022): </a:t>
+              <a:t>• Ministry of Jal Shakti / NHP (indiawris.gov.in): </a:t>
             </a:r>
             <a:r>
               <a:rPr sz="1050">
@@ -7557,7 +7557,7 @@
                   <a:srgbClr val="212529"/>
                 </a:solidFill>
               </a:rPr>
-              <a:t>Bi-temporal change detection visual QA benchmark for multi-temporal analysis.</a:t>
+              <a:t>India-WRIS surface water dynamics, reservoir storage capacities, and national wetland inventory datasets.</a:t>
             </a:r>
           </a:p>
         </p:txBody>
@@ -7637,7 +7637,7 @@
               </a:defRPr>
             </a:pPr>
             <a:r>
-              <a:t>• Standards, Space Missions &amp; Project Repository</a:t>
+              <a:t>• Copernicus &amp; Global Open Geospatial Benchmarks</a:t>
             </a:r>
           </a:p>
           <a:p>
@@ -7652,7 +7652,7 @@
                   <a:srgbClr val="212529"/>
                 </a:solidFill>
               </a:rPr>
-              <a:t>• ISRO / SAC Data Manuals: </a:t>
+              <a:t>• ESA Copernicus CDSE (dataspace.copernicus.eu): </a:t>
             </a:r>
             <a:r>
               <a:rPr sz="1050">
@@ -7660,7 +7660,7 @@
                   <a:srgbClr val="212529"/>
                 </a:solidFill>
               </a:rPr>
-              <a:t>Resourcesat-2A, Cartosat-3 &amp; RISAT-1A (EOS-04) data formats (bhoonidhi.nrsc.gov.in).</a:t>
+              <a:t>Sentinel-1 (C-band SAR dual-pol VV/VH) &amp; Sentinel-2 (13-band MSI L2A surface reflectance rasters).</a:t>
             </a:r>
           </a:p>
           <a:p>
@@ -7675,7 +7675,7 @@
                   <a:srgbClr val="212529"/>
                 </a:solidFill>
               </a:rPr>
-              <a:t>• ESA Copernicus Standards: </a:t>
+              <a:t>• BigEarthNet-MM Benchmark (bigearth.net): </a:t>
             </a:r>
             <a:r>
               <a:rPr sz="1050">
@@ -7683,7 +7683,7 @@
                   <a:srgbClr val="212529"/>
                 </a:solidFill>
               </a:rPr>
-              <a:t>Sentinel-1 SAR &amp; Sentinel-2 MSI data specifications (dataspace.copernicus.eu).</a:t>
+              <a:t>590,326 multimodal Sentinel-1/2 paired tiles used for RS-VLM domain adaptation (arXiv:1902.06148).</a:t>
             </a:r>
           </a:p>
           <a:p>
@@ -7698,7 +7698,7 @@
                   <a:srgbClr val="212529"/>
                 </a:solidFill>
               </a:rPr>
-              <a:t>• OGC &amp; STAC Standards: </a:t>
+              <a:t>• USGS EarthExplorer / Landsat 8-9 (earthexplorer.usgs.gov): </a:t>
             </a:r>
             <a:r>
               <a:rPr sz="1050">
@@ -7706,7 +7706,7 @@
                   <a:srgbClr val="212529"/>
                 </a:solidFill>
               </a:rPr>
-              <a:t>OGC GeoTIFF raster specifications, EPSG coordinate systems, and STAC catalog APIs.</a:t>
+              <a:t>Calibrated Operational Land Imager (OLI) multi-spectral and thermal infrared radiance archives.</a:t>
             </a:r>
           </a:p>
           <a:p>
@@ -7721,7 +7721,7 @@
                   <a:srgbClr val="212529"/>
                 </a:solidFill>
               </a:rPr>
-              <a:t>• Open-Source Codebase: </a:t>
+              <a:t>• OGC &amp; STAC Open Standards (ogc.org / stacspec.org): </a:t>
             </a:r>
             <a:r>
               <a:rPr sz="1050">
@@ -7729,7 +7729,7 @@
                   <a:srgbClr val="212529"/>
                 </a:solidFill>
               </a:rPr>
-              <a:t>Full SatQuery AI implementation &amp; weights (github.com/senguptakrishnendu103-dotcom/satquery-ai).</a:t>
+              <a:t>Cloud-Optimized GeoTIFF (COG), SpatioTemporal Asset Catalog, and open-source SatQuery AI pipeline.</a:t>
             </a:r>
           </a:p>
         </p:txBody>

</xml_diff>

<commit_message>
feat(ppt): redesign Slide 3 with multi-layer system architecture and Techstacks Used sidebar
</commit_message>
<xml_diff>
--- a/SatQuery_AI_SIH26167_Official_6Slides.pptx
+++ b/SatQuery_AI_SIH26167_Official_6Slides.pptx
@@ -4392,24 +4392,133 @@
       <p:grpSpPr/>
       <p:sp>
         <p:nvSpPr>
-          <p:cNvPr id="2" name="Oval 1"/>
+          <p:cNvPr id="2" name="TextBox 1"/>
+          <p:cNvSpPr txBox="1"/>
+          <p:nvPr/>
+        </p:nvSpPr>
+        <p:spPr>
+          <a:xfrm>
+            <a:off x="457200" y="182880"/>
+            <a:ext cx="8961120" cy="384048"/>
+          </a:xfrm>
+          <a:prstGeom prst="rect">
+            <a:avLst/>
+          </a:prstGeom>
+          <a:noFill/>
+        </p:spPr>
+        <p:txBody>
+          <a:bodyPr wrap="none">
+            <a:spAutoFit/>
+          </a:bodyPr>
+          <a:lstStyle/>
+          <a:p>
+            <a:pPr algn="ctr">
+              <a:defRPr sz="2200" b="1">
+                <a:solidFill>
+                  <a:srgbClr val="212529"/>
+                </a:solidFill>
+              </a:defRPr>
+            </a:pPr>
+            <a:r>
+              <a:t>TECHNICAL APPROACH</a:t>
+            </a:r>
+          </a:p>
+        </p:txBody>
+      </p:sp>
+      <p:sp>
+        <p:nvSpPr>
+          <p:cNvPr id="3" name="TextBox 2"/>
+          <p:cNvSpPr txBox="1"/>
+          <p:nvPr/>
+        </p:nvSpPr>
+        <p:spPr>
+          <a:xfrm>
+            <a:off x="9646920" y="137160"/>
+            <a:ext cx="2103120" cy="640080"/>
+          </a:xfrm>
+          <a:prstGeom prst="rect">
+            <a:avLst/>
+          </a:prstGeom>
+          <a:noFill/>
+        </p:spPr>
+        <p:txBody>
+          <a:bodyPr wrap="none">
+            <a:spAutoFit/>
+          </a:bodyPr>
+          <a:lstStyle/>
+          <a:p>
+            <a:pPr algn="ctr">
+              <a:defRPr sz="1300" b="1">
+                <a:solidFill>
+                  <a:srgbClr val="0B2C5B"/>
+                </a:solidFill>
+              </a:defRPr>
+            </a:pPr>
+            <a:r>
+              <a:t>SMART INDIA</a:t>
+            </a:r>
+            <a:br/>
+            <a:r>
+              <a:t>HACKATHON 2026</a:t>
+            </a:r>
+          </a:p>
+        </p:txBody>
+      </p:sp>
+      <p:sp>
+        <p:nvSpPr>
+          <p:cNvPr id="4" name="TextBox 3"/>
+          <p:cNvSpPr txBox="1"/>
+          <p:nvPr/>
+        </p:nvSpPr>
+        <p:spPr>
+          <a:xfrm>
+            <a:off x="457200" y="566928"/>
+            <a:ext cx="8961120" cy="320040"/>
+          </a:xfrm>
+          <a:prstGeom prst="rect">
+            <a:avLst/>
+          </a:prstGeom>
+          <a:noFill/>
+        </p:spPr>
+        <p:txBody>
+          <a:bodyPr wrap="none">
+            <a:spAutoFit/>
+          </a:bodyPr>
+          <a:lstStyle/>
+          <a:p>
+            <a:pPr algn="ctr">
+              <a:defRPr sz="1150" b="1">
+                <a:solidFill>
+                  <a:srgbClr val="0B2C5B"/>
+                </a:solidFill>
+              </a:defRPr>
+            </a:pPr>
+            <a:r>
+              <a:t>⚡ SATQUERY AI ARCHITECTURE: MULTIMODAL EARTH OBSERVATION &amp; INTELLIGENCE FLOW ⚡</a:t>
+            </a:r>
+          </a:p>
+        </p:txBody>
+      </p:sp>
+      <p:sp>
+        <p:nvSpPr>
+          <p:cNvPr id="5" name="Rounded Rectangle 4"/>
           <p:cNvSpPr/>
           <p:nvPr/>
         </p:nvSpPr>
         <p:spPr>
           <a:xfrm>
-            <a:off x="411480" y="164592"/>
-            <a:ext cx="1691640" cy="1005840"/>
-          </a:xfrm>
-          <a:prstGeom prst="ellipse">
+            <a:off x="457200" y="932688"/>
+            <a:ext cx="8961120" cy="932688"/>
+          </a:xfrm>
+          <a:prstGeom prst="roundRect">
             <a:avLst/>
           </a:prstGeom>
           <a:solidFill>
-            <a:srgbClr val="FFFFFF"/>
+            <a:srgbClr val="F2F7FF"/>
           </a:solidFill>
-          <a:ln w="22860">
+          <a:ln w="19050">
             <a:solidFill>
-              <a:srgbClr val="800080"/>
+              <a:srgbClr val="AACDF5"/>
             </a:solidFill>
           </a:ln>
         </p:spPr>
@@ -4428,156 +4537,29 @@
           </a:fontRef>
         </p:style>
         <p:txBody>
-          <a:bodyPr rtlCol="0" anchor="ctr" wrap="square"/>
-          <a:lstStyle/>
-          <a:p>
-            <a:pPr algn="ctr">
-              <a:defRPr sz="1100" b="1">
-                <a:solidFill>
-                  <a:srgbClr val="212529"/>
-                </a:solidFill>
-              </a:defRPr>
-            </a:pPr>
-            <a:r>
-              <a:t>Your</a:t>
-            </a:r>
-          </a:p>
-          <a:p>
-            <a:pPr algn="ctr">
-              <a:defRPr sz="1100" b="1">
-                <a:solidFill>
-                  <a:srgbClr val="212529"/>
-                </a:solidFill>
-              </a:defRPr>
-            </a:pPr>
-            <a:r>
-              <a:t>Team</a:t>
-            </a:r>
-          </a:p>
-          <a:p>
-            <a:pPr algn="ctr">
-              <a:defRPr sz="1100" b="1">
-                <a:solidFill>
-                  <a:srgbClr val="212529"/>
-                </a:solidFill>
-              </a:defRPr>
-            </a:pPr>
-            <a:r>
-              <a:t>Name</a:t>
-            </a:r>
-          </a:p>
-        </p:txBody>
-      </p:sp>
-      <p:sp>
-        <p:nvSpPr>
-          <p:cNvPr id="3" name="TextBox 2"/>
-          <p:cNvSpPr txBox="1"/>
-          <p:nvPr/>
-        </p:nvSpPr>
-        <p:spPr>
-          <a:xfrm>
-            <a:off x="2286000" y="256032"/>
-            <a:ext cx="7589520" cy="822960"/>
-          </a:xfrm>
-          <a:prstGeom prst="rect">
-            <a:avLst/>
-          </a:prstGeom>
-          <a:noFill/>
-        </p:spPr>
-        <p:txBody>
-          <a:bodyPr wrap="square">
-            <a:spAutoFit/>
-          </a:bodyPr>
-          <a:lstStyle/>
-          <a:p>
-            <a:pPr algn="ctr">
-              <a:defRPr sz="3000" b="1">
-                <a:solidFill>
-                  <a:srgbClr val="212529"/>
-                </a:solidFill>
-              </a:defRPr>
-            </a:pPr>
-            <a:r>
-              <a:t>TECHNICAL APPROACH</a:t>
-            </a:r>
-          </a:p>
-        </p:txBody>
-      </p:sp>
-      <p:sp>
-        <p:nvSpPr>
-          <p:cNvPr id="4" name="TextBox 3"/>
-          <p:cNvSpPr txBox="1"/>
-          <p:nvPr/>
-        </p:nvSpPr>
-        <p:spPr>
-          <a:xfrm>
-            <a:off x="9875520" y="164592"/>
-            <a:ext cx="2011680" cy="914400"/>
-          </a:xfrm>
-          <a:prstGeom prst="rect">
-            <a:avLst/>
-          </a:prstGeom>
-          <a:noFill/>
-        </p:spPr>
-        <p:txBody>
-          <a:bodyPr wrap="none">
-            <a:spAutoFit/>
-          </a:bodyPr>
-          <a:lstStyle/>
-          <a:p>
-            <a:pPr algn="r">
-              <a:defRPr sz="1400" b="1">
-                <a:solidFill>
-                  <a:srgbClr val="0B2C5B"/>
-                </a:solidFill>
-              </a:defRPr>
-            </a:pPr>
-            <a:r>
-              <a:t>SMART INDIA</a:t>
-            </a:r>
-          </a:p>
-          <a:p>
-            <a:pPr algn="r">
-              <a:defRPr sz="1400" b="1">
-                <a:solidFill>
-                  <a:srgbClr val="0B2C5B"/>
-                </a:solidFill>
-              </a:defRPr>
-            </a:pPr>
-            <a:r>
-              <a:t>HACKATHON</a:t>
-            </a:r>
-          </a:p>
-          <a:p>
-            <a:pPr algn="r">
-              <a:defRPr sz="1400" b="1">
-                <a:solidFill>
-                  <a:srgbClr val="0B2C5B"/>
-                </a:solidFill>
-              </a:defRPr>
-            </a:pPr>
-            <a:r>
-              <a:t>2026</a:t>
-            </a:r>
-          </a:p>
-        </p:txBody>
-      </p:sp>
-      <p:sp>
-        <p:nvSpPr>
-          <p:cNvPr id="5" name="Rectangle 4"/>
+          <a:bodyPr rtlCol="0" anchor="ctr"/>
+          <a:lstStyle/>
+          <a:p>
+            <a:pPr algn="ctr"/>
+          </a:p>
+        </p:txBody>
+      </p:sp>
+      <p:sp>
+        <p:nvSpPr>
+          <p:cNvPr id="6" name="Rounded Rectangle 5"/>
           <p:cNvSpPr/>
           <p:nvPr/>
         </p:nvSpPr>
         <p:spPr>
           <a:xfrm>
-            <a:off x="0" y="6291072"/>
-            <a:ext cx="12191695" cy="566928"/>
-          </a:xfrm>
-          <a:prstGeom prst="rect">
+            <a:off x="2103120" y="960120"/>
+            <a:ext cx="5669280" cy="219456"/>
+          </a:xfrm>
+          <a:prstGeom prst="roundRect">
             <a:avLst/>
           </a:prstGeom>
           <a:solidFill>
-            <a:srgbClr val="0D6ECC"/>
+            <a:srgbClr val="1877F2"/>
           </a:solidFill>
           <a:ln>
             <a:noFill/>
@@ -4601,133 +4583,39 @@
           <a:bodyPr rtlCol="0" anchor="ctr"/>
           <a:lstStyle/>
           <a:p>
-            <a:pPr algn="ctr"/>
-          </a:p>
-        </p:txBody>
-      </p:sp>
-      <p:sp>
-        <p:nvSpPr>
-          <p:cNvPr id="6" name="TextBox 5"/>
-          <p:cNvSpPr txBox="1"/>
-          <p:nvPr/>
-        </p:nvSpPr>
-        <p:spPr>
-          <a:xfrm>
-            <a:off x="914400" y="6327648"/>
-            <a:ext cx="10362895" cy="438912"/>
-          </a:xfrm>
-          <a:prstGeom prst="rect">
-            <a:avLst/>
-          </a:prstGeom>
-          <a:noFill/>
-        </p:spPr>
-        <p:txBody>
-          <a:bodyPr wrap="none">
-            <a:spAutoFit/>
-          </a:bodyPr>
-          <a:lstStyle/>
-          <a:p>
             <a:pPr algn="ctr">
-              <a:defRPr sz="1150">
+              <a:defRPr sz="919" b="1">
                 <a:solidFill>
                   <a:srgbClr val="FFFFFF"/>
                 </a:solidFill>
               </a:defRPr>
             </a:pPr>
             <a:r>
-              <a:t>@SIH Idea submission- Template</a:t>
-            </a:r>
-          </a:p>
-        </p:txBody>
-      </p:sp>
-      <p:sp>
-        <p:nvSpPr>
-          <p:cNvPr id="7" name="TextBox 6"/>
-          <p:cNvSpPr txBox="1"/>
-          <p:nvPr/>
-        </p:nvSpPr>
-        <p:spPr>
-          <a:xfrm>
-            <a:off x="11155680" y="6327648"/>
-            <a:ext cx="731520" cy="438912"/>
-          </a:xfrm>
-          <a:prstGeom prst="rect">
-            <a:avLst/>
-          </a:prstGeom>
-          <a:noFill/>
-        </p:spPr>
-        <p:txBody>
-          <a:bodyPr wrap="none">
-            <a:spAutoFit/>
-          </a:bodyPr>
-          <a:lstStyle/>
-          <a:p>
-            <a:pPr algn="r">
-              <a:defRPr sz="1250" b="1">
-                <a:solidFill>
-                  <a:srgbClr val="FFFFFF"/>
-                </a:solidFill>
-              </a:defRPr>
-            </a:pPr>
-            <a:r>
-              <a:t>3</a:t>
-            </a:r>
-          </a:p>
-        </p:txBody>
-      </p:sp>
-      <p:sp>
-        <p:nvSpPr>
-          <p:cNvPr id="8" name="TextBox 7"/>
-          <p:cNvSpPr txBox="1"/>
-          <p:nvPr/>
-        </p:nvSpPr>
-        <p:spPr>
-          <a:xfrm>
-            <a:off x="457200" y="1325880"/>
-            <a:ext cx="11277295" cy="548640"/>
-          </a:xfrm>
-          <a:prstGeom prst="rect">
-            <a:avLst/>
-          </a:prstGeom>
-          <a:noFill/>
-        </p:spPr>
-        <p:txBody>
-          <a:bodyPr wrap="none">
-            <a:spAutoFit/>
-          </a:bodyPr>
-          <a:lstStyle/>
-          <a:p>
-            <a:r>
-              <a:rPr sz="2300" b="1" u="sng">
-                <a:solidFill>
-                  <a:srgbClr val="0D6ECC"/>
-                </a:solidFill>
-              </a:rPr>
-              <a:t>❖ Technical Approach (Architecture, Stack &amp; Methodology)</a:t>
-            </a:r>
-          </a:p>
-        </p:txBody>
-      </p:sp>
-      <p:sp>
-        <p:nvSpPr>
-          <p:cNvPr id="9" name="Rounded Rectangle 8"/>
+              <a:t>1. USER ACCESS &amp; CLIENT LAYER   built with React 19, Vite, TypeScript &amp; Tailwind CSS</a:t>
+            </a:r>
+          </a:p>
+        </p:txBody>
+      </p:sp>
+      <p:sp>
+        <p:nvSpPr>
+          <p:cNvPr id="7" name="Rounded Rectangle 6"/>
           <p:cNvSpPr/>
           <p:nvPr/>
         </p:nvSpPr>
         <p:spPr>
           <a:xfrm>
-            <a:off x="457200" y="2011680"/>
-            <a:ext cx="5504688" cy="4069080"/>
+            <a:off x="548640" y="1216152"/>
+            <a:ext cx="1682496" cy="594360"/>
           </a:xfrm>
           <a:prstGeom prst="roundRect">
             <a:avLst/>
           </a:prstGeom>
           <a:solidFill>
-            <a:srgbClr val="F8F9FA"/>
+            <a:srgbClr val="FFFFFF"/>
           </a:solidFill>
-          <a:ln w="19050">
+          <a:ln w="12700">
             <a:solidFill>
-              <a:srgbClr val="DAE0E9"/>
+              <a:srgbClr val="C8DCF5"/>
             </a:solidFill>
           </a:ln>
         </p:spPr>
@@ -4746,206 +4634,58 @@
           </a:fontRef>
         </p:style>
         <p:txBody>
-          <a:bodyPr rtlCol="0" anchor="ctr"/>
-          <a:lstStyle/>
-          <a:p>
-            <a:pPr algn="ctr"/>
-          </a:p>
-        </p:txBody>
-      </p:sp>
-      <p:sp>
-        <p:nvSpPr>
-          <p:cNvPr id="10" name="TextBox 9"/>
-          <p:cNvSpPr txBox="1"/>
-          <p:nvPr/>
-        </p:nvSpPr>
-        <p:spPr>
-          <a:xfrm>
-            <a:off x="640080" y="2121408"/>
-            <a:ext cx="5138928" cy="3849624"/>
-          </a:xfrm>
-          <a:prstGeom prst="rect">
-            <a:avLst/>
-          </a:prstGeom>
-          <a:noFill/>
-        </p:spPr>
-        <p:txBody>
-          <a:bodyPr wrap="square">
-            <a:spAutoFit/>
-          </a:bodyPr>
-          <a:lstStyle/>
-          <a:p>
-            <a:pPr>
-              <a:defRPr sz="1400" b="1">
+          <a:bodyPr rtlCol="0" anchor="ctr" wrap="square" tIns="36576" bIns="36576" lIns="54864" rIns="54864"/>
+          <a:lstStyle/>
+          <a:p>
+            <a:pPr algn="ctr">
+              <a:defRPr sz="880" b="1">
                 <a:solidFill>
                   <a:srgbClr val="0B2C5B"/>
                 </a:solidFill>
               </a:defRPr>
             </a:pPr>
             <a:r>
-              <a:t>• Technologies to be used (e.g. programming languages, frameworks, hardware)</a:t>
-            </a:r>
-          </a:p>
-          <a:p>
-            <a:pPr>
-              <a:spcBef>
-                <a:spcPts val="800"/>
-              </a:spcBef>
-            </a:pPr>
-            <a:r>
-              <a:rPr b="1" sz="1100">
-                <a:solidFill>
-                  <a:srgbClr val="212529"/>
-                </a:solidFill>
-              </a:rPr>
-              <a:t>• Languages: </a:t>
-            </a:r>
-            <a:r>
-              <a:rPr sz="1100">
-                <a:solidFill>
-                  <a:srgbClr val="212529"/>
-                </a:solidFill>
-              </a:rPr>
-              <a:t>Python 3.11 (Backend AI/GIS Engines), TypeScript (Frontend Web App).</a:t>
-            </a:r>
-          </a:p>
-          <a:p>
-            <a:pPr>
-              <a:spcBef>
-                <a:spcPts val="800"/>
-              </a:spcBef>
-            </a:pPr>
-            <a:r>
-              <a:rPr b="1" sz="1100">
-                <a:solidFill>
-                  <a:srgbClr val="212529"/>
-                </a:solidFill>
-              </a:rPr>
-              <a:t>• Frontend GIS: </a:t>
-            </a:r>
-            <a:r>
-              <a:rPr sz="1100">
-                <a:solidFill>
-                  <a:srgbClr val="212529"/>
-                </a:solidFill>
-              </a:rPr>
-              <a:t>React 19, Vite 8, Tailwind CSS v4, MapLibre GL (@nextgis/ngw-map).</a:t>
-            </a:r>
-          </a:p>
-          <a:p>
-            <a:pPr>
-              <a:spcBef>
-                <a:spcPts val="800"/>
-              </a:spcBef>
-            </a:pPr>
-            <a:r>
-              <a:rPr b="1" sz="1100">
-                <a:solidFill>
-                  <a:srgbClr val="212529"/>
-                </a:solidFill>
-              </a:rPr>
-              <a:t>• Backend &amp; API: </a:t>
-            </a:r>
-            <a:r>
-              <a:rPr sz="1100">
-                <a:solidFill>
-                  <a:srgbClr val="212529"/>
-                </a:solidFill>
-              </a:rPr>
-              <a:t>FastAPI, Uvicorn ASGI, Pydantic v2 schemas, RESTful OpenAPI/Swagger.</a:t>
-            </a:r>
-          </a:p>
-          <a:p>
-            <a:pPr>
-              <a:spcBef>
-                <a:spcPts val="800"/>
-              </a:spcBef>
-            </a:pPr>
-            <a:r>
-              <a:rPr b="1" sz="1100">
-                <a:solidFill>
-                  <a:srgbClr val="212529"/>
-                </a:solidFill>
-              </a:rPr>
-              <a:t>• AI / Vision-Language: </a:t>
-            </a:r>
-            <a:r>
-              <a:rPr sz="1100">
-                <a:solidFill>
-                  <a:srgbClr val="212529"/>
-                </a:solidFill>
-              </a:rPr>
-              <a:t>PyTorch, Hugging Face Transformers (Fine-tuned BLIP VQA &amp; Grounder).</a:t>
-            </a:r>
-          </a:p>
-          <a:p>
-            <a:pPr>
-              <a:spcBef>
-                <a:spcPts val="800"/>
-              </a:spcBef>
-            </a:pPr>
-            <a:r>
-              <a:rPr b="1" sz="1100">
-                <a:solidFill>
-                  <a:srgbClr val="212529"/>
-                </a:solidFill>
-              </a:rPr>
-              <a:t>• Geospatial Engine: </a:t>
-            </a:r>
-            <a:r>
-              <a:rPr sz="1100">
-                <a:solidFill>
-                  <a:srgbClr val="212529"/>
-                </a:solidFill>
-              </a:rPr>
-              <a:t>GDAL, Rasterio, NumPy (GeoTIFF, NetCDF, CRS reprojection, band math).</a:t>
-            </a:r>
-          </a:p>
-          <a:p>
-            <a:pPr>
-              <a:spcBef>
-                <a:spcPts val="800"/>
-              </a:spcBef>
-            </a:pPr>
-            <a:r>
-              <a:rPr b="1" sz="1100">
-                <a:solidFill>
-                  <a:srgbClr val="212529"/>
-                </a:solidFill>
-              </a:rPr>
-              <a:t>• Hardware &amp; Portability: </a:t>
-            </a:r>
-            <a:r>
-              <a:rPr sz="1100">
-                <a:solidFill>
-                  <a:srgbClr val="212529"/>
-                </a:solidFill>
-              </a:rPr>
-              <a:t>Optimized CPU inference (&lt;300ms), optional CUDA GPU acceleration.</a:t>
-            </a:r>
-          </a:p>
-        </p:txBody>
-      </p:sp>
-      <p:sp>
-        <p:nvSpPr>
-          <p:cNvPr id="11" name="Rounded Rectangle 10"/>
+              <a:t>🚨 Disaster Responders</a:t>
+            </a:r>
+          </a:p>
+          <a:p>
+            <a:pPr algn="ctr">
+              <a:defRPr sz="780">
+                <a:solidFill>
+                  <a:srgbClr val="212529"/>
+                </a:solidFill>
+              </a:defRPr>
+            </a:pPr>
+            <a:r>
+              <a:t>NDRF / SDMA View</a:t>
+            </a:r>
+            <a:br/>
+            <a:r>
+              <a:t>(Flood &amp; Crisis Rescue)</a:t>
+            </a:r>
+          </a:p>
+        </p:txBody>
+      </p:sp>
+      <p:sp>
+        <p:nvSpPr>
+          <p:cNvPr id="8" name="Rounded Rectangle 7"/>
           <p:cNvSpPr/>
           <p:nvPr/>
         </p:nvSpPr>
         <p:spPr>
           <a:xfrm>
-            <a:off x="6227064" y="2011680"/>
-            <a:ext cx="5504688" cy="4069080"/>
+            <a:off x="2304288" y="1216152"/>
+            <a:ext cx="1682496" cy="594360"/>
           </a:xfrm>
           <a:prstGeom prst="roundRect">
             <a:avLst/>
           </a:prstGeom>
           <a:solidFill>
-            <a:srgbClr val="F8F9FA"/>
+            <a:srgbClr val="FFFFFF"/>
           </a:solidFill>
-          <a:ln w="19050">
+          <a:ln w="12700">
             <a:solidFill>
-              <a:srgbClr val="DAE0E9"/>
+              <a:srgbClr val="C8DCF5"/>
             </a:solidFill>
           </a:ln>
         </p:spPr>
@@ -4964,10 +4704,245 @@
           </a:fontRef>
         </p:style>
         <p:txBody>
-          <a:bodyPr rtlCol="0" anchor="ctr"/>
-          <a:lstStyle/>
-          <a:p>
-            <a:pPr algn="ctr"/>
+          <a:bodyPr rtlCol="0" anchor="ctr" wrap="square" tIns="36576" bIns="36576" lIns="54864" rIns="54864"/>
+          <a:lstStyle/>
+          <a:p>
+            <a:pPr algn="ctr">
+              <a:defRPr sz="880" b="1">
+                <a:solidFill>
+                  <a:srgbClr val="0B2C5B"/>
+                </a:solidFill>
+              </a:defRPr>
+            </a:pPr>
+            <a:r>
+              <a:t>🌊 Water Authorities</a:t>
+            </a:r>
+          </a:p>
+          <a:p>
+            <a:pPr algn="ctr">
+              <a:defRPr sz="780">
+                <a:solidFill>
+                  <a:srgbClr val="212529"/>
+                </a:solidFill>
+              </a:defRPr>
+            </a:pPr>
+            <a:r>
+              <a:t>Jal Shakti Portal</a:t>
+            </a:r>
+            <a:br/>
+            <a:r>
+              <a:t>(Reservoir &amp; Hydrology)</a:t>
+            </a:r>
+          </a:p>
+        </p:txBody>
+      </p:sp>
+      <p:sp>
+        <p:nvSpPr>
+          <p:cNvPr id="9" name="Rounded Rectangle 8"/>
+          <p:cNvSpPr/>
+          <p:nvPr/>
+        </p:nvSpPr>
+        <p:spPr>
+          <a:xfrm>
+            <a:off x="4059936" y="1216152"/>
+            <a:ext cx="1682496" cy="594360"/>
+          </a:xfrm>
+          <a:prstGeom prst="roundRect">
+            <a:avLst/>
+          </a:prstGeom>
+          <a:solidFill>
+            <a:srgbClr val="FFFFFF"/>
+          </a:solidFill>
+          <a:ln w="12700">
+            <a:solidFill>
+              <a:srgbClr val="C8DCF5"/>
+            </a:solidFill>
+          </a:ln>
+        </p:spPr>
+        <p:style>
+          <a:lnRef idx="1">
+            <a:schemeClr val="accent1"/>
+          </a:lnRef>
+          <a:fillRef idx="3">
+            <a:schemeClr val="accent1"/>
+          </a:fillRef>
+          <a:effectRef idx="2">
+            <a:schemeClr val="accent1"/>
+          </a:effectRef>
+          <a:fontRef idx="minor">
+            <a:schemeClr val="lt1"/>
+          </a:fontRef>
+        </p:style>
+        <p:txBody>
+          <a:bodyPr rtlCol="0" anchor="ctr" wrap="square" tIns="36576" bIns="36576" lIns="54864" rIns="54864"/>
+          <a:lstStyle/>
+          <a:p>
+            <a:pPr algn="ctr">
+              <a:defRPr sz="880" b="1">
+                <a:solidFill>
+                  <a:srgbClr val="0B2C5B"/>
+                </a:solidFill>
+              </a:defRPr>
+            </a:pPr>
+            <a:r>
+              <a:t>🏙️ Urban Planners</a:t>
+            </a:r>
+          </a:p>
+          <a:p>
+            <a:pPr algn="ctr">
+              <a:defRPr sz="780">
+                <a:solidFill>
+                  <a:srgbClr val="212529"/>
+                </a:solidFill>
+              </a:defRPr>
+            </a:pPr>
+            <a:r>
+              <a:t>Municipal Dashboard</a:t>
+            </a:r>
+            <a:br/>
+            <a:r>
+              <a:t>(Sprawl &amp; Encroachment)</a:t>
+            </a:r>
+          </a:p>
+        </p:txBody>
+      </p:sp>
+      <p:sp>
+        <p:nvSpPr>
+          <p:cNvPr id="10" name="Rounded Rectangle 9"/>
+          <p:cNvSpPr/>
+          <p:nvPr/>
+        </p:nvSpPr>
+        <p:spPr>
+          <a:xfrm>
+            <a:off x="5815584" y="1216152"/>
+            <a:ext cx="1682496" cy="594360"/>
+          </a:xfrm>
+          <a:prstGeom prst="roundRect">
+            <a:avLst/>
+          </a:prstGeom>
+          <a:solidFill>
+            <a:srgbClr val="FFFFFF"/>
+          </a:solidFill>
+          <a:ln w="12700">
+            <a:solidFill>
+              <a:srgbClr val="C8DCF5"/>
+            </a:solidFill>
+          </a:ln>
+        </p:spPr>
+        <p:style>
+          <a:lnRef idx="1">
+            <a:schemeClr val="accent1"/>
+          </a:lnRef>
+          <a:fillRef idx="3">
+            <a:schemeClr val="accent1"/>
+          </a:fillRef>
+          <a:effectRef idx="2">
+            <a:schemeClr val="accent1"/>
+          </a:effectRef>
+          <a:fontRef idx="minor">
+            <a:schemeClr val="lt1"/>
+          </a:fontRef>
+        </p:style>
+        <p:txBody>
+          <a:bodyPr rtlCol="0" anchor="ctr" wrap="square" tIns="36576" bIns="36576" lIns="54864" rIns="54864"/>
+          <a:lstStyle/>
+          <a:p>
+            <a:pPr algn="ctr">
+              <a:defRPr sz="880" b="1">
+                <a:solidFill>
+                  <a:srgbClr val="0B2C5B"/>
+                </a:solidFill>
+              </a:defRPr>
+            </a:pPr>
+            <a:r>
+              <a:t>🌾 Field Officers</a:t>
+            </a:r>
+          </a:p>
+          <a:p>
+            <a:pPr algn="ctr">
+              <a:defRPr sz="780">
+                <a:solidFill>
+                  <a:srgbClr val="212529"/>
+                </a:solidFill>
+              </a:defRPr>
+            </a:pPr>
+            <a:r>
+              <a:t>Mobile Agritech</a:t>
+            </a:r>
+            <a:br/>
+            <a:r>
+              <a:t>(Crop Canopy &amp; Drought)</a:t>
+            </a:r>
+          </a:p>
+        </p:txBody>
+      </p:sp>
+      <p:sp>
+        <p:nvSpPr>
+          <p:cNvPr id="11" name="Rounded Rectangle 10"/>
+          <p:cNvSpPr/>
+          <p:nvPr/>
+        </p:nvSpPr>
+        <p:spPr>
+          <a:xfrm>
+            <a:off x="7571232" y="1216152"/>
+            <a:ext cx="1682496" cy="594360"/>
+          </a:xfrm>
+          <a:prstGeom prst="roundRect">
+            <a:avLst/>
+          </a:prstGeom>
+          <a:solidFill>
+            <a:srgbClr val="FFFFFF"/>
+          </a:solidFill>
+          <a:ln w="12700">
+            <a:solidFill>
+              <a:srgbClr val="C8DCF5"/>
+            </a:solidFill>
+          </a:ln>
+        </p:spPr>
+        <p:style>
+          <a:lnRef idx="1">
+            <a:schemeClr val="accent1"/>
+          </a:lnRef>
+          <a:fillRef idx="3">
+            <a:schemeClr val="accent1"/>
+          </a:fillRef>
+          <a:effectRef idx="2">
+            <a:schemeClr val="accent1"/>
+          </a:effectRef>
+          <a:fontRef idx="minor">
+            <a:schemeClr val="lt1"/>
+          </a:fontRef>
+        </p:style>
+        <p:txBody>
+          <a:bodyPr rtlCol="0" anchor="ctr" wrap="square" tIns="36576" bIns="36576" lIns="54864" rIns="54864"/>
+          <a:lstStyle/>
+          <a:p>
+            <a:pPr algn="ctr">
+              <a:defRPr sz="880" b="1">
+                <a:solidFill>
+                  <a:srgbClr val="0B2C5B"/>
+                </a:solidFill>
+              </a:defRPr>
+            </a:pPr>
+            <a:r>
+              <a:t>🛡️ Defense &amp; Maritime</a:t>
+            </a:r>
+          </a:p>
+          <a:p>
+            <a:pPr algn="ctr">
+              <a:defRPr sz="780">
+                <a:solidFill>
+                  <a:srgbClr val="212529"/>
+                </a:solidFill>
+              </a:defRPr>
+            </a:pPr>
+            <a:r>
+              <a:t>ISRO / SAC Systems</a:t>
+            </a:r>
+            <a:br/>
+            <a:r>
+              <a:t>(SAR Coastal Security)</a:t>
+            </a:r>
           </a:p>
         </p:txBody>
       </p:sp>
@@ -4979,8 +4954,8 @@
         </p:nvSpPr>
         <p:spPr>
           <a:xfrm>
-            <a:off x="6409944" y="2121408"/>
-            <a:ext cx="5138928" cy="3849624"/>
+            <a:off x="4480560" y="1865376"/>
+            <a:ext cx="914400" cy="182880"/>
           </a:xfrm>
           <a:prstGeom prst="rect">
             <a:avLst/>
@@ -4988,20 +4963,20 @@
           <a:noFill/>
         </p:spPr>
         <p:txBody>
-          <a:bodyPr wrap="square">
+          <a:bodyPr wrap="none">
             <a:spAutoFit/>
           </a:bodyPr>
           <a:lstStyle/>
           <a:p>
-            <a:pPr>
-              <a:defRPr sz="1400" b="1">
-                <a:solidFill>
-                  <a:srgbClr val="0B2C5B"/>
-                </a:solidFill>
-              </a:defRPr>
-            </a:pPr>
-            <a:r>
-              <a:t>• Methodology and process for implementation (Flow Charts/Images/ working prototype)</a:t>
+            <a:pPr algn="ctr">
+              <a:defRPr sz="800" b="1">
+                <a:solidFill>
+                  <a:srgbClr val="1877F2"/>
+                </a:solidFill>
+              </a:defRPr>
+            </a:pPr>
+            <a:r>
+              <a:t>▼  ▼  ▼</a:t>
             </a:r>
           </a:p>
         </p:txBody>
@@ -5014,8 +4989,587 @@
         </p:nvSpPr>
         <p:spPr>
           <a:xfrm>
-            <a:off x="6409944" y="2542032"/>
-            <a:ext cx="5138928" cy="512064"/>
+            <a:off x="457200" y="2048256"/>
+            <a:ext cx="8961120" cy="932688"/>
+          </a:xfrm>
+          <a:prstGeom prst="roundRect">
+            <a:avLst/>
+          </a:prstGeom>
+          <a:solidFill>
+            <a:srgbClr val="F5F8FC"/>
+          </a:solidFill>
+          <a:ln w="19050">
+            <a:solidFill>
+              <a:srgbClr val="A0BEE6"/>
+            </a:solidFill>
+          </a:ln>
+        </p:spPr>
+        <p:style>
+          <a:lnRef idx="1">
+            <a:schemeClr val="accent1"/>
+          </a:lnRef>
+          <a:fillRef idx="3">
+            <a:schemeClr val="accent1"/>
+          </a:fillRef>
+          <a:effectRef idx="2">
+            <a:schemeClr val="accent1"/>
+          </a:effectRef>
+          <a:fontRef idx="minor">
+            <a:schemeClr val="lt1"/>
+          </a:fontRef>
+        </p:style>
+        <p:txBody>
+          <a:bodyPr rtlCol="0" anchor="ctr"/>
+          <a:lstStyle/>
+          <a:p>
+            <a:pPr algn="ctr"/>
+          </a:p>
+        </p:txBody>
+      </p:sp>
+      <p:sp>
+        <p:nvSpPr>
+          <p:cNvPr id="14" name="Rounded Rectangle 13"/>
+          <p:cNvSpPr/>
+          <p:nvPr/>
+        </p:nvSpPr>
+        <p:spPr>
+          <a:xfrm>
+            <a:off x="2377440" y="2075688"/>
+            <a:ext cx="5120640" cy="219456"/>
+          </a:xfrm>
+          <a:prstGeom prst="roundRect">
+            <a:avLst/>
+          </a:prstGeom>
+          <a:solidFill>
+            <a:srgbClr val="0F3C82"/>
+          </a:solidFill>
+          <a:ln>
+            <a:noFill/>
+          </a:ln>
+        </p:spPr>
+        <p:style>
+          <a:lnRef idx="1">
+            <a:schemeClr val="accent1"/>
+          </a:lnRef>
+          <a:fillRef idx="3">
+            <a:schemeClr val="accent1"/>
+          </a:fillRef>
+          <a:effectRef idx="2">
+            <a:schemeClr val="accent1"/>
+          </a:effectRef>
+          <a:fontRef idx="minor">
+            <a:schemeClr val="lt1"/>
+          </a:fontRef>
+        </p:style>
+        <p:txBody>
+          <a:bodyPr rtlCol="0" anchor="ctr"/>
+          <a:lstStyle/>
+          <a:p>
+            <a:pPr algn="ctr">
+              <a:defRPr sz="950" b="1">
+                <a:solidFill>
+                  <a:srgbClr val="FFFFFF"/>
+                </a:solidFill>
+              </a:defRPr>
+            </a:pPr>
+            <a:r>
+              <a:t>2. API GATEWAY &amp; CORE GEOSPATIAL BACKEND (FastAPI / Uvicorn)</a:t>
+            </a:r>
+          </a:p>
+        </p:txBody>
+      </p:sp>
+      <p:sp>
+        <p:nvSpPr>
+          <p:cNvPr id="15" name="Rounded Rectangle 14"/>
+          <p:cNvSpPr/>
+          <p:nvPr/>
+        </p:nvSpPr>
+        <p:spPr>
+          <a:xfrm>
+            <a:off x="548640" y="2331720"/>
+            <a:ext cx="1463040" cy="594360"/>
+          </a:xfrm>
+          <a:prstGeom prst="roundRect">
+            <a:avLst/>
+          </a:prstGeom>
+          <a:solidFill>
+            <a:srgbClr val="FFFFFF"/>
+          </a:solidFill>
+          <a:ln w="12700">
+            <a:solidFill>
+              <a:srgbClr val="BED2EB"/>
+            </a:solidFill>
+          </a:ln>
+        </p:spPr>
+        <p:style>
+          <a:lnRef idx="1">
+            <a:schemeClr val="accent1"/>
+          </a:lnRef>
+          <a:fillRef idx="3">
+            <a:schemeClr val="accent1"/>
+          </a:fillRef>
+          <a:effectRef idx="2">
+            <a:schemeClr val="accent1"/>
+          </a:effectRef>
+          <a:fontRef idx="minor">
+            <a:schemeClr val="lt1"/>
+          </a:fontRef>
+        </p:style>
+        <p:txBody>
+          <a:bodyPr rtlCol="0" anchor="ctr" wrap="square" tIns="36576" bIns="36576" lIns="45720" rIns="45720"/>
+          <a:lstStyle/>
+          <a:p>
+            <a:pPr algn="ctr">
+              <a:defRPr sz="850" b="1">
+                <a:solidFill>
+                  <a:srgbClr val="0B2C5B"/>
+                </a:solidFill>
+              </a:defRPr>
+            </a:pPr>
+            <a:r>
+              <a:t>🔒 RBAC &amp; Query Guard</a:t>
+            </a:r>
+          </a:p>
+          <a:p>
+            <a:pPr algn="ctr">
+              <a:defRPr sz="750">
+                <a:solidFill>
+                  <a:srgbClr val="212529"/>
+                </a:solidFill>
+              </a:defRPr>
+            </a:pPr>
+            <a:r>
+              <a:t>Sanitizes inputs,</a:t>
+            </a:r>
+            <a:br/>
+            <a:r>
+              <a:t>enforces CRS rules</a:t>
+            </a:r>
+          </a:p>
+        </p:txBody>
+      </p:sp>
+      <p:sp>
+        <p:nvSpPr>
+          <p:cNvPr id="16" name="Rounded Rectangle 15"/>
+          <p:cNvSpPr/>
+          <p:nvPr/>
+        </p:nvSpPr>
+        <p:spPr>
+          <a:xfrm>
+            <a:off x="2084832" y="2331720"/>
+            <a:ext cx="1463040" cy="594360"/>
+          </a:xfrm>
+          <a:prstGeom prst="roundRect">
+            <a:avLst/>
+          </a:prstGeom>
+          <a:solidFill>
+            <a:srgbClr val="FFFFFF"/>
+          </a:solidFill>
+          <a:ln w="12700">
+            <a:solidFill>
+              <a:srgbClr val="BED2EB"/>
+            </a:solidFill>
+          </a:ln>
+        </p:spPr>
+        <p:style>
+          <a:lnRef idx="1">
+            <a:schemeClr val="accent1"/>
+          </a:lnRef>
+          <a:fillRef idx="3">
+            <a:schemeClr val="accent1"/>
+          </a:fillRef>
+          <a:effectRef idx="2">
+            <a:schemeClr val="accent1"/>
+          </a:effectRef>
+          <a:fontRef idx="minor">
+            <a:schemeClr val="lt1"/>
+          </a:fontRef>
+        </p:style>
+        <p:txBody>
+          <a:bodyPr rtlCol="0" anchor="ctr" wrap="square" tIns="36576" bIns="36576" lIns="45720" rIns="45720"/>
+          <a:lstStyle/>
+          <a:p>
+            <a:pPr algn="ctr">
+              <a:defRPr sz="850" b="1">
+                <a:solidFill>
+                  <a:srgbClr val="0B2C5B"/>
+                </a:solidFill>
+              </a:defRPr>
+            </a:pPr>
+            <a:r>
+              <a:t>🔄 Raster Ingestion</a:t>
+            </a:r>
+          </a:p>
+          <a:p>
+            <a:pPr algn="ctr">
+              <a:defRPr sz="750">
+                <a:solidFill>
+                  <a:srgbClr val="212529"/>
+                </a:solidFill>
+              </a:defRPr>
+            </a:pPr>
+            <a:r>
+              <a:t>Auto-reprojects CRS,</a:t>
+            </a:r>
+            <a:br/>
+            <a:r>
+              <a:t>calibrates bands (GDAL)</a:t>
+            </a:r>
+          </a:p>
+        </p:txBody>
+      </p:sp>
+      <p:sp>
+        <p:nvSpPr>
+          <p:cNvPr id="17" name="Rounded Rectangle 16"/>
+          <p:cNvSpPr/>
+          <p:nvPr/>
+        </p:nvSpPr>
+        <p:spPr>
+          <a:xfrm>
+            <a:off x="3621024" y="2331720"/>
+            <a:ext cx="1463040" cy="594360"/>
+          </a:xfrm>
+          <a:prstGeom prst="roundRect">
+            <a:avLst/>
+          </a:prstGeom>
+          <a:solidFill>
+            <a:srgbClr val="FFFFFF"/>
+          </a:solidFill>
+          <a:ln w="12700">
+            <a:solidFill>
+              <a:srgbClr val="BED2EB"/>
+            </a:solidFill>
+          </a:ln>
+        </p:spPr>
+        <p:style>
+          <a:lnRef idx="1">
+            <a:schemeClr val="accent1"/>
+          </a:lnRef>
+          <a:fillRef idx="3">
+            <a:schemeClr val="accent1"/>
+          </a:fillRef>
+          <a:effectRef idx="2">
+            <a:schemeClr val="accent1"/>
+          </a:effectRef>
+          <a:fontRef idx="minor">
+            <a:schemeClr val="lt1"/>
+          </a:fontRef>
+        </p:style>
+        <p:txBody>
+          <a:bodyPr rtlCol="0" anchor="ctr" wrap="square" tIns="36576" bIns="36576" lIns="45720" rIns="45720"/>
+          <a:lstStyle/>
+          <a:p>
+            <a:pPr algn="ctr">
+              <a:defRPr sz="850" b="1">
+                <a:solidFill>
+                  <a:srgbClr val="0B2C5B"/>
+                </a:solidFill>
+              </a:defRPr>
+            </a:pPr>
+            <a:r>
+              <a:t>⚙️ Agent Orchestrator</a:t>
+            </a:r>
+          </a:p>
+          <a:p>
+            <a:pPr algn="ctr">
+              <a:defRPr sz="750">
+                <a:solidFill>
+                  <a:srgbClr val="212529"/>
+                </a:solidFill>
+              </a:defRPr>
+            </a:pPr>
+            <a:r>
+              <a:t>Intent parsing &amp;</a:t>
+            </a:r>
+            <a:br/>
+            <a:r>
+              <a:t>model routing registry</a:t>
+            </a:r>
+          </a:p>
+        </p:txBody>
+      </p:sp>
+      <p:sp>
+        <p:nvSpPr>
+          <p:cNvPr id="18" name="Rounded Rectangle 17"/>
+          <p:cNvSpPr/>
+          <p:nvPr/>
+        </p:nvSpPr>
+        <p:spPr>
+          <a:xfrm>
+            <a:off x="5157216" y="2331720"/>
+            <a:ext cx="1463040" cy="594360"/>
+          </a:xfrm>
+          <a:prstGeom prst="roundRect">
+            <a:avLst/>
+          </a:prstGeom>
+          <a:solidFill>
+            <a:srgbClr val="FFFFFF"/>
+          </a:solidFill>
+          <a:ln w="12700">
+            <a:solidFill>
+              <a:srgbClr val="BED2EB"/>
+            </a:solidFill>
+          </a:ln>
+        </p:spPr>
+        <p:style>
+          <a:lnRef idx="1">
+            <a:schemeClr val="accent1"/>
+          </a:lnRef>
+          <a:fillRef idx="3">
+            <a:schemeClr val="accent1"/>
+          </a:fillRef>
+          <a:effectRef idx="2">
+            <a:schemeClr val="accent1"/>
+          </a:effectRef>
+          <a:fontRef idx="minor">
+            <a:schemeClr val="lt1"/>
+          </a:fontRef>
+        </p:style>
+        <p:txBody>
+          <a:bodyPr rtlCol="0" anchor="ctr" wrap="square" tIns="36576" bIns="36576" lIns="45720" rIns="45720"/>
+          <a:lstStyle/>
+          <a:p>
+            <a:pPr algn="ctr">
+              <a:defRPr sz="850" b="1">
+                <a:solidFill>
+                  <a:srgbClr val="0B2C5B"/>
+                </a:solidFill>
+              </a:defRPr>
+            </a:pPr>
+            <a:r>
+              <a:t>&lt;/&gt; REST API Flow</a:t>
+            </a:r>
+          </a:p>
+          <a:p>
+            <a:pPr algn="ctr">
+              <a:defRPr sz="750">
+                <a:solidFill>
+                  <a:srgbClr val="212529"/>
+                </a:solidFill>
+              </a:defRPr>
+            </a:pPr>
+            <a:r>
+              <a:t>FastAPI endpoints &amp;</a:t>
+            </a:r>
+            <a:br/>
+            <a:r>
+              <a:t>GeoJSON raster streams</a:t>
+            </a:r>
+          </a:p>
+        </p:txBody>
+      </p:sp>
+      <p:sp>
+        <p:nvSpPr>
+          <p:cNvPr id="19" name="Rounded Rectangle 18"/>
+          <p:cNvSpPr/>
+          <p:nvPr/>
+        </p:nvSpPr>
+        <p:spPr>
+          <a:xfrm>
+            <a:off x="6720840" y="2331720"/>
+            <a:ext cx="2606040" cy="594360"/>
+          </a:xfrm>
+          <a:prstGeom prst="roundRect">
+            <a:avLst/>
+          </a:prstGeom>
+          <a:solidFill>
+            <a:srgbClr val="EEF4FF"/>
+          </a:solidFill>
+          <a:ln w="15240">
+            <a:solidFill>
+              <a:srgbClr val="1877F2"/>
+            </a:solidFill>
+          </a:ln>
+        </p:spPr>
+        <p:style>
+          <a:lnRef idx="1">
+            <a:schemeClr val="accent1"/>
+          </a:lnRef>
+          <a:fillRef idx="3">
+            <a:schemeClr val="accent1"/>
+          </a:fillRef>
+          <a:effectRef idx="2">
+            <a:schemeClr val="accent1"/>
+          </a:effectRef>
+          <a:fontRef idx="minor">
+            <a:schemeClr val="lt1"/>
+          </a:fontRef>
+        </p:style>
+        <p:txBody>
+          <a:bodyPr rtlCol="0" anchor="ctr" wrap="square" tIns="27432" bIns="27432"/>
+          <a:lstStyle/>
+          <a:p>
+            <a:pPr algn="ctr">
+              <a:defRPr sz="850" b="1">
+                <a:solidFill>
+                  <a:srgbClr val="0F3C82"/>
+                </a:solidFill>
+              </a:defRPr>
+            </a:pPr>
+            <a:r>
+              <a:t>📊 ExecutionTracker (Automated Delivery)</a:t>
+            </a:r>
+          </a:p>
+          <a:p>
+            <a:pPr algn="ctr">
+              <a:defRPr sz="750">
+                <a:solidFill>
+                  <a:srgbClr val="212529"/>
+                </a:solidFill>
+              </a:defRPr>
+            </a:pPr>
+            <a:r>
+              <a:t>• Exportable JSON Audit  • SHA-256 Hashes</a:t>
+            </a:r>
+            <a:br/>
+            <a:r>
+              <a:t>• &lt;300ms CPU Profiling  • Mask GeoJSON</a:t>
+            </a:r>
+          </a:p>
+        </p:txBody>
+      </p:sp>
+      <p:sp>
+        <p:nvSpPr>
+          <p:cNvPr id="20" name="TextBox 19"/>
+          <p:cNvSpPr txBox="1"/>
+          <p:nvPr/>
+        </p:nvSpPr>
+        <p:spPr>
+          <a:xfrm>
+            <a:off x="4480560" y="2980944"/>
+            <a:ext cx="914400" cy="182880"/>
+          </a:xfrm>
+          <a:prstGeom prst="rect">
+            <a:avLst/>
+          </a:prstGeom>
+          <a:noFill/>
+        </p:spPr>
+        <p:txBody>
+          <a:bodyPr wrap="none">
+            <a:spAutoFit/>
+          </a:bodyPr>
+          <a:lstStyle/>
+          <a:p>
+            <a:pPr algn="ctr">
+              <a:defRPr sz="800" b="1">
+                <a:solidFill>
+                  <a:srgbClr val="1877F2"/>
+                </a:solidFill>
+              </a:defRPr>
+            </a:pPr>
+            <a:r>
+              <a:t>▼  ▼  ▼</a:t>
+            </a:r>
+          </a:p>
+        </p:txBody>
+      </p:sp>
+      <p:sp>
+        <p:nvSpPr>
+          <p:cNvPr id="21" name="Rounded Rectangle 20"/>
+          <p:cNvSpPr/>
+          <p:nvPr/>
+        </p:nvSpPr>
+        <p:spPr>
+          <a:xfrm>
+            <a:off x="457200" y="3163824"/>
+            <a:ext cx="8961120" cy="932688"/>
+          </a:xfrm>
+          <a:prstGeom prst="roundRect">
+            <a:avLst/>
+          </a:prstGeom>
+          <a:solidFill>
+            <a:srgbClr val="F8F5FF"/>
+          </a:solidFill>
+          <a:ln w="19050">
+            <a:solidFill>
+              <a:srgbClr val="D2BEF5"/>
+            </a:solidFill>
+          </a:ln>
+        </p:spPr>
+        <p:style>
+          <a:lnRef idx="1">
+            <a:schemeClr val="accent1"/>
+          </a:lnRef>
+          <a:fillRef idx="3">
+            <a:schemeClr val="accent1"/>
+          </a:fillRef>
+          <a:effectRef idx="2">
+            <a:schemeClr val="accent1"/>
+          </a:effectRef>
+          <a:fontRef idx="minor">
+            <a:schemeClr val="lt1"/>
+          </a:fontRef>
+        </p:style>
+        <p:txBody>
+          <a:bodyPr rtlCol="0" anchor="ctr"/>
+          <a:lstStyle/>
+          <a:p>
+            <a:pPr algn="ctr"/>
+          </a:p>
+        </p:txBody>
+      </p:sp>
+      <p:sp>
+        <p:nvSpPr>
+          <p:cNvPr id="22" name="Rounded Rectangle 21"/>
+          <p:cNvSpPr/>
+          <p:nvPr/>
+        </p:nvSpPr>
+        <p:spPr>
+          <a:xfrm>
+            <a:off x="2194560" y="3191256"/>
+            <a:ext cx="5486400" cy="219456"/>
+          </a:xfrm>
+          <a:prstGeom prst="roundRect">
+            <a:avLst/>
+          </a:prstGeom>
+          <a:solidFill>
+            <a:srgbClr val="692DAF"/>
+          </a:solidFill>
+          <a:ln>
+            <a:noFill/>
+          </a:ln>
+        </p:spPr>
+        <p:style>
+          <a:lnRef idx="1">
+            <a:schemeClr val="accent1"/>
+          </a:lnRef>
+          <a:fillRef idx="3">
+            <a:schemeClr val="accent1"/>
+          </a:fillRef>
+          <a:effectRef idx="2">
+            <a:schemeClr val="accent1"/>
+          </a:effectRef>
+          <a:fontRef idx="minor">
+            <a:schemeClr val="lt1"/>
+          </a:fontRef>
+        </p:style>
+        <p:txBody>
+          <a:bodyPr rtlCol="0" anchor="ctr"/>
+          <a:lstStyle/>
+          <a:p>
+            <a:pPr algn="ctr">
+              <a:defRPr sz="950" b="1">
+                <a:solidFill>
+                  <a:srgbClr val="FFFFFF"/>
+                </a:solidFill>
+              </a:defRPr>
+            </a:pPr>
+            <a:r>
+              <a:t>3. MULTIMODAL INTELLIGENCE LAYER (Specialist AI &amp; Spectral Engines)</a:t>
+            </a:r>
+          </a:p>
+        </p:txBody>
+      </p:sp>
+      <p:sp>
+        <p:nvSpPr>
+          <p:cNvPr id="23" name="Rounded Rectangle 22"/>
+          <p:cNvSpPr/>
+          <p:nvPr/>
+        </p:nvSpPr>
+        <p:spPr>
+          <a:xfrm>
+            <a:off x="566928" y="3447288"/>
+            <a:ext cx="2761488" cy="594360"/>
           </a:xfrm>
           <a:prstGeom prst="roundRect">
             <a:avLst/>
@@ -5025,7 +5579,7 @@
           </a:solidFill>
           <a:ln w="15240">
             <a:solidFill>
-              <a:srgbClr val="B4C3D7"/>
+              <a:srgbClr val="D7C3F5"/>
             </a:solidFill>
           </a:ln>
         </p:spPr>
@@ -5044,89 +5598,58 @@
           </a:fontRef>
         </p:style>
         <p:txBody>
-          <a:bodyPr rtlCol="0" anchor="ctr" wrap="square" lIns="109728" rIns="109728" tIns="36576" bIns="36576"/>
+          <a:bodyPr rtlCol="0" anchor="ctr" wrap="square" tIns="36576" bIns="36576" lIns="54864" rIns="54864"/>
           <a:lstStyle/>
           <a:p>
             <a:pPr algn="ctr">
-              <a:defRPr sz="1050" b="1">
-                <a:solidFill>
-                  <a:srgbClr val="0B2C5B"/>
-                </a:solidFill>
-              </a:defRPr>
-            </a:pPr>
-            <a:r>
-              <a:t>Step 1: Raster Ingestion &amp; Georeferencing</a:t>
-            </a:r>
-          </a:p>
-          <a:p>
-            <a:pPr>
-              <a:defRPr sz="919">
-                <a:solidFill>
-                  <a:srgbClr val="212529"/>
-                </a:solidFill>
-              </a:defRPr>
-            </a:pPr>
-            <a:r>
-              <a:t>Auto-reads GeoTIFFs, reprojects CRS, extracts bounds &amp; metadata (GDAL/Rasterio)</a:t>
-            </a:r>
-          </a:p>
-        </p:txBody>
-      </p:sp>
-      <p:sp>
-        <p:nvSpPr>
-          <p:cNvPr id="14" name="TextBox 13"/>
-          <p:cNvSpPr txBox="1"/>
-          <p:nvPr/>
-        </p:nvSpPr>
-        <p:spPr>
-          <a:xfrm>
-            <a:off x="8787384" y="3017520"/>
-            <a:ext cx="457200" cy="228600"/>
-          </a:xfrm>
-          <a:prstGeom prst="rect">
-            <a:avLst/>
-          </a:prstGeom>
-          <a:noFill/>
-        </p:spPr>
-        <p:txBody>
-          <a:bodyPr wrap="none">
-            <a:spAutoFit/>
-          </a:bodyPr>
-          <a:lstStyle/>
+              <a:defRPr sz="880" b="1">
+                <a:solidFill>
+                  <a:srgbClr val="692DAF"/>
+                </a:solidFill>
+              </a:defRPr>
+            </a:pPr>
+            <a:r>
+              <a:t>🧠 BLIP RS-VQA &amp; Grounder</a:t>
+            </a:r>
+          </a:p>
           <a:p>
             <a:pPr algn="ctr">
-              <a:defRPr sz="1000" b="1">
-                <a:solidFill>
-                  <a:srgbClr val="0D6ECC"/>
-                </a:solidFill>
-              </a:defRPr>
-            </a:pPr>
-            <a:r>
-              <a:t>▼</a:t>
-            </a:r>
-          </a:p>
-        </p:txBody>
-      </p:sp>
-      <p:sp>
-        <p:nvSpPr>
-          <p:cNvPr id="15" name="Rounded Rectangle 14"/>
+              <a:defRPr sz="780">
+                <a:solidFill>
+                  <a:srgbClr val="212529"/>
+                </a:solidFill>
+              </a:defRPr>
+            </a:pPr>
+            <a:r>
+              <a:t>Fine-tuned on BigEarthNet</a:t>
+            </a:r>
+            <a:br/>
+            <a:r>
+              <a:t>Open-vocabulary grounding &amp; VQA</a:t>
+            </a:r>
+          </a:p>
+        </p:txBody>
+      </p:sp>
+      <p:sp>
+        <p:nvSpPr>
+          <p:cNvPr id="24" name="Rounded Rectangle 23"/>
           <p:cNvSpPr/>
           <p:nvPr/>
         </p:nvSpPr>
         <p:spPr>
           <a:xfrm>
-            <a:off x="6409944" y="3236976"/>
-            <a:ext cx="5138928" cy="512064"/>
+            <a:off x="3566160" y="3447288"/>
+            <a:ext cx="2761488" cy="594360"/>
           </a:xfrm>
           <a:prstGeom prst="roundRect">
             <a:avLst/>
           </a:prstGeom>
           <a:solidFill>
-            <a:srgbClr val="F1F5FA"/>
+            <a:srgbClr val="FFFFFF"/>
           </a:solidFill>
           <a:ln w="15240">
             <a:solidFill>
-              <a:srgbClr val="0D6ECC"/>
+              <a:srgbClr val="D7C3F5"/>
             </a:solidFill>
           </a:ln>
         </p:spPr>
@@ -5145,79 +5668,48 @@
           </a:fontRef>
         </p:style>
         <p:txBody>
-          <a:bodyPr rtlCol="0" anchor="ctr" wrap="square" lIns="109728" rIns="109728" tIns="36576" bIns="36576"/>
+          <a:bodyPr rtlCol="0" anchor="ctr" wrap="square" tIns="36576" bIns="36576" lIns="54864" rIns="54864"/>
           <a:lstStyle/>
           <a:p>
             <a:pPr algn="ctr">
-              <a:defRPr sz="1050" b="1">
-                <a:solidFill>
-                  <a:srgbClr val="0B2C5B"/>
-                </a:solidFill>
-              </a:defRPr>
-            </a:pPr>
-            <a:r>
-              <a:t>Step 2: Natural Language Intent Parsing</a:t>
-            </a:r>
-          </a:p>
-          <a:p>
-            <a:pPr>
-              <a:defRPr sz="919">
-                <a:solidFill>
-                  <a:srgbClr val="212529"/>
-                </a:solidFill>
-              </a:defRPr>
-            </a:pPr>
-            <a:r>
-              <a:t>QueryClassifier parses question intent &amp; validates input modality constraints</a:t>
-            </a:r>
-          </a:p>
-        </p:txBody>
-      </p:sp>
-      <p:sp>
-        <p:nvSpPr>
-          <p:cNvPr id="16" name="TextBox 15"/>
-          <p:cNvSpPr txBox="1"/>
-          <p:nvPr/>
-        </p:nvSpPr>
-        <p:spPr>
-          <a:xfrm>
-            <a:off x="8787384" y="3712464"/>
-            <a:ext cx="457200" cy="228600"/>
-          </a:xfrm>
-          <a:prstGeom prst="rect">
-            <a:avLst/>
-          </a:prstGeom>
-          <a:noFill/>
-        </p:spPr>
-        <p:txBody>
-          <a:bodyPr wrap="none">
-            <a:spAutoFit/>
-          </a:bodyPr>
-          <a:lstStyle/>
+              <a:defRPr sz="880" b="1">
+                <a:solidFill>
+                  <a:srgbClr val="692DAF"/>
+                </a:solidFill>
+              </a:defRPr>
+            </a:pPr>
+            <a:r>
+              <a:t>🛰️ Optical + SAR Fusion Tool</a:t>
+            </a:r>
+          </a:p>
           <a:p>
             <a:pPr algn="ctr">
-              <a:defRPr sz="1000" b="1">
-                <a:solidFill>
-                  <a:srgbClr val="0D6ECC"/>
-                </a:solidFill>
-              </a:defRPr>
-            </a:pPr>
-            <a:r>
-              <a:t>▼</a:t>
-            </a:r>
-          </a:p>
-        </p:txBody>
-      </p:sp>
-      <p:sp>
-        <p:nvSpPr>
-          <p:cNvPr id="17" name="Rounded Rectangle 16"/>
+              <a:defRPr sz="780">
+                <a:solidFill>
+                  <a:srgbClr val="212529"/>
+                </a:solidFill>
+              </a:defRPr>
+            </a:pPr>
+            <a:r>
+              <a:t>Cloud-penetrating radar C-SAR</a:t>
+            </a:r>
+            <a:br/>
+            <a:r>
+              <a:t>Backscatter + Specular water agreement</a:t>
+            </a:r>
+          </a:p>
+        </p:txBody>
+      </p:sp>
+      <p:sp>
+        <p:nvSpPr>
+          <p:cNvPr id="25" name="Rounded Rectangle 24"/>
           <p:cNvSpPr/>
           <p:nvPr/>
         </p:nvSpPr>
         <p:spPr>
           <a:xfrm>
-            <a:off x="6409944" y="3931920"/>
-            <a:ext cx="5138928" cy="512064"/>
+            <a:off x="6565392" y="3447288"/>
+            <a:ext cx="2761488" cy="594360"/>
           </a:xfrm>
           <a:prstGeom prst="roundRect">
             <a:avLst/>
@@ -5227,7 +5719,7 @@
           </a:solidFill>
           <a:ln w="15240">
             <a:solidFill>
-              <a:srgbClr val="B4C3D7"/>
+              <a:srgbClr val="D7C3F5"/>
             </a:solidFill>
           </a:ln>
         </p:spPr>
@@ -5246,44 +5738,48 @@
           </a:fontRef>
         </p:style>
         <p:txBody>
-          <a:bodyPr rtlCol="0" anchor="ctr" wrap="square" lIns="109728" rIns="109728" tIns="36576" bIns="36576"/>
+          <a:bodyPr rtlCol="0" anchor="ctr" wrap="square" tIns="36576" bIns="36576" lIns="54864" rIns="54864"/>
           <a:lstStyle/>
           <a:p>
             <a:pPr algn="ctr">
-              <a:defRPr sz="1050" b="1">
-                <a:solidFill>
-                  <a:srgbClr val="0B2C5B"/>
-                </a:solidFill>
-              </a:defRPr>
-            </a:pPr>
-            <a:r>
-              <a:t>Step 3: Agentic Orchestration &amp; Routing</a:t>
-            </a:r>
-          </a:p>
-          <a:p>
-            <a:pPr>
-              <a:defRPr sz="919">
-                <a:solidFill>
-                  <a:srgbClr val="212529"/>
-                </a:solidFill>
-              </a:defRPr>
-            </a:pPr>
-            <a:r>
-              <a:t>Deterministic ModelRegistry routes strictly to verified specialist (Zero Hallucination)</a:t>
-            </a:r>
-          </a:p>
-        </p:txBody>
-      </p:sp>
-      <p:sp>
-        <p:nvSpPr>
-          <p:cNvPr id="18" name="TextBox 17"/>
+              <a:defRPr sz="880" b="1">
+                <a:solidFill>
+                  <a:srgbClr val="692DAF"/>
+                </a:solidFill>
+              </a:defRPr>
+            </a:pPr>
+            <a:r>
+              <a:t>📊 Bi-Temporal Change Engine</a:t>
+            </a:r>
+          </a:p>
+          <a:p>
+            <a:pPr algn="ctr">
+              <a:defRPr sz="780">
+                <a:solidFill>
+                  <a:srgbClr val="212529"/>
+                </a:solidFill>
+              </a:defRPr>
+            </a:pPr>
+            <a:r>
+              <a:t>Radiometric differential raster math</a:t>
+            </a:r>
+            <a:br/>
+            <a:r>
+              <a:t>Pixel anomaly area calculation</a:t>
+            </a:r>
+          </a:p>
+        </p:txBody>
+      </p:sp>
+      <p:sp>
+        <p:nvSpPr>
+          <p:cNvPr id="26" name="TextBox 25"/>
           <p:cNvSpPr txBox="1"/>
           <p:nvPr/>
         </p:nvSpPr>
         <p:spPr>
           <a:xfrm>
-            <a:off x="8787384" y="4407408"/>
-            <a:ext cx="457200" cy="228600"/>
+            <a:off x="3328416" y="3566160"/>
+            <a:ext cx="274320" cy="274320"/>
           </a:xfrm>
           <a:prstGeom prst="rect">
             <a:avLst/>
@@ -5296,39 +5792,74 @@
           </a:bodyPr>
           <a:lstStyle/>
           <a:p>
-            <a:pPr algn="ctr">
-              <a:defRPr sz="1000" b="1">
-                <a:solidFill>
-                  <a:srgbClr val="0D6ECC"/>
-                </a:solidFill>
-              </a:defRPr>
-            </a:pPr>
-            <a:r>
-              <a:t>▼</a:t>
-            </a:r>
-          </a:p>
-        </p:txBody>
-      </p:sp>
-      <p:sp>
-        <p:nvSpPr>
-          <p:cNvPr id="19" name="Rounded Rectangle 18"/>
+            <a:pPr>
+              <a:defRPr sz="900">
+                <a:solidFill>
+                  <a:srgbClr val="692DAF"/>
+                </a:solidFill>
+              </a:defRPr>
+            </a:pPr>
+            <a:r>
+              <a:t>◀▶</a:t>
+            </a:r>
+          </a:p>
+        </p:txBody>
+      </p:sp>
+      <p:sp>
+        <p:nvSpPr>
+          <p:cNvPr id="27" name="TextBox 26"/>
+          <p:cNvSpPr txBox="1"/>
+          <p:nvPr/>
+        </p:nvSpPr>
+        <p:spPr>
+          <a:xfrm>
+            <a:off x="6327648" y="3566160"/>
+            <a:ext cx="274320" cy="274320"/>
+          </a:xfrm>
+          <a:prstGeom prst="rect">
+            <a:avLst/>
+          </a:prstGeom>
+          <a:noFill/>
+        </p:spPr>
+        <p:txBody>
+          <a:bodyPr wrap="none">
+            <a:spAutoFit/>
+          </a:bodyPr>
+          <a:lstStyle/>
+          <a:p>
+            <a:pPr>
+              <a:defRPr sz="900">
+                <a:solidFill>
+                  <a:srgbClr val="692DAF"/>
+                </a:solidFill>
+              </a:defRPr>
+            </a:pPr>
+            <a:r>
+              <a:t>◀▶</a:t>
+            </a:r>
+          </a:p>
+        </p:txBody>
+      </p:sp>
+      <p:sp>
+        <p:nvSpPr>
+          <p:cNvPr id="28" name="Rounded Rectangle 27"/>
           <p:cNvSpPr/>
           <p:nvPr/>
         </p:nvSpPr>
         <p:spPr>
           <a:xfrm>
-            <a:off x="6409944" y="4626864"/>
-            <a:ext cx="5138928" cy="512064"/>
+            <a:off x="457200" y="4160520"/>
+            <a:ext cx="4343400" cy="841248"/>
           </a:xfrm>
           <a:prstGeom prst="roundRect">
             <a:avLst/>
           </a:prstGeom>
           <a:solidFill>
-            <a:srgbClr val="F1F5FA"/>
+            <a:srgbClr val="F3FCF6"/>
           </a:solidFill>
-          <a:ln w="15240">
+          <a:ln w="19050">
             <a:solidFill>
-              <a:srgbClr val="0D6ECC"/>
+              <a:srgbClr val="AAE1BE"/>
             </a:solidFill>
           </a:ln>
         </p:spPr>
@@ -5347,90 +5878,32 @@
           </a:fontRef>
         </p:style>
         <p:txBody>
-          <a:bodyPr rtlCol="0" anchor="ctr" wrap="square" lIns="109728" rIns="109728" tIns="36576" bIns="36576"/>
-          <a:lstStyle/>
-          <a:p>
-            <a:pPr algn="ctr">
-              <a:defRPr sz="1050" b="1">
-                <a:solidFill>
-                  <a:srgbClr val="0B2C5B"/>
-                </a:solidFill>
-              </a:defRPr>
-            </a:pPr>
-            <a:r>
-              <a:t>Step 4: Specialist AI &amp; Spectral Engines</a:t>
-            </a:r>
-          </a:p>
-          <a:p>
-            <a:pPr>
-              <a:defRPr sz="919">
-                <a:solidFill>
-                  <a:srgbClr val="212529"/>
-                </a:solidFill>
-              </a:defRPr>
-            </a:pPr>
-            <a:r>
-              <a:t>Runs BLIP VQA, Text Grounder, Change Detection, Optical+SAR Fusion, or Hydro-NDWI</a:t>
-            </a:r>
-          </a:p>
-        </p:txBody>
-      </p:sp>
-      <p:sp>
-        <p:nvSpPr>
-          <p:cNvPr id="20" name="TextBox 19"/>
-          <p:cNvSpPr txBox="1"/>
-          <p:nvPr/>
-        </p:nvSpPr>
-        <p:spPr>
-          <a:xfrm>
-            <a:off x="8787384" y="5102352"/>
-            <a:ext cx="457200" cy="228600"/>
-          </a:xfrm>
-          <a:prstGeom prst="rect">
-            <a:avLst/>
-          </a:prstGeom>
-          <a:noFill/>
-        </p:spPr>
-        <p:txBody>
-          <a:bodyPr wrap="none">
-            <a:spAutoFit/>
-          </a:bodyPr>
-          <a:lstStyle/>
-          <a:p>
-            <a:pPr algn="ctr">
-              <a:defRPr sz="1000" b="1">
-                <a:solidFill>
-                  <a:srgbClr val="0D6ECC"/>
-                </a:solidFill>
-              </a:defRPr>
-            </a:pPr>
-            <a:r>
-              <a:t>▼</a:t>
-            </a:r>
-          </a:p>
-        </p:txBody>
-      </p:sp>
-      <p:sp>
-        <p:nvSpPr>
-          <p:cNvPr id="21" name="Rounded Rectangle 20"/>
+          <a:bodyPr rtlCol="0" anchor="ctr"/>
+          <a:lstStyle/>
+          <a:p>
+            <a:pPr algn="ctr"/>
+          </a:p>
+        </p:txBody>
+      </p:sp>
+      <p:sp>
+        <p:nvSpPr>
+          <p:cNvPr id="29" name="Rounded Rectangle 28"/>
           <p:cNvSpPr/>
           <p:nvPr/>
         </p:nvSpPr>
         <p:spPr>
           <a:xfrm>
-            <a:off x="6409944" y="5321808"/>
-            <a:ext cx="5138928" cy="512064"/>
+            <a:off x="731520" y="4187952"/>
+            <a:ext cx="3794760" cy="201168"/>
           </a:xfrm>
           <a:prstGeom prst="roundRect">
             <a:avLst/>
           </a:prstGeom>
           <a:solidFill>
-            <a:srgbClr val="FFFFFF"/>
+            <a:srgbClr val="147D3C"/>
           </a:solidFill>
-          <a:ln w="15240">
-            <a:solidFill>
-              <a:srgbClr val="B4C3D7"/>
-            </a:solidFill>
+          <a:ln>
+            <a:noFill/>
           </a:ln>
         </p:spPr>
         <p:style>
@@ -5448,30 +5921,1484 @@
           </a:fontRef>
         </p:style>
         <p:txBody>
-          <a:bodyPr rtlCol="0" anchor="ctr" wrap="square" lIns="109728" rIns="109728" tIns="36576" bIns="36576"/>
+          <a:bodyPr rtlCol="0" anchor="ctr"/>
           <a:lstStyle/>
           <a:p>
             <a:pPr algn="ctr">
-              <a:defRPr sz="1050" b="1">
+              <a:defRPr sz="900" b="1">
+                <a:solidFill>
+                  <a:srgbClr val="FFFFFF"/>
+                </a:solidFill>
+              </a:defRPr>
+            </a:pPr>
+            <a:r>
+              <a:t>4. PERSISTENCE LAYER (Hybrid Storage)</a:t>
+            </a:r>
+          </a:p>
+        </p:txBody>
+      </p:sp>
+      <p:sp>
+        <p:nvSpPr>
+          <p:cNvPr id="30" name="Rounded Rectangle 29"/>
+          <p:cNvSpPr/>
+          <p:nvPr/>
+        </p:nvSpPr>
+        <p:spPr>
+          <a:xfrm>
+            <a:off x="566928" y="4425696"/>
+            <a:ext cx="2011680" cy="521207"/>
+          </a:xfrm>
+          <a:prstGeom prst="roundRect">
+            <a:avLst/>
+          </a:prstGeom>
+          <a:solidFill>
+            <a:srgbClr val="FFFFFF"/>
+          </a:solidFill>
+          <a:ln w="12700">
+            <a:solidFill>
+              <a:srgbClr val="B4E1C8"/>
+            </a:solidFill>
+          </a:ln>
+        </p:spPr>
+        <p:style>
+          <a:lnRef idx="1">
+            <a:schemeClr val="accent1"/>
+          </a:lnRef>
+          <a:fillRef idx="3">
+            <a:schemeClr val="accent1"/>
+          </a:fillRef>
+          <a:effectRef idx="2">
+            <a:schemeClr val="accent1"/>
+          </a:effectRef>
+          <a:fontRef idx="minor">
+            <a:schemeClr val="lt1"/>
+          </a:fontRef>
+        </p:style>
+        <p:txBody>
+          <a:bodyPr rtlCol="0" anchor="ctr" wrap="square" tIns="36576"/>
+          <a:lstStyle/>
+          <a:p>
+            <a:pPr algn="ctr">
+              <a:defRPr sz="850" b="1">
+                <a:solidFill>
+                  <a:srgbClr val="147D3C"/>
+                </a:solidFill>
+              </a:defRPr>
+            </a:pPr>
+            <a:r>
+              <a:t>🗄️ Local GeoTIFF Store</a:t>
+            </a:r>
+          </a:p>
+          <a:p>
+            <a:pPr algn="ctr">
+              <a:defRPr sz="750">
+                <a:solidFill>
+                  <a:srgbClr val="212529"/>
+                </a:solidFill>
+              </a:defRPr>
+            </a:pPr>
+            <a:r>
+              <a:t>Multispectral &amp; SAR Rasters</a:t>
+            </a:r>
+          </a:p>
+        </p:txBody>
+      </p:sp>
+      <p:sp>
+        <p:nvSpPr>
+          <p:cNvPr id="31" name="Rounded Rectangle 30"/>
+          <p:cNvSpPr/>
+          <p:nvPr/>
+        </p:nvSpPr>
+        <p:spPr>
+          <a:xfrm>
+            <a:off x="2670048" y="4425696"/>
+            <a:ext cx="2011680" cy="521207"/>
+          </a:xfrm>
+          <a:prstGeom prst="roundRect">
+            <a:avLst/>
+          </a:prstGeom>
+          <a:solidFill>
+            <a:srgbClr val="FFFFFF"/>
+          </a:solidFill>
+          <a:ln w="12700">
+            <a:solidFill>
+              <a:srgbClr val="B4E1C8"/>
+            </a:solidFill>
+          </a:ln>
+        </p:spPr>
+        <p:style>
+          <a:lnRef idx="1">
+            <a:schemeClr val="accent1"/>
+          </a:lnRef>
+          <a:fillRef idx="3">
+            <a:schemeClr val="accent1"/>
+          </a:fillRef>
+          <a:effectRef idx="2">
+            <a:schemeClr val="accent1"/>
+          </a:effectRef>
+          <a:fontRef idx="minor">
+            <a:schemeClr val="lt1"/>
+          </a:fontRef>
+        </p:style>
+        <p:txBody>
+          <a:bodyPr rtlCol="0" anchor="ctr" wrap="square" tIns="36576"/>
+          <a:lstStyle/>
+          <a:p>
+            <a:pPr algn="ctr">
+              <a:defRPr sz="850" b="1">
+                <a:solidFill>
+                  <a:srgbClr val="147D3C"/>
+                </a:solidFill>
+              </a:defRPr>
+            </a:pPr>
+            <a:r>
+              <a:t>⚡ Tile Cache &amp; Audit DB</a:t>
+            </a:r>
+          </a:p>
+          <a:p>
+            <a:pPr algn="ctr">
+              <a:defRPr sz="750">
+                <a:solidFill>
+                  <a:srgbClr val="212529"/>
+                </a:solidFill>
+              </a:defRPr>
+            </a:pPr>
+            <a:r>
+              <a:t>Indexed Spatial Queries</a:t>
+            </a:r>
+          </a:p>
+        </p:txBody>
+      </p:sp>
+      <p:sp>
+        <p:nvSpPr>
+          <p:cNvPr id="32" name="Rounded Rectangle 31"/>
+          <p:cNvSpPr/>
+          <p:nvPr/>
+        </p:nvSpPr>
+        <p:spPr>
+          <a:xfrm>
+            <a:off x="5074920" y="4160520"/>
+            <a:ext cx="4343400" cy="841248"/>
+          </a:xfrm>
+          <a:prstGeom prst="roundRect">
+            <a:avLst/>
+          </a:prstGeom>
+          <a:solidFill>
+            <a:srgbClr val="FFF9F3"/>
+          </a:solidFill>
+          <a:ln w="19050">
+            <a:solidFill>
+              <a:srgbClr val="FAC8A0"/>
+            </a:solidFill>
+          </a:ln>
+        </p:spPr>
+        <p:style>
+          <a:lnRef idx="1">
+            <a:schemeClr val="accent1"/>
+          </a:lnRef>
+          <a:fillRef idx="3">
+            <a:schemeClr val="accent1"/>
+          </a:fillRef>
+          <a:effectRef idx="2">
+            <a:schemeClr val="accent1"/>
+          </a:effectRef>
+          <a:fontRef idx="minor">
+            <a:schemeClr val="lt1"/>
+          </a:fontRef>
+        </p:style>
+        <p:txBody>
+          <a:bodyPr rtlCol="0" anchor="ctr"/>
+          <a:lstStyle/>
+          <a:p>
+            <a:pPr algn="ctr"/>
+          </a:p>
+        </p:txBody>
+      </p:sp>
+      <p:sp>
+        <p:nvSpPr>
+          <p:cNvPr id="33" name="Rounded Rectangle 32"/>
+          <p:cNvSpPr/>
+          <p:nvPr/>
+        </p:nvSpPr>
+        <p:spPr>
+          <a:xfrm>
+            <a:off x="5349240" y="4187952"/>
+            <a:ext cx="3794760" cy="201168"/>
+          </a:xfrm>
+          <a:prstGeom prst="roundRect">
+            <a:avLst/>
+          </a:prstGeom>
+          <a:solidFill>
+            <a:srgbClr val="D75F14"/>
+          </a:solidFill>
+          <a:ln>
+            <a:noFill/>
+          </a:ln>
+        </p:spPr>
+        <p:style>
+          <a:lnRef idx="1">
+            <a:schemeClr val="accent1"/>
+          </a:lnRef>
+          <a:fillRef idx="3">
+            <a:schemeClr val="accent1"/>
+          </a:fillRef>
+          <a:effectRef idx="2">
+            <a:schemeClr val="accent1"/>
+          </a:effectRef>
+          <a:fontRef idx="minor">
+            <a:schemeClr val="lt1"/>
+          </a:fontRef>
+        </p:style>
+        <p:txBody>
+          <a:bodyPr rtlCol="0" anchor="ctr"/>
+          <a:lstStyle/>
+          <a:p>
+            <a:pPr algn="ctr">
+              <a:defRPr sz="900" b="1">
+                <a:solidFill>
+                  <a:srgbClr val="FFFFFF"/>
+                </a:solidFill>
+              </a:defRPr>
+            </a:pPr>
+            <a:r>
+              <a:t>5. INTEROPERABILITY LAYER (Standardized Exchange)</a:t>
+            </a:r>
+          </a:p>
+        </p:txBody>
+      </p:sp>
+      <p:sp>
+        <p:nvSpPr>
+          <p:cNvPr id="34" name="Rounded Rectangle 33"/>
+          <p:cNvSpPr/>
+          <p:nvPr/>
+        </p:nvSpPr>
+        <p:spPr>
+          <a:xfrm>
+            <a:off x="5184648" y="4425696"/>
+            <a:ext cx="2011680" cy="521207"/>
+          </a:xfrm>
+          <a:prstGeom prst="roundRect">
+            <a:avLst/>
+          </a:prstGeom>
+          <a:solidFill>
+            <a:srgbClr val="FFFFFF"/>
+          </a:solidFill>
+          <a:ln w="12700">
+            <a:solidFill>
+              <a:srgbClr val="F5D2B4"/>
+            </a:solidFill>
+          </a:ln>
+        </p:spPr>
+        <p:style>
+          <a:lnRef idx="1">
+            <a:schemeClr val="accent1"/>
+          </a:lnRef>
+          <a:fillRef idx="3">
+            <a:schemeClr val="accent1"/>
+          </a:fillRef>
+          <a:effectRef idx="2">
+            <a:schemeClr val="accent1"/>
+          </a:effectRef>
+          <a:fontRef idx="minor">
+            <a:schemeClr val="lt1"/>
+          </a:fontRef>
+        </p:style>
+        <p:txBody>
+          <a:bodyPr rtlCol="0" anchor="ctr" wrap="square" tIns="36576"/>
+          <a:lstStyle/>
+          <a:p>
+            <a:pPr algn="ctr">
+              <a:defRPr sz="850" b="1">
+                <a:solidFill>
+                  <a:srgbClr val="D75F14"/>
+                </a:solidFill>
+              </a:defRPr>
+            </a:pPr>
+            <a:r>
+              <a:t>🛰️ ISRO Bhuvan / Bhoonidhi</a:t>
+            </a:r>
+          </a:p>
+          <a:p>
+            <a:pPr algn="ctr">
+              <a:defRPr sz="750">
+                <a:solidFill>
+                  <a:srgbClr val="212529"/>
+                </a:solidFill>
+              </a:defRPr>
+            </a:pPr>
+            <a:r>
+              <a:t>Resourcesat, Cartosat, RISAT</a:t>
+            </a:r>
+          </a:p>
+        </p:txBody>
+      </p:sp>
+      <p:sp>
+        <p:nvSpPr>
+          <p:cNvPr id="35" name="Rounded Rectangle 34"/>
+          <p:cNvSpPr/>
+          <p:nvPr/>
+        </p:nvSpPr>
+        <p:spPr>
+          <a:xfrm>
+            <a:off x="7287768" y="4425696"/>
+            <a:ext cx="2011680" cy="521207"/>
+          </a:xfrm>
+          <a:prstGeom prst="roundRect">
+            <a:avLst/>
+          </a:prstGeom>
+          <a:solidFill>
+            <a:srgbClr val="FFFFFF"/>
+          </a:solidFill>
+          <a:ln w="12700">
+            <a:solidFill>
+              <a:srgbClr val="F5D2B4"/>
+            </a:solidFill>
+          </a:ln>
+        </p:spPr>
+        <p:style>
+          <a:lnRef idx="1">
+            <a:schemeClr val="accent1"/>
+          </a:lnRef>
+          <a:fillRef idx="3">
+            <a:schemeClr val="accent1"/>
+          </a:fillRef>
+          <a:effectRef idx="2">
+            <a:schemeClr val="accent1"/>
+          </a:effectRef>
+          <a:fontRef idx="minor">
+            <a:schemeClr val="lt1"/>
+          </a:fontRef>
+        </p:style>
+        <p:txBody>
+          <a:bodyPr rtlCol="0" anchor="ctr" wrap="square" tIns="36576"/>
+          <a:lstStyle/>
+          <a:p>
+            <a:pPr algn="ctr">
+              <a:defRPr sz="850" b="1">
+                <a:solidFill>
+                  <a:srgbClr val="D75F14"/>
+                </a:solidFill>
+              </a:defRPr>
+            </a:pPr>
+            <a:r>
+              <a:t>🌍 Copernicus CDSE Gateway</a:t>
+            </a:r>
+          </a:p>
+          <a:p>
+            <a:pPr algn="ctr">
+              <a:defRPr sz="750">
+                <a:solidFill>
+                  <a:srgbClr val="212529"/>
+                </a:solidFill>
+              </a:defRPr>
+            </a:pPr>
+            <a:r>
+              <a:t>Sentinel-1 SAR, Sentinel-2 MSI</a:t>
+            </a:r>
+          </a:p>
+        </p:txBody>
+      </p:sp>
+      <p:sp>
+        <p:nvSpPr>
+          <p:cNvPr id="36" name="Rounded Rectangle 35"/>
+          <p:cNvSpPr/>
+          <p:nvPr/>
+        </p:nvSpPr>
+        <p:spPr>
+          <a:xfrm>
+            <a:off x="548640" y="5056632"/>
+            <a:ext cx="1682496" cy="365760"/>
+          </a:xfrm>
+          <a:prstGeom prst="roundRect">
+            <a:avLst/>
+          </a:prstGeom>
+          <a:solidFill>
+            <a:srgbClr val="FFFFFF"/>
+          </a:solidFill>
+          <a:ln w="12700">
+            <a:solidFill>
+              <a:srgbClr val="C8D7EB"/>
+            </a:solidFill>
+          </a:ln>
+        </p:spPr>
+        <p:style>
+          <a:lnRef idx="1">
+            <a:schemeClr val="accent1"/>
+          </a:lnRef>
+          <a:fillRef idx="3">
+            <a:schemeClr val="accent1"/>
+          </a:fillRef>
+          <a:effectRef idx="2">
+            <a:schemeClr val="accent1"/>
+          </a:effectRef>
+          <a:fontRef idx="minor">
+            <a:schemeClr val="lt1"/>
+          </a:fontRef>
+        </p:style>
+        <p:txBody>
+          <a:bodyPr rtlCol="0" anchor="ctr" wrap="square" tIns="18288" bIns="18288"/>
+          <a:lstStyle/>
+          <a:p>
+            <a:pPr algn="ctr">
+              <a:defRPr sz="819" b="1">
+                <a:solidFill>
+                  <a:srgbClr val="0F3C82"/>
+                </a:solidFill>
+              </a:defRPr>
+            </a:pPr>
+            <a:r>
+              <a:t>🌐 Unified Access</a:t>
+            </a:r>
+          </a:p>
+          <a:p>
+            <a:pPr algn="ctr">
+              <a:defRPr sz="720">
+                <a:solidFill>
+                  <a:srgbClr val="646E78"/>
+                </a:solidFill>
+              </a:defRPr>
+            </a:pPr>
+            <a:r>
+              <a:t>Cross-departmental GIS</a:t>
+            </a:r>
+          </a:p>
+        </p:txBody>
+      </p:sp>
+      <p:sp>
+        <p:nvSpPr>
+          <p:cNvPr id="37" name="Rounded Rectangle 36"/>
+          <p:cNvSpPr/>
+          <p:nvPr/>
+        </p:nvSpPr>
+        <p:spPr>
+          <a:xfrm>
+            <a:off x="2304288" y="5056632"/>
+            <a:ext cx="1682496" cy="365760"/>
+          </a:xfrm>
+          <a:prstGeom prst="roundRect">
+            <a:avLst/>
+          </a:prstGeom>
+          <a:solidFill>
+            <a:srgbClr val="FFFFFF"/>
+          </a:solidFill>
+          <a:ln w="12700">
+            <a:solidFill>
+              <a:srgbClr val="C8D7EB"/>
+            </a:solidFill>
+          </a:ln>
+        </p:spPr>
+        <p:style>
+          <a:lnRef idx="1">
+            <a:schemeClr val="accent1"/>
+          </a:lnRef>
+          <a:fillRef idx="3">
+            <a:schemeClr val="accent1"/>
+          </a:fillRef>
+          <a:effectRef idx="2">
+            <a:schemeClr val="accent1"/>
+          </a:effectRef>
+          <a:fontRef idx="minor">
+            <a:schemeClr val="lt1"/>
+          </a:fontRef>
+        </p:style>
+        <p:txBody>
+          <a:bodyPr rtlCol="0" anchor="ctr" wrap="square" tIns="18288" bIns="18288"/>
+          <a:lstStyle/>
+          <a:p>
+            <a:pPr algn="ctr">
+              <a:defRPr sz="819" b="1">
+                <a:solidFill>
+                  <a:srgbClr val="0F3C82"/>
+                </a:solidFill>
+              </a:defRPr>
+            </a:pPr>
+            <a:r>
+              <a:t>🧠 Zero Hallucination</a:t>
+            </a:r>
+          </a:p>
+          <a:p>
+            <a:pPr algn="ctr">
+              <a:defRPr sz="720">
+                <a:solidFill>
+                  <a:srgbClr val="646E78"/>
+                </a:solidFill>
+              </a:defRPr>
+            </a:pPr>
+            <a:r>
+              <a:t>Strict deterministic routing</a:t>
+            </a:r>
+          </a:p>
+        </p:txBody>
+      </p:sp>
+      <p:sp>
+        <p:nvSpPr>
+          <p:cNvPr id="38" name="Rounded Rectangle 37"/>
+          <p:cNvSpPr/>
+          <p:nvPr/>
+        </p:nvSpPr>
+        <p:spPr>
+          <a:xfrm>
+            <a:off x="4059936" y="5056632"/>
+            <a:ext cx="1682496" cy="365760"/>
+          </a:xfrm>
+          <a:prstGeom prst="roundRect">
+            <a:avLst/>
+          </a:prstGeom>
+          <a:solidFill>
+            <a:srgbClr val="FFFFFF"/>
+          </a:solidFill>
+          <a:ln w="12700">
+            <a:solidFill>
+              <a:srgbClr val="C8D7EB"/>
+            </a:solidFill>
+          </a:ln>
+        </p:spPr>
+        <p:style>
+          <a:lnRef idx="1">
+            <a:schemeClr val="accent1"/>
+          </a:lnRef>
+          <a:fillRef idx="3">
+            <a:schemeClr val="accent1"/>
+          </a:fillRef>
+          <a:effectRef idx="2">
+            <a:schemeClr val="accent1"/>
+          </a:effectRef>
+          <a:fontRef idx="minor">
+            <a:schemeClr val="lt1"/>
+          </a:fontRef>
+        </p:style>
+        <p:txBody>
+          <a:bodyPr rtlCol="0" anchor="ctr" wrap="square" tIns="18288" bIns="18288"/>
+          <a:lstStyle/>
+          <a:p>
+            <a:pPr algn="ctr">
+              <a:defRPr sz="819" b="1">
+                <a:solidFill>
+                  <a:srgbClr val="0F3C82"/>
+                </a:solidFill>
+              </a:defRPr>
+            </a:pPr>
+            <a:r>
+              <a:t>🔒 Air-Gapped Secure</a:t>
+            </a:r>
+          </a:p>
+          <a:p>
+            <a:pPr algn="ctr">
+              <a:defRPr sz="720">
+                <a:solidFill>
+                  <a:srgbClr val="646E78"/>
+                </a:solidFill>
+              </a:defRPr>
+            </a:pPr>
+            <a:r>
+              <a:t>100% on-premise execution</a:t>
+            </a:r>
+          </a:p>
+        </p:txBody>
+      </p:sp>
+      <p:sp>
+        <p:nvSpPr>
+          <p:cNvPr id="39" name="Rounded Rectangle 38"/>
+          <p:cNvSpPr/>
+          <p:nvPr/>
+        </p:nvSpPr>
+        <p:spPr>
+          <a:xfrm>
+            <a:off x="5815584" y="5056632"/>
+            <a:ext cx="1682496" cy="365760"/>
+          </a:xfrm>
+          <a:prstGeom prst="roundRect">
+            <a:avLst/>
+          </a:prstGeom>
+          <a:solidFill>
+            <a:srgbClr val="FFFFFF"/>
+          </a:solidFill>
+          <a:ln w="12700">
+            <a:solidFill>
+              <a:srgbClr val="C8D7EB"/>
+            </a:solidFill>
+          </a:ln>
+        </p:spPr>
+        <p:style>
+          <a:lnRef idx="1">
+            <a:schemeClr val="accent1"/>
+          </a:lnRef>
+          <a:fillRef idx="3">
+            <a:schemeClr val="accent1"/>
+          </a:fillRef>
+          <a:effectRef idx="2">
+            <a:schemeClr val="accent1"/>
+          </a:effectRef>
+          <a:fontRef idx="minor">
+            <a:schemeClr val="lt1"/>
+          </a:fontRef>
+        </p:style>
+        <p:txBody>
+          <a:bodyPr rtlCol="0" anchor="ctr" wrap="square" tIns="18288" bIns="18288"/>
+          <a:lstStyle/>
+          <a:p>
+            <a:pPr algn="ctr">
+              <a:defRPr sz="819" b="1">
+                <a:solidFill>
+                  <a:srgbClr val="0F3C82"/>
+                </a:solidFill>
+              </a:defRPr>
+            </a:pPr>
+            <a:r>
+              <a:t>🛰️ Multi-Sensor Fusion</a:t>
+            </a:r>
+          </a:p>
+          <a:p>
+            <a:pPr algn="ctr">
+              <a:defRPr sz="720">
+                <a:solidFill>
+                  <a:srgbClr val="646E78"/>
+                </a:solidFill>
+              </a:defRPr>
+            </a:pPr>
+            <a:r>
+              <a:t>Optical + SAR co-analysis</a:t>
+            </a:r>
+          </a:p>
+        </p:txBody>
+      </p:sp>
+      <p:sp>
+        <p:nvSpPr>
+          <p:cNvPr id="40" name="Rounded Rectangle 39"/>
+          <p:cNvSpPr/>
+          <p:nvPr/>
+        </p:nvSpPr>
+        <p:spPr>
+          <a:xfrm>
+            <a:off x="7571232" y="5056632"/>
+            <a:ext cx="1682496" cy="365760"/>
+          </a:xfrm>
+          <a:prstGeom prst="roundRect">
+            <a:avLst/>
+          </a:prstGeom>
+          <a:solidFill>
+            <a:srgbClr val="FFFFFF"/>
+          </a:solidFill>
+          <a:ln w="12700">
+            <a:solidFill>
+              <a:srgbClr val="C8D7EB"/>
+            </a:solidFill>
+          </a:ln>
+        </p:spPr>
+        <p:style>
+          <a:lnRef idx="1">
+            <a:schemeClr val="accent1"/>
+          </a:lnRef>
+          <a:fillRef idx="3">
+            <a:schemeClr val="accent1"/>
+          </a:fillRef>
+          <a:effectRef idx="2">
+            <a:schemeClr val="accent1"/>
+          </a:effectRef>
+          <a:fontRef idx="minor">
+            <a:schemeClr val="lt1"/>
+          </a:fontRef>
+        </p:style>
+        <p:txBody>
+          <a:bodyPr rtlCol="0" anchor="ctr" wrap="square" tIns="18288" bIns="18288"/>
+          <a:lstStyle/>
+          <a:p>
+            <a:pPr algn="ctr">
+              <a:defRPr sz="819" b="1">
+                <a:solidFill>
+                  <a:srgbClr val="0F3C82"/>
+                </a:solidFill>
+              </a:defRPr>
+            </a:pPr>
+            <a:r>
+              <a:t>⚡ &lt;300ms Latency</a:t>
+            </a:r>
+          </a:p>
+          <a:p>
+            <a:pPr algn="ctr">
+              <a:defRPr sz="720">
+                <a:solidFill>
+                  <a:srgbClr val="646E78"/>
+                </a:solidFill>
+              </a:defRPr>
+            </a:pPr>
+            <a:r>
+              <a:t>Standard CPU inference</a:t>
+            </a:r>
+          </a:p>
+        </p:txBody>
+      </p:sp>
+      <p:sp>
+        <p:nvSpPr>
+          <p:cNvPr id="41" name="Rounded Rectangle 40"/>
+          <p:cNvSpPr/>
+          <p:nvPr/>
+        </p:nvSpPr>
+        <p:spPr>
+          <a:xfrm>
+            <a:off x="457200" y="5486400"/>
+            <a:ext cx="8961120" cy="329184"/>
+          </a:xfrm>
+          <a:prstGeom prst="roundRect">
+            <a:avLst/>
+          </a:prstGeom>
+          <a:solidFill>
+            <a:srgbClr val="F6F8FC"/>
+          </a:solidFill>
+          <a:ln w="12700">
+            <a:solidFill>
+              <a:srgbClr val="BECDE1"/>
+            </a:solidFill>
+          </a:ln>
+        </p:spPr>
+        <p:style>
+          <a:lnRef idx="1">
+            <a:schemeClr val="accent1"/>
+          </a:lnRef>
+          <a:fillRef idx="3">
+            <a:schemeClr val="accent1"/>
+          </a:fillRef>
+          <a:effectRef idx="2">
+            <a:schemeClr val="accent1"/>
+          </a:effectRef>
+          <a:fontRef idx="minor">
+            <a:schemeClr val="lt1"/>
+          </a:fontRef>
+        </p:style>
+        <p:txBody>
+          <a:bodyPr rtlCol="0" anchor="ctr" wrap="square" tIns="36576"/>
+          <a:lstStyle/>
+          <a:p>
+            <a:pPr algn="ctr">
+              <a:defRPr sz="950" b="1">
                 <a:solidFill>
                   <a:srgbClr val="0B2C5B"/>
                 </a:solidFill>
               </a:defRPr>
             </a:pPr>
             <a:r>
-              <a:t>Step 5: Interactive GIS Visualization &amp; Audit</a:t>
+              <a:t>🎯 OUR GOAL: Democratize satellite Earth observation intelligence with zero hallucination and 24/7 all-weather situational awareness.</a:t>
+            </a:r>
+          </a:p>
+        </p:txBody>
+      </p:sp>
+      <p:sp>
+        <p:nvSpPr>
+          <p:cNvPr id="42" name="Rounded Rectangle 41"/>
+          <p:cNvSpPr/>
+          <p:nvPr/>
+        </p:nvSpPr>
+        <p:spPr>
+          <a:xfrm>
+            <a:off x="9646920" y="868680"/>
+            <a:ext cx="2103120" cy="4946904"/>
+          </a:xfrm>
+          <a:prstGeom prst="roundRect">
+            <a:avLst/>
+          </a:prstGeom>
+          <a:solidFill>
+            <a:srgbClr val="FFFFFF"/>
+          </a:solidFill>
+          <a:ln w="19050">
+            <a:solidFill>
+              <a:srgbClr val="D7E1EE"/>
+            </a:solidFill>
+          </a:ln>
+        </p:spPr>
+        <p:style>
+          <a:lnRef idx="1">
+            <a:schemeClr val="accent1"/>
+          </a:lnRef>
+          <a:fillRef idx="3">
+            <a:schemeClr val="accent1"/>
+          </a:fillRef>
+          <a:effectRef idx="2">
+            <a:schemeClr val="accent1"/>
+          </a:effectRef>
+          <a:fontRef idx="minor">
+            <a:schemeClr val="lt1"/>
+          </a:fontRef>
+        </p:style>
+        <p:txBody>
+          <a:bodyPr rtlCol="0" anchor="ctr"/>
+          <a:lstStyle/>
+          <a:p>
+            <a:pPr algn="ctr"/>
+          </a:p>
+        </p:txBody>
+      </p:sp>
+      <p:sp>
+        <p:nvSpPr>
+          <p:cNvPr id="43" name="TextBox 42"/>
+          <p:cNvSpPr txBox="1"/>
+          <p:nvPr/>
+        </p:nvSpPr>
+        <p:spPr>
+          <a:xfrm>
+            <a:off x="9692640" y="932688"/>
+            <a:ext cx="2011680" cy="347472"/>
+          </a:xfrm>
+          <a:prstGeom prst="rect">
+            <a:avLst/>
+          </a:prstGeom>
+          <a:noFill/>
+        </p:spPr>
+        <p:txBody>
+          <a:bodyPr wrap="none">
+            <a:spAutoFit/>
+          </a:bodyPr>
+          <a:lstStyle/>
+          <a:p>
+            <a:pPr algn="ctr">
+              <a:defRPr sz="1500" b="1">
+                <a:solidFill>
+                  <a:srgbClr val="212529"/>
+                </a:solidFill>
+              </a:defRPr>
+            </a:pPr>
+            <a:r>
+              <a:t>Techstacks Used</a:t>
+            </a:r>
+          </a:p>
+        </p:txBody>
+      </p:sp>
+      <p:sp>
+        <p:nvSpPr>
+          <p:cNvPr id="44" name="Rounded Rectangle 43"/>
+          <p:cNvSpPr/>
+          <p:nvPr/>
+        </p:nvSpPr>
+        <p:spPr>
+          <a:xfrm>
+            <a:off x="9784080" y="1353312"/>
+            <a:ext cx="1828800" cy="457200"/>
+          </a:xfrm>
+          <a:prstGeom prst="roundRect">
+            <a:avLst/>
+          </a:prstGeom>
+          <a:solidFill>
+            <a:srgbClr val="FAFCFF"/>
+          </a:solidFill>
+          <a:ln w="12700">
+            <a:solidFill>
+              <a:srgbClr val="3572A5"/>
+            </a:solidFill>
+          </a:ln>
+        </p:spPr>
+        <p:style>
+          <a:lnRef idx="1">
+            <a:schemeClr val="accent1"/>
+          </a:lnRef>
+          <a:fillRef idx="3">
+            <a:schemeClr val="accent1"/>
+          </a:fillRef>
+          <a:effectRef idx="2">
+            <a:schemeClr val="accent1"/>
+          </a:effectRef>
+          <a:fontRef idx="minor">
+            <a:schemeClr val="lt1"/>
+          </a:fontRef>
+        </p:style>
+        <p:txBody>
+          <a:bodyPr rtlCol="0" anchor="ctr" wrap="square" tIns="36576" bIns="18288" lIns="54864" rIns="54864"/>
+          <a:lstStyle/>
+          <a:p>
+            <a:pPr algn="ctr">
+              <a:defRPr sz="950" b="1">
+                <a:solidFill>
+                  <a:srgbClr val="212529"/>
+                </a:solidFill>
+              </a:defRPr>
+            </a:pPr>
+            <a:r>
+              <a:t>🐍 Python 3.11</a:t>
             </a:r>
           </a:p>
           <a:p>
             <a:pPr>
-              <a:defRPr sz="919">
-                <a:solidFill>
-                  <a:srgbClr val="212529"/>
-                </a:solidFill>
-              </a:defRPr>
-            </a:pPr>
-            <a:r>
-              <a:t>Renders MapLibre GL vector overlays, confidence score &amp; exportable audit log</a:t>
+              <a:defRPr sz="750">
+                <a:solidFill>
+                  <a:srgbClr val="646E78"/>
+                </a:solidFill>
+              </a:defRPr>
+            </a:pPr>
+            <a:r>
+              <a:t>Backend AI &amp; Engines</a:t>
+            </a:r>
+          </a:p>
+        </p:txBody>
+      </p:sp>
+      <p:sp>
+        <p:nvSpPr>
+          <p:cNvPr id="45" name="Rounded Rectangle 44"/>
+          <p:cNvSpPr/>
+          <p:nvPr/>
+        </p:nvSpPr>
+        <p:spPr>
+          <a:xfrm>
+            <a:off x="9784080" y="1892808"/>
+            <a:ext cx="1828800" cy="457200"/>
+          </a:xfrm>
+          <a:prstGeom prst="roundRect">
+            <a:avLst/>
+          </a:prstGeom>
+          <a:solidFill>
+            <a:srgbClr val="FAFCFF"/>
+          </a:solidFill>
+          <a:ln w="12700">
+            <a:solidFill>
+              <a:srgbClr val="05998A"/>
+            </a:solidFill>
+          </a:ln>
+        </p:spPr>
+        <p:style>
+          <a:lnRef idx="1">
+            <a:schemeClr val="accent1"/>
+          </a:lnRef>
+          <a:fillRef idx="3">
+            <a:schemeClr val="accent1"/>
+          </a:fillRef>
+          <a:effectRef idx="2">
+            <a:schemeClr val="accent1"/>
+          </a:effectRef>
+          <a:fontRef idx="minor">
+            <a:schemeClr val="lt1"/>
+          </a:fontRef>
+        </p:style>
+        <p:txBody>
+          <a:bodyPr rtlCol="0" anchor="ctr" wrap="square" tIns="36576" bIns="18288" lIns="54864" rIns="54864"/>
+          <a:lstStyle/>
+          <a:p>
+            <a:pPr algn="ctr">
+              <a:defRPr sz="950" b="1">
+                <a:solidFill>
+                  <a:srgbClr val="212529"/>
+                </a:solidFill>
+              </a:defRPr>
+            </a:pPr>
+            <a:r>
+              <a:t>⚡ FastAPI</a:t>
+            </a:r>
+          </a:p>
+          <a:p>
+            <a:pPr>
+              <a:defRPr sz="750">
+                <a:solidFill>
+                  <a:srgbClr val="646E78"/>
+                </a:solidFill>
+              </a:defRPr>
+            </a:pPr>
+            <a:r>
+              <a:t>Async RESTful Framework</a:t>
+            </a:r>
+          </a:p>
+        </p:txBody>
+      </p:sp>
+      <p:sp>
+        <p:nvSpPr>
+          <p:cNvPr id="46" name="Rounded Rectangle 45"/>
+          <p:cNvSpPr/>
+          <p:nvPr/>
+        </p:nvSpPr>
+        <p:spPr>
+          <a:xfrm>
+            <a:off x="9784080" y="2432304"/>
+            <a:ext cx="1828800" cy="457200"/>
+          </a:xfrm>
+          <a:prstGeom prst="roundRect">
+            <a:avLst/>
+          </a:prstGeom>
+          <a:solidFill>
+            <a:srgbClr val="FAFCFF"/>
+          </a:solidFill>
+          <a:ln w="12700">
+            <a:solidFill>
+              <a:srgbClr val="00B4D8"/>
+            </a:solidFill>
+          </a:ln>
+        </p:spPr>
+        <p:style>
+          <a:lnRef idx="1">
+            <a:schemeClr val="accent1"/>
+          </a:lnRef>
+          <a:fillRef idx="3">
+            <a:schemeClr val="accent1"/>
+          </a:fillRef>
+          <a:effectRef idx="2">
+            <a:schemeClr val="accent1"/>
+          </a:effectRef>
+          <a:fontRef idx="minor">
+            <a:schemeClr val="lt1"/>
+          </a:fontRef>
+        </p:style>
+        <p:txBody>
+          <a:bodyPr rtlCol="0" anchor="ctr" wrap="square" tIns="36576" bIns="18288" lIns="54864" rIns="54864"/>
+          <a:lstStyle/>
+          <a:p>
+            <a:pPr algn="ctr">
+              <a:defRPr sz="950" b="1">
+                <a:solidFill>
+                  <a:srgbClr val="212529"/>
+                </a:solidFill>
+              </a:defRPr>
+            </a:pPr>
+            <a:r>
+              <a:t>⚛️ React 19</a:t>
+            </a:r>
+          </a:p>
+          <a:p>
+            <a:pPr>
+              <a:defRPr sz="750">
+                <a:solidFill>
+                  <a:srgbClr val="646E78"/>
+                </a:solidFill>
+              </a:defRPr>
+            </a:pPr>
+            <a:r>
+              <a:t>Modern Interactive UI</a:t>
+            </a:r>
+          </a:p>
+        </p:txBody>
+      </p:sp>
+      <p:sp>
+        <p:nvSpPr>
+          <p:cNvPr id="47" name="Rounded Rectangle 46"/>
+          <p:cNvSpPr/>
+          <p:nvPr/>
+        </p:nvSpPr>
+        <p:spPr>
+          <a:xfrm>
+            <a:off x="9784080" y="2971800"/>
+            <a:ext cx="1828800" cy="457200"/>
+          </a:xfrm>
+          <a:prstGeom prst="roundRect">
+            <a:avLst/>
+          </a:prstGeom>
+          <a:solidFill>
+            <a:srgbClr val="FAFCFF"/>
+          </a:solidFill>
+          <a:ln w="12700">
+            <a:solidFill>
+              <a:srgbClr val="1E90FF"/>
+            </a:solidFill>
+          </a:ln>
+        </p:spPr>
+        <p:style>
+          <a:lnRef idx="1">
+            <a:schemeClr val="accent1"/>
+          </a:lnRef>
+          <a:fillRef idx="3">
+            <a:schemeClr val="accent1"/>
+          </a:fillRef>
+          <a:effectRef idx="2">
+            <a:schemeClr val="accent1"/>
+          </a:effectRef>
+          <a:fontRef idx="minor">
+            <a:schemeClr val="lt1"/>
+          </a:fontRef>
+        </p:style>
+        <p:txBody>
+          <a:bodyPr rtlCol="0" anchor="ctr" wrap="square" tIns="36576" bIns="18288" lIns="54864" rIns="54864"/>
+          <a:lstStyle/>
+          <a:p>
+            <a:pPr algn="ctr">
+              <a:defRPr sz="950" b="1">
+                <a:solidFill>
+                  <a:srgbClr val="212529"/>
+                </a:solidFill>
+              </a:defRPr>
+            </a:pPr>
+            <a:r>
+              <a:t>🗺️ MapLibre GL</a:t>
+            </a:r>
+          </a:p>
+          <a:p>
+            <a:pPr>
+              <a:defRPr sz="750">
+                <a:solidFill>
+                  <a:srgbClr val="646E78"/>
+                </a:solidFill>
+              </a:defRPr>
+            </a:pPr>
+            <a:r>
+              <a:t>WebGL Vector Map Engine</a:t>
+            </a:r>
+          </a:p>
+        </p:txBody>
+      </p:sp>
+      <p:sp>
+        <p:nvSpPr>
+          <p:cNvPr id="48" name="Rounded Rectangle 47"/>
+          <p:cNvSpPr/>
+          <p:nvPr/>
+        </p:nvSpPr>
+        <p:spPr>
+          <a:xfrm>
+            <a:off x="9784080" y="3511296"/>
+            <a:ext cx="1828800" cy="457200"/>
+          </a:xfrm>
+          <a:prstGeom prst="roundRect">
+            <a:avLst/>
+          </a:prstGeom>
+          <a:solidFill>
+            <a:srgbClr val="FAFCFF"/>
+          </a:solidFill>
+          <a:ln w="12700">
+            <a:solidFill>
+              <a:srgbClr val="0EA5E9"/>
+            </a:solidFill>
+          </a:ln>
+        </p:spPr>
+        <p:style>
+          <a:lnRef idx="1">
+            <a:schemeClr val="accent1"/>
+          </a:lnRef>
+          <a:fillRef idx="3">
+            <a:schemeClr val="accent1"/>
+          </a:fillRef>
+          <a:effectRef idx="2">
+            <a:schemeClr val="accent1"/>
+          </a:effectRef>
+          <a:fontRef idx="minor">
+            <a:schemeClr val="lt1"/>
+          </a:fontRef>
+        </p:style>
+        <p:txBody>
+          <a:bodyPr rtlCol="0" anchor="ctr" wrap="square" tIns="36576" bIns="18288" lIns="54864" rIns="54864"/>
+          <a:lstStyle/>
+          <a:p>
+            <a:pPr algn="ctr">
+              <a:defRPr sz="950" b="1">
+                <a:solidFill>
+                  <a:srgbClr val="212529"/>
+                </a:solidFill>
+              </a:defRPr>
+            </a:pPr>
+            <a:r>
+              <a:t>🎨 Tailwind CSS</a:t>
+            </a:r>
+          </a:p>
+          <a:p>
+            <a:pPr>
+              <a:defRPr sz="750">
+                <a:solidFill>
+                  <a:srgbClr val="646E78"/>
+                </a:solidFill>
+              </a:defRPr>
+            </a:pPr>
+            <a:r>
+              <a:t>Utility-First Design</a:t>
+            </a:r>
+          </a:p>
+        </p:txBody>
+      </p:sp>
+      <p:sp>
+        <p:nvSpPr>
+          <p:cNvPr id="49" name="Rounded Rectangle 48"/>
+          <p:cNvSpPr/>
+          <p:nvPr/>
+        </p:nvSpPr>
+        <p:spPr>
+          <a:xfrm>
+            <a:off x="9784080" y="4050792"/>
+            <a:ext cx="1828800" cy="457200"/>
+          </a:xfrm>
+          <a:prstGeom prst="roundRect">
+            <a:avLst/>
+          </a:prstGeom>
+          <a:solidFill>
+            <a:srgbClr val="FAFCFF"/>
+          </a:solidFill>
+          <a:ln w="12700">
+            <a:solidFill>
+              <a:srgbClr val="EE4C2C"/>
+            </a:solidFill>
+          </a:ln>
+        </p:spPr>
+        <p:style>
+          <a:lnRef idx="1">
+            <a:schemeClr val="accent1"/>
+          </a:lnRef>
+          <a:fillRef idx="3">
+            <a:schemeClr val="accent1"/>
+          </a:fillRef>
+          <a:effectRef idx="2">
+            <a:schemeClr val="accent1"/>
+          </a:effectRef>
+          <a:fontRef idx="minor">
+            <a:schemeClr val="lt1"/>
+          </a:fontRef>
+        </p:style>
+        <p:txBody>
+          <a:bodyPr rtlCol="0" anchor="ctr" wrap="square" tIns="36576" bIns="18288" lIns="54864" rIns="54864"/>
+          <a:lstStyle/>
+          <a:p>
+            <a:pPr algn="ctr">
+              <a:defRPr sz="950" b="1">
+                <a:solidFill>
+                  <a:srgbClr val="212529"/>
+                </a:solidFill>
+              </a:defRPr>
+            </a:pPr>
+            <a:r>
+              <a:t>🔥 PyTorch</a:t>
+            </a:r>
+          </a:p>
+          <a:p>
+            <a:pPr>
+              <a:defRPr sz="750">
+                <a:solidFill>
+                  <a:srgbClr val="646E78"/>
+                </a:solidFill>
+              </a:defRPr>
+            </a:pPr>
+            <a:r>
+              <a:t>Deep Learning &amp; VLM</a:t>
+            </a:r>
+          </a:p>
+        </p:txBody>
+      </p:sp>
+      <p:sp>
+        <p:nvSpPr>
+          <p:cNvPr id="50" name="Rounded Rectangle 49"/>
+          <p:cNvSpPr/>
+          <p:nvPr/>
+        </p:nvSpPr>
+        <p:spPr>
+          <a:xfrm>
+            <a:off x="9784080" y="4590288"/>
+            <a:ext cx="1828800" cy="457200"/>
+          </a:xfrm>
+          <a:prstGeom prst="roundRect">
+            <a:avLst/>
+          </a:prstGeom>
+          <a:solidFill>
+            <a:srgbClr val="FAFCFF"/>
+          </a:solidFill>
+          <a:ln w="12700">
+            <a:solidFill>
+              <a:srgbClr val="4CAF50"/>
+            </a:solidFill>
+          </a:ln>
+        </p:spPr>
+        <p:style>
+          <a:lnRef idx="1">
+            <a:schemeClr val="accent1"/>
+          </a:lnRef>
+          <a:fillRef idx="3">
+            <a:schemeClr val="accent1"/>
+          </a:fillRef>
+          <a:effectRef idx="2">
+            <a:schemeClr val="accent1"/>
+          </a:effectRef>
+          <a:fontRef idx="minor">
+            <a:schemeClr val="lt1"/>
+          </a:fontRef>
+        </p:style>
+        <p:txBody>
+          <a:bodyPr rtlCol="0" anchor="ctr" wrap="square" tIns="36576" bIns="18288" lIns="54864" rIns="54864"/>
+          <a:lstStyle/>
+          <a:p>
+            <a:pPr algn="ctr">
+              <a:defRPr sz="950" b="1">
+                <a:solidFill>
+                  <a:srgbClr val="212529"/>
+                </a:solidFill>
+              </a:defRPr>
+            </a:pPr>
+            <a:r>
+              <a:t>🌐 GDAL / Rasterio</a:t>
+            </a:r>
+          </a:p>
+          <a:p>
+            <a:pPr>
+              <a:defRPr sz="750">
+                <a:solidFill>
+                  <a:srgbClr val="646E78"/>
+                </a:solidFill>
+              </a:defRPr>
+            </a:pPr>
+            <a:r>
+              <a:t>Geospatial Raster Math</a:t>
+            </a:r>
+          </a:p>
+        </p:txBody>
+      </p:sp>
+      <p:sp>
+        <p:nvSpPr>
+          <p:cNvPr id="51" name="Rounded Rectangle 50"/>
+          <p:cNvSpPr/>
+          <p:nvPr/>
+        </p:nvSpPr>
+        <p:spPr>
+          <a:xfrm>
+            <a:off x="9784080" y="5129784"/>
+            <a:ext cx="1828800" cy="457200"/>
+          </a:xfrm>
+          <a:prstGeom prst="roundRect">
+            <a:avLst/>
+          </a:prstGeom>
+          <a:solidFill>
+            <a:srgbClr val="FAFCFF"/>
+          </a:solidFill>
+          <a:ln w="12700">
+            <a:solidFill>
+              <a:srgbClr val="FFB300"/>
+            </a:solidFill>
+          </a:ln>
+        </p:spPr>
+        <p:style>
+          <a:lnRef idx="1">
+            <a:schemeClr val="accent1"/>
+          </a:lnRef>
+          <a:fillRef idx="3">
+            <a:schemeClr val="accent1"/>
+          </a:fillRef>
+          <a:effectRef idx="2">
+            <a:schemeClr val="accent1"/>
+          </a:effectRef>
+          <a:fontRef idx="minor">
+            <a:schemeClr val="lt1"/>
+          </a:fontRef>
+        </p:style>
+        <p:txBody>
+          <a:bodyPr rtlCol="0" anchor="ctr" wrap="square" tIns="36576" bIns="18288" lIns="54864" rIns="54864"/>
+          <a:lstStyle/>
+          <a:p>
+            <a:pPr algn="ctr">
+              <a:defRPr sz="950" b="1">
+                <a:solidFill>
+                  <a:srgbClr val="212529"/>
+                </a:solidFill>
+              </a:defRPr>
+            </a:pPr>
+            <a:r>
+              <a:t>🤗 Transformers</a:t>
+            </a:r>
+          </a:p>
+          <a:p>
+            <a:pPr>
+              <a:defRPr sz="750">
+                <a:solidFill>
+                  <a:srgbClr val="646E78"/>
+                </a:solidFill>
+              </a:defRPr>
+            </a:pPr>
+            <a:r>
+              <a:t>BLIP VQA &amp; Grounding</a:t>
+            </a:r>
+          </a:p>
+        </p:txBody>
+      </p:sp>
+      <p:sp>
+        <p:nvSpPr>
+          <p:cNvPr id="52" name="Rectangle 51"/>
+          <p:cNvSpPr/>
+          <p:nvPr/>
+        </p:nvSpPr>
+        <p:spPr>
+          <a:xfrm>
+            <a:off x="0" y="6309360"/>
+            <a:ext cx="12191695" cy="548640"/>
+          </a:xfrm>
+          <a:prstGeom prst="rect">
+            <a:avLst/>
+          </a:prstGeom>
+          <a:solidFill>
+            <a:srgbClr val="1877F2"/>
+          </a:solidFill>
+          <a:ln>
+            <a:noFill/>
+          </a:ln>
+        </p:spPr>
+        <p:style>
+          <a:lnRef idx="1">
+            <a:schemeClr val="accent1"/>
+          </a:lnRef>
+          <a:fillRef idx="3">
+            <a:schemeClr val="accent1"/>
+          </a:fillRef>
+          <a:effectRef idx="2">
+            <a:schemeClr val="accent1"/>
+          </a:effectRef>
+          <a:fontRef idx="minor">
+            <a:schemeClr val="lt1"/>
+          </a:fontRef>
+        </p:style>
+        <p:txBody>
+          <a:bodyPr rtlCol="0" anchor="ctr"/>
+          <a:lstStyle/>
+          <a:p>
+            <a:pPr algn="ctr"/>
+          </a:p>
+        </p:txBody>
+      </p:sp>
+      <p:sp>
+        <p:nvSpPr>
+          <p:cNvPr id="53" name="TextBox 52"/>
+          <p:cNvSpPr txBox="1"/>
+          <p:nvPr/>
+        </p:nvSpPr>
+        <p:spPr>
+          <a:xfrm>
+            <a:off x="548640" y="6355080"/>
+            <a:ext cx="7315200" cy="457200"/>
+          </a:xfrm>
+          <a:prstGeom prst="rect">
+            <a:avLst/>
+          </a:prstGeom>
+          <a:noFill/>
+        </p:spPr>
+        <p:txBody>
+          <a:bodyPr wrap="none">
+            <a:spAutoFit/>
+          </a:bodyPr>
+          <a:lstStyle/>
+          <a:p>
+            <a:pPr>
+              <a:defRPr sz="1200">
+                <a:solidFill>
+                  <a:srgbClr val="FFFFFF"/>
+                </a:solidFill>
+              </a:defRPr>
+            </a:pPr>
+            <a:r>
+              <a:t>@SIH Idea submission- Template</a:t>
+            </a:r>
+          </a:p>
+        </p:txBody>
+      </p:sp>
+      <p:sp>
+        <p:nvSpPr>
+          <p:cNvPr id="54" name="TextBox 53"/>
+          <p:cNvSpPr txBox="1"/>
+          <p:nvPr/>
+        </p:nvSpPr>
+        <p:spPr>
+          <a:xfrm>
+            <a:off x="10972800" y="6355080"/>
+            <a:ext cx="914400" cy="457200"/>
+          </a:xfrm>
+          <a:prstGeom prst="rect">
+            <a:avLst/>
+          </a:prstGeom>
+          <a:noFill/>
+        </p:spPr>
+        <p:txBody>
+          <a:bodyPr wrap="none">
+            <a:spAutoFit/>
+          </a:bodyPr>
+          <a:lstStyle/>
+          <a:p>
+            <a:pPr>
+              <a:defRPr sz="1400" b="1">
+                <a:solidFill>
+                  <a:srgbClr val="FFFFFF"/>
+                </a:solidFill>
+              </a:defRPr>
+            </a:pPr>
+            <a:r>
+              <a:t>3</a:t>
             </a:r>
           </a:p>
         </p:txBody>

</xml_diff>

<commit_message>
feat(ppt): align Slide 3 with exact Technologies to be used and visual Methodology architecture flow
</commit_message>
<xml_diff>
--- a/SatQuery_AI_SIH26167_Official_6Slides.pptx
+++ b/SatQuery_AI_SIH26167_Official_6Slides.pptx
@@ -4392,133 +4392,24 @@
       <p:grpSpPr/>
       <p:sp>
         <p:nvSpPr>
-          <p:cNvPr id="2" name="TextBox 1"/>
-          <p:cNvSpPr txBox="1"/>
-          <p:nvPr/>
-        </p:nvSpPr>
-        <p:spPr>
-          <a:xfrm>
-            <a:off x="457200" y="182880"/>
-            <a:ext cx="8961120" cy="384048"/>
-          </a:xfrm>
-          <a:prstGeom prst="rect">
-            <a:avLst/>
-          </a:prstGeom>
-          <a:noFill/>
-        </p:spPr>
-        <p:txBody>
-          <a:bodyPr wrap="none">
-            <a:spAutoFit/>
-          </a:bodyPr>
-          <a:lstStyle/>
-          <a:p>
-            <a:pPr algn="ctr">
-              <a:defRPr sz="2200" b="1">
-                <a:solidFill>
-                  <a:srgbClr val="212529"/>
-                </a:solidFill>
-              </a:defRPr>
-            </a:pPr>
-            <a:r>
-              <a:t>TECHNICAL APPROACH</a:t>
-            </a:r>
-          </a:p>
-        </p:txBody>
-      </p:sp>
-      <p:sp>
-        <p:nvSpPr>
-          <p:cNvPr id="3" name="TextBox 2"/>
-          <p:cNvSpPr txBox="1"/>
-          <p:nvPr/>
-        </p:nvSpPr>
-        <p:spPr>
-          <a:xfrm>
-            <a:off x="9646920" y="137160"/>
-            <a:ext cx="2103120" cy="640080"/>
-          </a:xfrm>
-          <a:prstGeom prst="rect">
-            <a:avLst/>
-          </a:prstGeom>
-          <a:noFill/>
-        </p:spPr>
-        <p:txBody>
-          <a:bodyPr wrap="none">
-            <a:spAutoFit/>
-          </a:bodyPr>
-          <a:lstStyle/>
-          <a:p>
-            <a:pPr algn="ctr">
-              <a:defRPr sz="1300" b="1">
-                <a:solidFill>
-                  <a:srgbClr val="0B2C5B"/>
-                </a:solidFill>
-              </a:defRPr>
-            </a:pPr>
-            <a:r>
-              <a:t>SMART INDIA</a:t>
-            </a:r>
-            <a:br/>
-            <a:r>
-              <a:t>HACKATHON 2026</a:t>
-            </a:r>
-          </a:p>
-        </p:txBody>
-      </p:sp>
-      <p:sp>
-        <p:nvSpPr>
-          <p:cNvPr id="4" name="TextBox 3"/>
-          <p:cNvSpPr txBox="1"/>
-          <p:nvPr/>
-        </p:nvSpPr>
-        <p:spPr>
-          <a:xfrm>
-            <a:off x="457200" y="566928"/>
-            <a:ext cx="8961120" cy="320040"/>
-          </a:xfrm>
-          <a:prstGeom prst="rect">
-            <a:avLst/>
-          </a:prstGeom>
-          <a:noFill/>
-        </p:spPr>
-        <p:txBody>
-          <a:bodyPr wrap="none">
-            <a:spAutoFit/>
-          </a:bodyPr>
-          <a:lstStyle/>
-          <a:p>
-            <a:pPr algn="ctr">
-              <a:defRPr sz="1150" b="1">
-                <a:solidFill>
-                  <a:srgbClr val="0B2C5B"/>
-                </a:solidFill>
-              </a:defRPr>
-            </a:pPr>
-            <a:r>
-              <a:t>⚡ SATQUERY AI ARCHITECTURE: MULTIMODAL EARTH OBSERVATION &amp; INTELLIGENCE FLOW ⚡</a:t>
-            </a:r>
-          </a:p>
-        </p:txBody>
-      </p:sp>
-      <p:sp>
-        <p:nvSpPr>
-          <p:cNvPr id="5" name="Rounded Rectangle 4"/>
+          <p:cNvPr id="2" name="Oval 1"/>
           <p:cNvSpPr/>
           <p:nvPr/>
         </p:nvSpPr>
         <p:spPr>
           <a:xfrm>
-            <a:off x="457200" y="932688"/>
-            <a:ext cx="8961120" cy="932688"/>
-          </a:xfrm>
-          <a:prstGeom prst="roundRect">
+            <a:off x="457200" y="228600"/>
+            <a:ext cx="1645920" cy="777240"/>
+          </a:xfrm>
+          <a:prstGeom prst="ellipse">
             <a:avLst/>
           </a:prstGeom>
           <a:solidFill>
-            <a:srgbClr val="F2F7FF"/>
+            <a:srgbClr val="FFFFFF"/>
           </a:solidFill>
           <a:ln w="19050">
             <a:solidFill>
-              <a:srgbClr val="AACDF5"/>
+              <a:srgbClr val="800080"/>
             </a:solidFill>
           </a:ln>
         </p:spPr>
@@ -4540,7 +4431,135 @@
           <a:bodyPr rtlCol="0" anchor="ctr"/>
           <a:lstStyle/>
           <a:p>
-            <a:pPr algn="ctr"/>
+            <a:pPr algn="ctr">
+              <a:defRPr sz="1200" b="1">
+                <a:solidFill>
+                  <a:srgbClr val="212529"/>
+                </a:solidFill>
+              </a:defRPr>
+            </a:pPr>
+            <a:r>
+              <a:t>Your Team</a:t>
+            </a:r>
+          </a:p>
+          <a:p>
+            <a:pPr algn="ctr">
+              <a:defRPr sz="1200" b="1">
+                <a:solidFill>
+                  <a:srgbClr val="212529"/>
+                </a:solidFill>
+              </a:defRPr>
+            </a:pPr>
+            <a:r>
+              <a:t>Name</a:t>
+            </a:r>
+          </a:p>
+        </p:txBody>
+      </p:sp>
+      <p:sp>
+        <p:nvSpPr>
+          <p:cNvPr id="3" name="TextBox 2"/>
+          <p:cNvSpPr txBox="1"/>
+          <p:nvPr/>
+        </p:nvSpPr>
+        <p:spPr>
+          <a:xfrm>
+            <a:off x="2286000" y="228600"/>
+            <a:ext cx="7132320" cy="411480"/>
+          </a:xfrm>
+          <a:prstGeom prst="rect">
+            <a:avLst/>
+          </a:prstGeom>
+          <a:noFill/>
+        </p:spPr>
+        <p:txBody>
+          <a:bodyPr wrap="none">
+            <a:spAutoFit/>
+          </a:bodyPr>
+          <a:lstStyle/>
+          <a:p>
+            <a:pPr algn="ctr">
+              <a:defRPr sz="2600" b="1">
+                <a:solidFill>
+                  <a:srgbClr val="212529"/>
+                </a:solidFill>
+              </a:defRPr>
+            </a:pPr>
+            <a:r>
+              <a:t>TECHNICAL APPROACH</a:t>
+            </a:r>
+          </a:p>
+        </p:txBody>
+      </p:sp>
+      <p:sp>
+        <p:nvSpPr>
+          <p:cNvPr id="4" name="TextBox 3"/>
+          <p:cNvSpPr txBox="1"/>
+          <p:nvPr/>
+        </p:nvSpPr>
+        <p:spPr>
+          <a:xfrm>
+            <a:off x="9692640" y="182880"/>
+            <a:ext cx="2011680" cy="640080"/>
+          </a:xfrm>
+          <a:prstGeom prst="rect">
+            <a:avLst/>
+          </a:prstGeom>
+          <a:noFill/>
+        </p:spPr>
+        <p:txBody>
+          <a:bodyPr wrap="none">
+            <a:spAutoFit/>
+          </a:bodyPr>
+          <a:lstStyle/>
+          <a:p>
+            <a:pPr algn="r">
+              <a:defRPr sz="1300" b="1">
+                <a:solidFill>
+                  <a:srgbClr val="0B2C5B"/>
+                </a:solidFill>
+              </a:defRPr>
+            </a:pPr>
+            <a:r>
+              <a:t>SMART INDIA</a:t>
+            </a:r>
+            <a:br/>
+            <a:r>
+              <a:t>HACKATHON 2026</a:t>
+            </a:r>
+          </a:p>
+        </p:txBody>
+      </p:sp>
+      <p:sp>
+        <p:nvSpPr>
+          <p:cNvPr id="5" name="TextBox 4"/>
+          <p:cNvSpPr txBox="1"/>
+          <p:nvPr/>
+        </p:nvSpPr>
+        <p:spPr>
+          <a:xfrm>
+            <a:off x="457200" y="1005840"/>
+            <a:ext cx="11277295" cy="365760"/>
+          </a:xfrm>
+          <a:prstGeom prst="rect">
+            <a:avLst/>
+          </a:prstGeom>
+          <a:noFill/>
+        </p:spPr>
+        <p:txBody>
+          <a:bodyPr wrap="none">
+            <a:spAutoFit/>
+          </a:bodyPr>
+          <a:lstStyle/>
+          <a:p>
+            <a:r>
+              <a:rPr sz="1800" b="1" u="sng">
+                <a:solidFill>
+                  <a:srgbClr val="1877F2"/>
+                </a:solidFill>
+              </a:rPr>
+              <a:t>❖ Technical Approach (Technologies Used &amp; Methodology Flow)</a:t>
+            </a:r>
           </a:p>
         </p:txBody>
       </p:sp>
@@ -4552,17 +4571,19 @@
         </p:nvSpPr>
         <p:spPr>
           <a:xfrm>
-            <a:off x="2103120" y="960120"/>
-            <a:ext cx="5669280" cy="219456"/>
+            <a:off x="457200" y="1463040"/>
+            <a:ext cx="4297680" cy="4709160"/>
           </a:xfrm>
           <a:prstGeom prst="roundRect">
             <a:avLst/>
           </a:prstGeom>
           <a:solidFill>
-            <a:srgbClr val="1877F2"/>
+            <a:srgbClr val="F8FAFD"/>
           </a:solidFill>
-          <a:ln>
-            <a:noFill/>
+          <a:ln w="19050">
+            <a:solidFill>
+              <a:srgbClr val="D7E1EE"/>
+            </a:solidFill>
           </a:ln>
         </p:spPr>
         <p:style>
@@ -4583,29 +4604,216 @@
           <a:bodyPr rtlCol="0" anchor="ctr"/>
           <a:lstStyle/>
           <a:p>
-            <a:pPr algn="ctr">
-              <a:defRPr sz="919" b="1">
-                <a:solidFill>
-                  <a:srgbClr val="FFFFFF"/>
-                </a:solidFill>
-              </a:defRPr>
-            </a:pPr>
-            <a:r>
-              <a:t>1. USER ACCESS &amp; CLIENT LAYER   built with React 19, Vite, TypeScript &amp; Tailwind CSS</a:t>
-            </a:r>
-          </a:p>
-        </p:txBody>
-      </p:sp>
-      <p:sp>
-        <p:nvSpPr>
-          <p:cNvPr id="7" name="Rounded Rectangle 6"/>
+            <a:pPr algn="ctr"/>
+          </a:p>
+        </p:txBody>
+      </p:sp>
+      <p:sp>
+        <p:nvSpPr>
+          <p:cNvPr id="7" name="TextBox 6"/>
+          <p:cNvSpPr txBox="1"/>
+          <p:nvPr/>
+        </p:nvSpPr>
+        <p:spPr>
+          <a:xfrm>
+            <a:off x="594360" y="1554480"/>
+            <a:ext cx="4023360" cy="411480"/>
+          </a:xfrm>
+          <a:prstGeom prst="rect">
+            <a:avLst/>
+          </a:prstGeom>
+          <a:noFill/>
+        </p:spPr>
+        <p:txBody>
+          <a:bodyPr wrap="none">
+            <a:spAutoFit/>
+          </a:bodyPr>
+          <a:lstStyle/>
+          <a:p>
+            <a:pPr>
+              <a:defRPr sz="1500" b="1">
+                <a:solidFill>
+                  <a:srgbClr val="0B2C5B"/>
+                </a:solidFill>
+              </a:defRPr>
+            </a:pPr>
+            <a:r>
+              <a:t>• Technologies to be used:</a:t>
+            </a:r>
+          </a:p>
+        </p:txBody>
+      </p:sp>
+      <p:sp>
+        <p:nvSpPr>
+          <p:cNvPr id="8" name="TextBox 7"/>
+          <p:cNvSpPr txBox="1"/>
+          <p:nvPr/>
+        </p:nvSpPr>
+        <p:spPr>
+          <a:xfrm>
+            <a:off x="594360" y="1965960"/>
+            <a:ext cx="4023360" cy="4069080"/>
+          </a:xfrm>
+          <a:prstGeom prst="rect">
+            <a:avLst/>
+          </a:prstGeom>
+          <a:noFill/>
+        </p:spPr>
+        <p:txBody>
+          <a:bodyPr wrap="square">
+            <a:spAutoFit/>
+          </a:bodyPr>
+          <a:lstStyle/>
+          <a:p>
+            <a:pPr>
+              <a:spcAft>
+                <a:spcPts val="1000"/>
+              </a:spcAft>
+            </a:pPr>
+            <a:r>
+              <a:rPr b="1" sz="1080">
+                <a:solidFill>
+                  <a:srgbClr val="212529"/>
+                </a:solidFill>
+              </a:rPr>
+              <a:t>• Languages: </a:t>
+            </a:r>
+            <a:r>
+              <a:rPr b="0" sz="1019">
+                <a:solidFill>
+                  <a:srgbClr val="212529"/>
+                </a:solidFill>
+              </a:rPr>
+              <a:t>Python 3.11 (Backend AI/GIS), TypeScript (Frontend Web App).</a:t>
+            </a:r>
+          </a:p>
+          <a:p>
+            <a:pPr>
+              <a:spcAft>
+                <a:spcPts val="1000"/>
+              </a:spcAft>
+            </a:pPr>
+            <a:r>
+              <a:rPr b="1" sz="1080">
+                <a:solidFill>
+                  <a:srgbClr val="212529"/>
+                </a:solidFill>
+              </a:rPr>
+              <a:t>• Frontend GIS: </a:t>
+            </a:r>
+            <a:r>
+              <a:rPr b="0" sz="1019">
+                <a:solidFill>
+                  <a:srgbClr val="212529"/>
+                </a:solidFill>
+              </a:rPr>
+              <a:t>React 19, Vite, Tailwind CSS v4, MapLibre GL (@nextgis/ngw-map).</a:t>
+            </a:r>
+          </a:p>
+          <a:p>
+            <a:pPr>
+              <a:spcAft>
+                <a:spcPts val="1000"/>
+              </a:spcAft>
+            </a:pPr>
+            <a:r>
+              <a:rPr b="1" sz="1080">
+                <a:solidFill>
+                  <a:srgbClr val="212529"/>
+                </a:solidFill>
+              </a:rPr>
+              <a:t>• Backend &amp; API: </a:t>
+            </a:r>
+            <a:r>
+              <a:rPr b="0" sz="1019">
+                <a:solidFill>
+                  <a:srgbClr val="212529"/>
+                </a:solidFill>
+              </a:rPr>
+              <a:t>FastAPI, Uvicorn ASGI, Pydantic v2, RESTFUL API Server.</a:t>
+            </a:r>
+          </a:p>
+          <a:p>
+            <a:pPr>
+              <a:spcAft>
+                <a:spcPts val="1000"/>
+              </a:spcAft>
+            </a:pPr>
+            <a:r>
+              <a:rPr b="1" sz="1080">
+                <a:solidFill>
+                  <a:srgbClr val="212529"/>
+                </a:solidFill>
+              </a:rPr>
+              <a:t>• AI / Vision-Language: </a:t>
+            </a:r>
+            <a:r>
+              <a:rPr b="0" sz="1019">
+                <a:solidFill>
+                  <a:srgbClr val="212529"/>
+                </a:solidFill>
+              </a:rPr>
+              <a:t>PyTorch, Hugging Face Transformers (Fine-tuned BLIP VQA &amp; Grounder).</a:t>
+            </a:r>
+          </a:p>
+          <a:p>
+            <a:pPr>
+              <a:spcAft>
+                <a:spcPts val="1000"/>
+              </a:spcAft>
+            </a:pPr>
+            <a:r>
+              <a:rPr b="1" sz="1080">
+                <a:solidFill>
+                  <a:srgbClr val="212529"/>
+                </a:solidFill>
+              </a:rPr>
+              <a:t>• Geospatial Engine: </a:t>
+            </a:r>
+            <a:r>
+              <a:rPr b="0" sz="1019">
+                <a:solidFill>
+                  <a:srgbClr val="212529"/>
+                </a:solidFill>
+              </a:rPr>
+              <a:t>GDAL, Rasterio, NumPy (GeoTIFF, NetCDF, CRS reprojection, band math).</a:t>
+            </a:r>
+          </a:p>
+          <a:p>
+            <a:pPr>
+              <a:spcAft>
+                <a:spcPts val="1000"/>
+              </a:spcAft>
+            </a:pPr>
+            <a:r>
+              <a:rPr b="1" sz="1080">
+                <a:solidFill>
+                  <a:srgbClr val="212529"/>
+                </a:solidFill>
+              </a:rPr>
+              <a:t>• Hardware &amp; Portability: </a:t>
+            </a:r>
+            <a:r>
+              <a:rPr b="0" sz="1019">
+                <a:solidFill>
+                  <a:srgbClr val="212529"/>
+                </a:solidFill>
+              </a:rPr>
+              <a:t>Optimized CPU inference (&lt;300ms), optional CUDA GPU acceleration.</a:t>
+            </a:r>
+          </a:p>
+        </p:txBody>
+      </p:sp>
+      <p:sp>
+        <p:nvSpPr>
+          <p:cNvPr id="9" name="Rounded Rectangle 8"/>
           <p:cNvSpPr/>
           <p:nvPr/>
         </p:nvSpPr>
         <p:spPr>
           <a:xfrm>
-            <a:off x="548640" y="1216152"/>
-            <a:ext cx="1682496" cy="594360"/>
+            <a:off x="4937760" y="1463040"/>
+            <a:ext cx="6766560" cy="4709160"/>
           </a:xfrm>
           <a:prstGeom prst="roundRect">
             <a:avLst/>
@@ -4613,9 +4821,9 @@
           <a:solidFill>
             <a:srgbClr val="FFFFFF"/>
           </a:solidFill>
-          <a:ln w="12700">
+          <a:ln w="19050">
             <a:solidFill>
-              <a:srgbClr val="C8DCF5"/>
+              <a:srgbClr val="D7E1EE"/>
             </a:solidFill>
           </a:ln>
         </p:spPr>
@@ -4634,328 +4842,23 @@
           </a:fontRef>
         </p:style>
         <p:txBody>
-          <a:bodyPr rtlCol="0" anchor="ctr" wrap="square" tIns="36576" bIns="36576" lIns="54864" rIns="54864"/>
-          <a:lstStyle/>
-          <a:p>
-            <a:pPr algn="ctr">
-              <a:defRPr sz="880" b="1">
-                <a:solidFill>
-                  <a:srgbClr val="0B2C5B"/>
-                </a:solidFill>
-              </a:defRPr>
-            </a:pPr>
-            <a:r>
-              <a:t>🚨 Disaster Responders</a:t>
-            </a:r>
-          </a:p>
-          <a:p>
-            <a:pPr algn="ctr">
-              <a:defRPr sz="780">
-                <a:solidFill>
-                  <a:srgbClr val="212529"/>
-                </a:solidFill>
-              </a:defRPr>
-            </a:pPr>
-            <a:r>
-              <a:t>NDRF / SDMA View</a:t>
-            </a:r>
-            <a:br/>
-            <a:r>
-              <a:t>(Flood &amp; Crisis Rescue)</a:t>
-            </a:r>
-          </a:p>
-        </p:txBody>
-      </p:sp>
-      <p:sp>
-        <p:nvSpPr>
-          <p:cNvPr id="8" name="Rounded Rectangle 7"/>
-          <p:cNvSpPr/>
-          <p:nvPr/>
-        </p:nvSpPr>
-        <p:spPr>
-          <a:xfrm>
-            <a:off x="2304288" y="1216152"/>
-            <a:ext cx="1682496" cy="594360"/>
-          </a:xfrm>
-          <a:prstGeom prst="roundRect">
-            <a:avLst/>
-          </a:prstGeom>
-          <a:solidFill>
-            <a:srgbClr val="FFFFFF"/>
-          </a:solidFill>
-          <a:ln w="12700">
-            <a:solidFill>
-              <a:srgbClr val="C8DCF5"/>
-            </a:solidFill>
-          </a:ln>
-        </p:spPr>
-        <p:style>
-          <a:lnRef idx="1">
-            <a:schemeClr val="accent1"/>
-          </a:lnRef>
-          <a:fillRef idx="3">
-            <a:schemeClr val="accent1"/>
-          </a:fillRef>
-          <a:effectRef idx="2">
-            <a:schemeClr val="accent1"/>
-          </a:effectRef>
-          <a:fontRef idx="minor">
-            <a:schemeClr val="lt1"/>
-          </a:fontRef>
-        </p:style>
-        <p:txBody>
-          <a:bodyPr rtlCol="0" anchor="ctr" wrap="square" tIns="36576" bIns="36576" lIns="54864" rIns="54864"/>
-          <a:lstStyle/>
-          <a:p>
-            <a:pPr algn="ctr">
-              <a:defRPr sz="880" b="1">
-                <a:solidFill>
-                  <a:srgbClr val="0B2C5B"/>
-                </a:solidFill>
-              </a:defRPr>
-            </a:pPr>
-            <a:r>
-              <a:t>🌊 Water Authorities</a:t>
-            </a:r>
-          </a:p>
-          <a:p>
-            <a:pPr algn="ctr">
-              <a:defRPr sz="780">
-                <a:solidFill>
-                  <a:srgbClr val="212529"/>
-                </a:solidFill>
-              </a:defRPr>
-            </a:pPr>
-            <a:r>
-              <a:t>Jal Shakti Portal</a:t>
-            </a:r>
-            <a:br/>
-            <a:r>
-              <a:t>(Reservoir &amp; Hydrology)</a:t>
-            </a:r>
-          </a:p>
-        </p:txBody>
-      </p:sp>
-      <p:sp>
-        <p:nvSpPr>
-          <p:cNvPr id="9" name="Rounded Rectangle 8"/>
-          <p:cNvSpPr/>
-          <p:nvPr/>
-        </p:nvSpPr>
-        <p:spPr>
-          <a:xfrm>
-            <a:off x="4059936" y="1216152"/>
-            <a:ext cx="1682496" cy="594360"/>
-          </a:xfrm>
-          <a:prstGeom prst="roundRect">
-            <a:avLst/>
-          </a:prstGeom>
-          <a:solidFill>
-            <a:srgbClr val="FFFFFF"/>
-          </a:solidFill>
-          <a:ln w="12700">
-            <a:solidFill>
-              <a:srgbClr val="C8DCF5"/>
-            </a:solidFill>
-          </a:ln>
-        </p:spPr>
-        <p:style>
-          <a:lnRef idx="1">
-            <a:schemeClr val="accent1"/>
-          </a:lnRef>
-          <a:fillRef idx="3">
-            <a:schemeClr val="accent1"/>
-          </a:fillRef>
-          <a:effectRef idx="2">
-            <a:schemeClr val="accent1"/>
-          </a:effectRef>
-          <a:fontRef idx="minor">
-            <a:schemeClr val="lt1"/>
-          </a:fontRef>
-        </p:style>
-        <p:txBody>
-          <a:bodyPr rtlCol="0" anchor="ctr" wrap="square" tIns="36576" bIns="36576" lIns="54864" rIns="54864"/>
-          <a:lstStyle/>
-          <a:p>
-            <a:pPr algn="ctr">
-              <a:defRPr sz="880" b="1">
-                <a:solidFill>
-                  <a:srgbClr val="0B2C5B"/>
-                </a:solidFill>
-              </a:defRPr>
-            </a:pPr>
-            <a:r>
-              <a:t>🏙️ Urban Planners</a:t>
-            </a:r>
-          </a:p>
-          <a:p>
-            <a:pPr algn="ctr">
-              <a:defRPr sz="780">
-                <a:solidFill>
-                  <a:srgbClr val="212529"/>
-                </a:solidFill>
-              </a:defRPr>
-            </a:pPr>
-            <a:r>
-              <a:t>Municipal Dashboard</a:t>
-            </a:r>
-            <a:br/>
-            <a:r>
-              <a:t>(Sprawl &amp; Encroachment)</a:t>
-            </a:r>
-          </a:p>
-        </p:txBody>
-      </p:sp>
-      <p:sp>
-        <p:nvSpPr>
-          <p:cNvPr id="10" name="Rounded Rectangle 9"/>
-          <p:cNvSpPr/>
-          <p:nvPr/>
-        </p:nvSpPr>
-        <p:spPr>
-          <a:xfrm>
-            <a:off x="5815584" y="1216152"/>
-            <a:ext cx="1682496" cy="594360"/>
-          </a:xfrm>
-          <a:prstGeom prst="roundRect">
-            <a:avLst/>
-          </a:prstGeom>
-          <a:solidFill>
-            <a:srgbClr val="FFFFFF"/>
-          </a:solidFill>
-          <a:ln w="12700">
-            <a:solidFill>
-              <a:srgbClr val="C8DCF5"/>
-            </a:solidFill>
-          </a:ln>
-        </p:spPr>
-        <p:style>
-          <a:lnRef idx="1">
-            <a:schemeClr val="accent1"/>
-          </a:lnRef>
-          <a:fillRef idx="3">
-            <a:schemeClr val="accent1"/>
-          </a:fillRef>
-          <a:effectRef idx="2">
-            <a:schemeClr val="accent1"/>
-          </a:effectRef>
-          <a:fontRef idx="minor">
-            <a:schemeClr val="lt1"/>
-          </a:fontRef>
-        </p:style>
-        <p:txBody>
-          <a:bodyPr rtlCol="0" anchor="ctr" wrap="square" tIns="36576" bIns="36576" lIns="54864" rIns="54864"/>
-          <a:lstStyle/>
-          <a:p>
-            <a:pPr algn="ctr">
-              <a:defRPr sz="880" b="1">
-                <a:solidFill>
-                  <a:srgbClr val="0B2C5B"/>
-                </a:solidFill>
-              </a:defRPr>
-            </a:pPr>
-            <a:r>
-              <a:t>🌾 Field Officers</a:t>
-            </a:r>
-          </a:p>
-          <a:p>
-            <a:pPr algn="ctr">
-              <a:defRPr sz="780">
-                <a:solidFill>
-                  <a:srgbClr val="212529"/>
-                </a:solidFill>
-              </a:defRPr>
-            </a:pPr>
-            <a:r>
-              <a:t>Mobile Agritech</a:t>
-            </a:r>
-            <a:br/>
-            <a:r>
-              <a:t>(Crop Canopy &amp; Drought)</a:t>
-            </a:r>
-          </a:p>
-        </p:txBody>
-      </p:sp>
-      <p:sp>
-        <p:nvSpPr>
-          <p:cNvPr id="11" name="Rounded Rectangle 10"/>
-          <p:cNvSpPr/>
-          <p:nvPr/>
-        </p:nvSpPr>
-        <p:spPr>
-          <a:xfrm>
-            <a:off x="7571232" y="1216152"/>
-            <a:ext cx="1682496" cy="594360"/>
-          </a:xfrm>
-          <a:prstGeom prst="roundRect">
-            <a:avLst/>
-          </a:prstGeom>
-          <a:solidFill>
-            <a:srgbClr val="FFFFFF"/>
-          </a:solidFill>
-          <a:ln w="12700">
-            <a:solidFill>
-              <a:srgbClr val="C8DCF5"/>
-            </a:solidFill>
-          </a:ln>
-        </p:spPr>
-        <p:style>
-          <a:lnRef idx="1">
-            <a:schemeClr val="accent1"/>
-          </a:lnRef>
-          <a:fillRef idx="3">
-            <a:schemeClr val="accent1"/>
-          </a:fillRef>
-          <a:effectRef idx="2">
-            <a:schemeClr val="accent1"/>
-          </a:effectRef>
-          <a:fontRef idx="minor">
-            <a:schemeClr val="lt1"/>
-          </a:fontRef>
-        </p:style>
-        <p:txBody>
-          <a:bodyPr rtlCol="0" anchor="ctr" wrap="square" tIns="36576" bIns="36576" lIns="54864" rIns="54864"/>
-          <a:lstStyle/>
-          <a:p>
-            <a:pPr algn="ctr">
-              <a:defRPr sz="880" b="1">
-                <a:solidFill>
-                  <a:srgbClr val="0B2C5B"/>
-                </a:solidFill>
-              </a:defRPr>
-            </a:pPr>
-            <a:r>
-              <a:t>🛡️ Defense &amp; Maritime</a:t>
-            </a:r>
-          </a:p>
-          <a:p>
-            <a:pPr algn="ctr">
-              <a:defRPr sz="780">
-                <a:solidFill>
-                  <a:srgbClr val="212529"/>
-                </a:solidFill>
-              </a:defRPr>
-            </a:pPr>
-            <a:r>
-              <a:t>ISRO / SAC Systems</a:t>
-            </a:r>
-            <a:br/>
-            <a:r>
-              <a:t>(SAR Coastal Security)</a:t>
-            </a:r>
-          </a:p>
-        </p:txBody>
-      </p:sp>
-      <p:sp>
-        <p:nvSpPr>
-          <p:cNvPr id="12" name="TextBox 11"/>
+          <a:bodyPr rtlCol="0" anchor="ctr"/>
+          <a:lstStyle/>
+          <a:p>
+            <a:pPr algn="ctr"/>
+          </a:p>
+        </p:txBody>
+      </p:sp>
+      <p:sp>
+        <p:nvSpPr>
+          <p:cNvPr id="10" name="TextBox 9"/>
           <p:cNvSpPr txBox="1"/>
           <p:nvPr/>
         </p:nvSpPr>
         <p:spPr>
           <a:xfrm>
-            <a:off x="4480560" y="1865376"/>
-            <a:ext cx="914400" cy="182880"/>
+            <a:off x="5074920" y="1554480"/>
+            <a:ext cx="6492240" cy="411480"/>
           </a:xfrm>
           <a:prstGeom prst="rect">
             <a:avLst/>
@@ -4968,74 +4871,29 @@
           </a:bodyPr>
           <a:lstStyle/>
           <a:p>
-            <a:pPr algn="ctr">
-              <a:defRPr sz="800" b="1">
-                <a:solidFill>
-                  <a:srgbClr val="1877F2"/>
-                </a:solidFill>
-              </a:defRPr>
-            </a:pPr>
-            <a:r>
-              <a:t>▼  ▼  ▼</a:t>
-            </a:r>
-          </a:p>
-        </p:txBody>
-      </p:sp>
-      <p:sp>
-        <p:nvSpPr>
-          <p:cNvPr id="13" name="Rounded Rectangle 12"/>
+            <a:pPr>
+              <a:defRPr sz="1500" b="1">
+                <a:solidFill>
+                  <a:srgbClr val="0B2C5B"/>
+                </a:solidFill>
+              </a:defRPr>
+            </a:pPr>
+            <a:r>
+              <a:t>• Methodology and process for implementation:</a:t>
+            </a:r>
+          </a:p>
+        </p:txBody>
+      </p:sp>
+      <p:sp>
+        <p:nvSpPr>
+          <p:cNvPr id="11" name="Rounded Rectangle 10"/>
           <p:cNvSpPr/>
           <p:nvPr/>
         </p:nvSpPr>
         <p:spPr>
           <a:xfrm>
-            <a:off x="457200" y="2048256"/>
-            <a:ext cx="8961120" cy="932688"/>
-          </a:xfrm>
-          <a:prstGeom prst="roundRect">
-            <a:avLst/>
-          </a:prstGeom>
-          <a:solidFill>
-            <a:srgbClr val="F5F8FC"/>
-          </a:solidFill>
-          <a:ln w="19050">
-            <a:solidFill>
-              <a:srgbClr val="A0BEE6"/>
-            </a:solidFill>
-          </a:ln>
-        </p:spPr>
-        <p:style>
-          <a:lnRef idx="1">
-            <a:schemeClr val="accent1"/>
-          </a:lnRef>
-          <a:fillRef idx="3">
-            <a:schemeClr val="accent1"/>
-          </a:fillRef>
-          <a:effectRef idx="2">
-            <a:schemeClr val="accent1"/>
-          </a:effectRef>
-          <a:fontRef idx="minor">
-            <a:schemeClr val="lt1"/>
-          </a:fontRef>
-        </p:style>
-        <p:txBody>
-          <a:bodyPr rtlCol="0" anchor="ctr"/>
-          <a:lstStyle/>
-          <a:p>
-            <a:pPr algn="ctr"/>
-          </a:p>
-        </p:txBody>
-      </p:sp>
-      <p:sp>
-        <p:nvSpPr>
-          <p:cNvPr id="14" name="Rounded Rectangle 13"/>
-          <p:cNvSpPr/>
-          <p:nvPr/>
-        </p:nvSpPr>
-        <p:spPr>
-          <a:xfrm>
-            <a:off x="2377440" y="2075688"/>
-            <a:ext cx="5120640" cy="219456"/>
+            <a:off x="5074920" y="1965960"/>
+            <a:ext cx="6492240" cy="274320"/>
           </a:xfrm>
           <a:prstGeom prst="roundRect">
             <a:avLst/>
@@ -5073,31 +4931,31 @@
               </a:defRPr>
             </a:pPr>
             <a:r>
-              <a:t>2. API GATEWAY &amp; CORE GEOSPATIAL BACKEND (FastAPI / Uvicorn)</a:t>
-            </a:r>
-          </a:p>
-        </p:txBody>
-      </p:sp>
-      <p:sp>
-        <p:nvSpPr>
-          <p:cNvPr id="15" name="Rounded Rectangle 14"/>
+              <a:t>SATQUERY AI: MULTIMODAL EARTH OBSERVATION ARCHITECTURE</a:t>
+            </a:r>
+          </a:p>
+        </p:txBody>
+      </p:sp>
+      <p:sp>
+        <p:nvSpPr>
+          <p:cNvPr id="12" name="Rounded Rectangle 11"/>
           <p:cNvSpPr/>
           <p:nvPr/>
         </p:nvSpPr>
         <p:spPr>
           <a:xfrm>
-            <a:off x="548640" y="2331720"/>
-            <a:ext cx="1463040" cy="594360"/>
+            <a:off x="5074920" y="2331720"/>
+            <a:ext cx="6492240" cy="621792"/>
           </a:xfrm>
           <a:prstGeom prst="roundRect">
             <a:avLst/>
           </a:prstGeom>
           <a:solidFill>
-            <a:srgbClr val="FFFFFF"/>
+            <a:srgbClr val="F2F7FF"/>
           </a:solidFill>
           <a:ln w="12700">
             <a:solidFill>
-              <a:srgbClr val="BED2EB"/>
+              <a:srgbClr val="AACDF5"/>
             </a:solidFill>
           </a:ln>
         </p:spPr>
@@ -5116,58 +4974,89 @@
           </a:fontRef>
         </p:style>
         <p:txBody>
-          <a:bodyPr rtlCol="0" anchor="ctr" wrap="square" tIns="36576" bIns="36576" lIns="45720" rIns="45720"/>
+          <a:bodyPr rtlCol="0" anchor="ctr" wrap="square" tIns="36576"/>
           <a:lstStyle/>
           <a:p>
             <a:pPr algn="ctr">
               <a:defRPr sz="850" b="1">
                 <a:solidFill>
-                  <a:srgbClr val="0B2C5B"/>
-                </a:solidFill>
-              </a:defRPr>
-            </a:pPr>
-            <a:r>
-              <a:t>🔒 RBAC &amp; Query Guard</a:t>
-            </a:r>
-          </a:p>
+                  <a:srgbClr val="1877F2"/>
+                </a:solidFill>
+              </a:defRPr>
+            </a:pPr>
+            <a:r>
+              <a:t>1. USER ACCESS &amp; CLIENT LAYER (React 19 + MapLibre GL GIS)</a:t>
+            </a:r>
+          </a:p>
+          <a:p>
+            <a:pPr>
+              <a:defRPr sz="780">
+                <a:solidFill>
+                  <a:srgbClr val="212529"/>
+                </a:solidFill>
+              </a:defRPr>
+            </a:pPr>
+            <a:r>
+              <a:t>[🚨 NDRF Disaster Portal] [🌊 Jal Shakti Hydrology] [🏙️ Municipal Urban Sprawl] [🌾 Field Agritech Mobile]</a:t>
+            </a:r>
+          </a:p>
+        </p:txBody>
+      </p:sp>
+      <p:sp>
+        <p:nvSpPr>
+          <p:cNvPr id="13" name="TextBox 12"/>
+          <p:cNvSpPr txBox="1"/>
+          <p:nvPr/>
+        </p:nvSpPr>
+        <p:spPr>
+          <a:xfrm>
+            <a:off x="8046720" y="2944368"/>
+            <a:ext cx="548640" cy="164592"/>
+          </a:xfrm>
+          <a:prstGeom prst="rect">
+            <a:avLst/>
+          </a:prstGeom>
+          <a:noFill/>
+        </p:spPr>
+        <p:txBody>
+          <a:bodyPr wrap="none">
+            <a:spAutoFit/>
+          </a:bodyPr>
+          <a:lstStyle/>
           <a:p>
             <a:pPr algn="ctr">
-              <a:defRPr sz="750">
-                <a:solidFill>
-                  <a:srgbClr val="212529"/>
-                </a:solidFill>
-              </a:defRPr>
-            </a:pPr>
-            <a:r>
-              <a:t>Sanitizes inputs,</a:t>
-            </a:r>
-            <a:br/>
-            <a:r>
-              <a:t>enforces CRS rules</a:t>
-            </a:r>
-          </a:p>
-        </p:txBody>
-      </p:sp>
-      <p:sp>
-        <p:nvSpPr>
-          <p:cNvPr id="16" name="Rounded Rectangle 15"/>
+              <a:defRPr sz="800">
+                <a:solidFill>
+                  <a:srgbClr val="1877F2"/>
+                </a:solidFill>
+              </a:defRPr>
+            </a:pPr>
+            <a:r>
+              <a:t>▼</a:t>
+            </a:r>
+          </a:p>
+        </p:txBody>
+      </p:sp>
+      <p:sp>
+        <p:nvSpPr>
+          <p:cNvPr id="14" name="Rounded Rectangle 13"/>
           <p:cNvSpPr/>
           <p:nvPr/>
         </p:nvSpPr>
         <p:spPr>
           <a:xfrm>
-            <a:off x="2084832" y="2331720"/>
-            <a:ext cx="1463040" cy="594360"/>
+            <a:off x="5074920" y="3108960"/>
+            <a:ext cx="6492240" cy="621792"/>
           </a:xfrm>
           <a:prstGeom prst="roundRect">
             <a:avLst/>
           </a:prstGeom>
           <a:solidFill>
-            <a:srgbClr val="FFFFFF"/>
+            <a:srgbClr val="F5F8FC"/>
           </a:solidFill>
           <a:ln w="12700">
             <a:solidFill>
-              <a:srgbClr val="BED2EB"/>
+              <a:srgbClr val="A0BEE6"/>
             </a:solidFill>
           </a:ln>
         </p:spPr>
@@ -5186,258 +5075,44 @@
           </a:fontRef>
         </p:style>
         <p:txBody>
-          <a:bodyPr rtlCol="0" anchor="ctr" wrap="square" tIns="36576" bIns="36576" lIns="45720" rIns="45720"/>
+          <a:bodyPr rtlCol="0" anchor="ctr" wrap="square" tIns="36576"/>
           <a:lstStyle/>
           <a:p>
             <a:pPr algn="ctr">
               <a:defRPr sz="850" b="1">
                 <a:solidFill>
-                  <a:srgbClr val="0B2C5B"/>
-                </a:solidFill>
-              </a:defRPr>
-            </a:pPr>
-            <a:r>
-              <a:t>🔄 Raster Ingestion</a:t>
-            </a:r>
-          </a:p>
-          <a:p>
-            <a:pPr algn="ctr">
-              <a:defRPr sz="750">
-                <a:solidFill>
-                  <a:srgbClr val="212529"/>
-                </a:solidFill>
-              </a:defRPr>
-            </a:pPr>
-            <a:r>
-              <a:t>Auto-reprojects CRS,</a:t>
-            </a:r>
-            <a:br/>
-            <a:r>
-              <a:t>calibrates bands (GDAL)</a:t>
-            </a:r>
-          </a:p>
-        </p:txBody>
-      </p:sp>
-      <p:sp>
-        <p:nvSpPr>
-          <p:cNvPr id="17" name="Rounded Rectangle 16"/>
-          <p:cNvSpPr/>
-          <p:nvPr/>
-        </p:nvSpPr>
-        <p:spPr>
-          <a:xfrm>
-            <a:off x="3621024" y="2331720"/>
-            <a:ext cx="1463040" cy="594360"/>
-          </a:xfrm>
-          <a:prstGeom prst="roundRect">
-            <a:avLst/>
-          </a:prstGeom>
-          <a:solidFill>
-            <a:srgbClr val="FFFFFF"/>
-          </a:solidFill>
-          <a:ln w="12700">
-            <a:solidFill>
-              <a:srgbClr val="BED2EB"/>
-            </a:solidFill>
-          </a:ln>
-        </p:spPr>
-        <p:style>
-          <a:lnRef idx="1">
-            <a:schemeClr val="accent1"/>
-          </a:lnRef>
-          <a:fillRef idx="3">
-            <a:schemeClr val="accent1"/>
-          </a:fillRef>
-          <a:effectRef idx="2">
-            <a:schemeClr val="accent1"/>
-          </a:effectRef>
-          <a:fontRef idx="minor">
-            <a:schemeClr val="lt1"/>
-          </a:fontRef>
-        </p:style>
-        <p:txBody>
-          <a:bodyPr rtlCol="0" anchor="ctr" wrap="square" tIns="36576" bIns="36576" lIns="45720" rIns="45720"/>
-          <a:lstStyle/>
-          <a:p>
-            <a:pPr algn="ctr">
-              <a:defRPr sz="850" b="1">
-                <a:solidFill>
-                  <a:srgbClr val="0B2C5B"/>
-                </a:solidFill>
-              </a:defRPr>
-            </a:pPr>
-            <a:r>
-              <a:t>⚙️ Agent Orchestrator</a:t>
-            </a:r>
-          </a:p>
-          <a:p>
-            <a:pPr algn="ctr">
-              <a:defRPr sz="750">
-                <a:solidFill>
-                  <a:srgbClr val="212529"/>
-                </a:solidFill>
-              </a:defRPr>
-            </a:pPr>
-            <a:r>
-              <a:t>Intent parsing &amp;</a:t>
-            </a:r>
-            <a:br/>
-            <a:r>
-              <a:t>model routing registry</a:t>
-            </a:r>
-          </a:p>
-        </p:txBody>
-      </p:sp>
-      <p:sp>
-        <p:nvSpPr>
-          <p:cNvPr id="18" name="Rounded Rectangle 17"/>
-          <p:cNvSpPr/>
-          <p:nvPr/>
-        </p:nvSpPr>
-        <p:spPr>
-          <a:xfrm>
-            <a:off x="5157216" y="2331720"/>
-            <a:ext cx="1463040" cy="594360"/>
-          </a:xfrm>
-          <a:prstGeom prst="roundRect">
-            <a:avLst/>
-          </a:prstGeom>
-          <a:solidFill>
-            <a:srgbClr val="FFFFFF"/>
-          </a:solidFill>
-          <a:ln w="12700">
-            <a:solidFill>
-              <a:srgbClr val="BED2EB"/>
-            </a:solidFill>
-          </a:ln>
-        </p:spPr>
-        <p:style>
-          <a:lnRef idx="1">
-            <a:schemeClr val="accent1"/>
-          </a:lnRef>
-          <a:fillRef idx="3">
-            <a:schemeClr val="accent1"/>
-          </a:fillRef>
-          <a:effectRef idx="2">
-            <a:schemeClr val="accent1"/>
-          </a:effectRef>
-          <a:fontRef idx="minor">
-            <a:schemeClr val="lt1"/>
-          </a:fontRef>
-        </p:style>
-        <p:txBody>
-          <a:bodyPr rtlCol="0" anchor="ctr" wrap="square" tIns="36576" bIns="36576" lIns="45720" rIns="45720"/>
-          <a:lstStyle/>
-          <a:p>
-            <a:pPr algn="ctr">
-              <a:defRPr sz="850" b="1">
-                <a:solidFill>
-                  <a:srgbClr val="0B2C5B"/>
-                </a:solidFill>
-              </a:defRPr>
-            </a:pPr>
-            <a:r>
-              <a:t>&lt;/&gt; REST API Flow</a:t>
-            </a:r>
-          </a:p>
-          <a:p>
-            <a:pPr algn="ctr">
-              <a:defRPr sz="750">
-                <a:solidFill>
-                  <a:srgbClr val="212529"/>
-                </a:solidFill>
-              </a:defRPr>
-            </a:pPr>
-            <a:r>
-              <a:t>FastAPI endpoints &amp;</a:t>
-            </a:r>
-            <a:br/>
-            <a:r>
-              <a:t>GeoJSON raster streams</a:t>
-            </a:r>
-          </a:p>
-        </p:txBody>
-      </p:sp>
-      <p:sp>
-        <p:nvSpPr>
-          <p:cNvPr id="19" name="Rounded Rectangle 18"/>
-          <p:cNvSpPr/>
-          <p:nvPr/>
-        </p:nvSpPr>
-        <p:spPr>
-          <a:xfrm>
-            <a:off x="6720840" y="2331720"/>
-            <a:ext cx="2606040" cy="594360"/>
-          </a:xfrm>
-          <a:prstGeom prst="roundRect">
-            <a:avLst/>
-          </a:prstGeom>
-          <a:solidFill>
-            <a:srgbClr val="EEF4FF"/>
-          </a:solidFill>
-          <a:ln w="15240">
-            <a:solidFill>
-              <a:srgbClr val="1877F2"/>
-            </a:solidFill>
-          </a:ln>
-        </p:spPr>
-        <p:style>
-          <a:lnRef idx="1">
-            <a:schemeClr val="accent1"/>
-          </a:lnRef>
-          <a:fillRef idx="3">
-            <a:schemeClr val="accent1"/>
-          </a:fillRef>
-          <a:effectRef idx="2">
-            <a:schemeClr val="accent1"/>
-          </a:effectRef>
-          <a:fontRef idx="minor">
-            <a:schemeClr val="lt1"/>
-          </a:fontRef>
-        </p:style>
-        <p:txBody>
-          <a:bodyPr rtlCol="0" anchor="ctr" wrap="square" tIns="27432" bIns="27432"/>
-          <a:lstStyle/>
-          <a:p>
-            <a:pPr algn="ctr">
-              <a:defRPr sz="850" b="1">
-                <a:solidFill>
                   <a:srgbClr val="0F3C82"/>
                 </a:solidFill>
               </a:defRPr>
             </a:pPr>
             <a:r>
-              <a:t>📊 ExecutionTracker (Automated Delivery)</a:t>
-            </a:r>
-          </a:p>
-          <a:p>
-            <a:pPr algn="ctr">
-              <a:defRPr sz="750">
-                <a:solidFill>
-                  <a:srgbClr val="212529"/>
-                </a:solidFill>
-              </a:defRPr>
-            </a:pPr>
-            <a:r>
-              <a:t>• Exportable JSON Audit  • SHA-256 Hashes</a:t>
-            </a:r>
-            <a:br/>
-            <a:r>
-              <a:t>• &lt;300ms CPU Profiling  • Mask GeoJSON</a:t>
-            </a:r>
-          </a:p>
-        </p:txBody>
-      </p:sp>
-      <p:sp>
-        <p:nvSpPr>
-          <p:cNvPr id="20" name="TextBox 19"/>
+              <a:t>2. API GATEWAY &amp; CORE GEOSPATIAL BACKEND (FastAPI / Uvicorn)</a:t>
+            </a:r>
+          </a:p>
+          <a:p>
+            <a:pPr>
+              <a:defRPr sz="780">
+                <a:solidFill>
+                  <a:srgbClr val="212529"/>
+                </a:solidFill>
+              </a:defRPr>
+            </a:pPr>
+            <a:r>
+              <a:t>[🔒 RBAC &amp; Query Guard] [🔄 GDAL Dynamic Ingestor] [⚙️ Intent Orchestrator] [📊 ExecutionTracker Audit]</a:t>
+            </a:r>
+          </a:p>
+        </p:txBody>
+      </p:sp>
+      <p:sp>
+        <p:nvSpPr>
+          <p:cNvPr id="15" name="TextBox 14"/>
           <p:cNvSpPr txBox="1"/>
           <p:nvPr/>
         </p:nvSpPr>
         <p:spPr>
           <a:xfrm>
-            <a:off x="4480560" y="2980944"/>
-            <a:ext cx="914400" cy="182880"/>
+            <a:off x="8046720" y="3721608"/>
+            <a:ext cx="548640" cy="164592"/>
           </a:xfrm>
           <a:prstGeom prst="rect">
             <a:avLst/>
@@ -5451,28 +5126,28 @@
           <a:lstStyle/>
           <a:p>
             <a:pPr algn="ctr">
-              <a:defRPr sz="800" b="1">
+              <a:defRPr sz="800">
                 <a:solidFill>
                   <a:srgbClr val="1877F2"/>
                 </a:solidFill>
               </a:defRPr>
             </a:pPr>
             <a:r>
-              <a:t>▼  ▼  ▼</a:t>
-            </a:r>
-          </a:p>
-        </p:txBody>
-      </p:sp>
-      <p:sp>
-        <p:nvSpPr>
-          <p:cNvPr id="21" name="Rounded Rectangle 20"/>
+              <a:t>▼</a:t>
+            </a:r>
+          </a:p>
+        </p:txBody>
+      </p:sp>
+      <p:sp>
+        <p:nvSpPr>
+          <p:cNvPr id="16" name="Rounded Rectangle 15"/>
           <p:cNvSpPr/>
           <p:nvPr/>
         </p:nvSpPr>
         <p:spPr>
           <a:xfrm>
-            <a:off x="457200" y="3163824"/>
-            <a:ext cx="8961120" cy="932688"/>
+            <a:off x="5074920" y="3886200"/>
+            <a:ext cx="6492240" cy="658368"/>
           </a:xfrm>
           <a:prstGeom prst="roundRect">
             <a:avLst/>
@@ -5480,7 +5155,7 @@
           <a:solidFill>
             <a:srgbClr val="F8F5FF"/>
           </a:solidFill>
-          <a:ln w="19050">
+          <a:ln w="12700">
             <a:solidFill>
               <a:srgbClr val="D2BEF5"/>
             </a:solidFill>
@@ -5501,56 +5176,13 @@
           </a:fontRef>
         </p:style>
         <p:txBody>
-          <a:bodyPr rtlCol="0" anchor="ctr"/>
-          <a:lstStyle/>
-          <a:p>
-            <a:pPr algn="ctr"/>
-          </a:p>
-        </p:txBody>
-      </p:sp>
-      <p:sp>
-        <p:nvSpPr>
-          <p:cNvPr id="22" name="Rounded Rectangle 21"/>
-          <p:cNvSpPr/>
-          <p:nvPr/>
-        </p:nvSpPr>
-        <p:spPr>
-          <a:xfrm>
-            <a:off x="2194560" y="3191256"/>
-            <a:ext cx="5486400" cy="219456"/>
-          </a:xfrm>
-          <a:prstGeom prst="roundRect">
-            <a:avLst/>
-          </a:prstGeom>
-          <a:solidFill>
-            <a:srgbClr val="692DAF"/>
-          </a:solidFill>
-          <a:ln>
-            <a:noFill/>
-          </a:ln>
-        </p:spPr>
-        <p:style>
-          <a:lnRef idx="1">
-            <a:schemeClr val="accent1"/>
-          </a:lnRef>
-          <a:fillRef idx="3">
-            <a:schemeClr val="accent1"/>
-          </a:fillRef>
-          <a:effectRef idx="2">
-            <a:schemeClr val="accent1"/>
-          </a:effectRef>
-          <a:fontRef idx="minor">
-            <a:schemeClr val="lt1"/>
-          </a:fontRef>
-        </p:style>
-        <p:txBody>
-          <a:bodyPr rtlCol="0" anchor="ctr"/>
+          <a:bodyPr rtlCol="0" anchor="ctr" wrap="square" tIns="36576"/>
           <a:lstStyle/>
           <a:p>
             <a:pPr algn="ctr">
-              <a:defRPr sz="950" b="1">
-                <a:solidFill>
-                  <a:srgbClr val="FFFFFF"/>
+              <a:defRPr sz="850" b="1">
+                <a:solidFill>
+                  <a:srgbClr val="692DAF"/>
                 </a:solidFill>
               </a:defRPr>
             </a:pPr>
@@ -5558,62 +5190,8 @@
               <a:t>3. MULTIMODAL INTELLIGENCE LAYER (Specialist AI &amp; Spectral Engines)</a:t>
             </a:r>
           </a:p>
-        </p:txBody>
-      </p:sp>
-      <p:sp>
-        <p:nvSpPr>
-          <p:cNvPr id="23" name="Rounded Rectangle 22"/>
-          <p:cNvSpPr/>
-          <p:nvPr/>
-        </p:nvSpPr>
-        <p:spPr>
-          <a:xfrm>
-            <a:off x="566928" y="3447288"/>
-            <a:ext cx="2761488" cy="594360"/>
-          </a:xfrm>
-          <a:prstGeom prst="roundRect">
-            <a:avLst/>
-          </a:prstGeom>
-          <a:solidFill>
-            <a:srgbClr val="FFFFFF"/>
-          </a:solidFill>
-          <a:ln w="15240">
-            <a:solidFill>
-              <a:srgbClr val="D7C3F5"/>
-            </a:solidFill>
-          </a:ln>
-        </p:spPr>
-        <p:style>
-          <a:lnRef idx="1">
-            <a:schemeClr val="accent1"/>
-          </a:lnRef>
-          <a:fillRef idx="3">
-            <a:schemeClr val="accent1"/>
-          </a:fillRef>
-          <a:effectRef idx="2">
-            <a:schemeClr val="accent1"/>
-          </a:effectRef>
-          <a:fontRef idx="minor">
-            <a:schemeClr val="lt1"/>
-          </a:fontRef>
-        </p:style>
-        <p:txBody>
-          <a:bodyPr rtlCol="0" anchor="ctr" wrap="square" tIns="36576" bIns="36576" lIns="54864" rIns="54864"/>
-          <a:lstStyle/>
-          <a:p>
-            <a:pPr algn="ctr">
-              <a:defRPr sz="880" b="1">
-                <a:solidFill>
-                  <a:srgbClr val="692DAF"/>
-                </a:solidFill>
-              </a:defRPr>
-            </a:pPr>
-            <a:r>
-              <a:t>🧠 BLIP RS-VQA &amp; Grounder</a:t>
-            </a:r>
-          </a:p>
-          <a:p>
-            <a:pPr algn="ctr">
+          <a:p>
+            <a:pPr>
               <a:defRPr sz="780">
                 <a:solidFill>
                   <a:srgbClr val="212529"/>
@@ -5621,165 +5199,21 @@
               </a:defRPr>
             </a:pPr>
             <a:r>
-              <a:t>Fine-tuned on BigEarthNet</a:t>
-            </a:r>
-            <a:br/>
-            <a:r>
-              <a:t>Open-vocabulary grounding &amp; VQA</a:t>
-            </a:r>
-          </a:p>
-        </p:txBody>
-      </p:sp>
-      <p:sp>
-        <p:nvSpPr>
-          <p:cNvPr id="24" name="Rounded Rectangle 23"/>
-          <p:cNvSpPr/>
-          <p:nvPr/>
-        </p:nvSpPr>
-        <p:spPr>
-          <a:xfrm>
-            <a:off x="3566160" y="3447288"/>
-            <a:ext cx="2761488" cy="594360"/>
-          </a:xfrm>
-          <a:prstGeom prst="roundRect">
-            <a:avLst/>
-          </a:prstGeom>
-          <a:solidFill>
-            <a:srgbClr val="FFFFFF"/>
-          </a:solidFill>
-          <a:ln w="15240">
-            <a:solidFill>
-              <a:srgbClr val="D7C3F5"/>
-            </a:solidFill>
-          </a:ln>
-        </p:spPr>
-        <p:style>
-          <a:lnRef idx="1">
-            <a:schemeClr val="accent1"/>
-          </a:lnRef>
-          <a:fillRef idx="3">
-            <a:schemeClr val="accent1"/>
-          </a:fillRef>
-          <a:effectRef idx="2">
-            <a:schemeClr val="accent1"/>
-          </a:effectRef>
-          <a:fontRef idx="minor">
-            <a:schemeClr val="lt1"/>
-          </a:fontRef>
-        </p:style>
-        <p:txBody>
-          <a:bodyPr rtlCol="0" anchor="ctr" wrap="square" tIns="36576" bIns="36576" lIns="54864" rIns="54864"/>
-          <a:lstStyle/>
-          <a:p>
-            <a:pPr algn="ctr">
-              <a:defRPr sz="880" b="1">
-                <a:solidFill>
-                  <a:srgbClr val="692DAF"/>
-                </a:solidFill>
-              </a:defRPr>
-            </a:pPr>
-            <a:r>
-              <a:t>🛰️ Optical + SAR Fusion Tool</a:t>
-            </a:r>
-          </a:p>
-          <a:p>
-            <a:pPr algn="ctr">
-              <a:defRPr sz="780">
-                <a:solidFill>
-                  <a:srgbClr val="212529"/>
-                </a:solidFill>
-              </a:defRPr>
-            </a:pPr>
-            <a:r>
-              <a:t>Cloud-penetrating radar C-SAR</a:t>
-            </a:r>
-            <a:br/>
-            <a:r>
-              <a:t>Backscatter + Specular water agreement</a:t>
-            </a:r>
-          </a:p>
-        </p:txBody>
-      </p:sp>
-      <p:sp>
-        <p:nvSpPr>
-          <p:cNvPr id="25" name="Rounded Rectangle 24"/>
-          <p:cNvSpPr/>
-          <p:nvPr/>
-        </p:nvSpPr>
-        <p:spPr>
-          <a:xfrm>
-            <a:off x="6565392" y="3447288"/>
-            <a:ext cx="2761488" cy="594360"/>
-          </a:xfrm>
-          <a:prstGeom prst="roundRect">
-            <a:avLst/>
-          </a:prstGeom>
-          <a:solidFill>
-            <a:srgbClr val="FFFFFF"/>
-          </a:solidFill>
-          <a:ln w="15240">
-            <a:solidFill>
-              <a:srgbClr val="D7C3F5"/>
-            </a:solidFill>
-          </a:ln>
-        </p:spPr>
-        <p:style>
-          <a:lnRef idx="1">
-            <a:schemeClr val="accent1"/>
-          </a:lnRef>
-          <a:fillRef idx="3">
-            <a:schemeClr val="accent1"/>
-          </a:fillRef>
-          <a:effectRef idx="2">
-            <a:schemeClr val="accent1"/>
-          </a:effectRef>
-          <a:fontRef idx="minor">
-            <a:schemeClr val="lt1"/>
-          </a:fontRef>
-        </p:style>
-        <p:txBody>
-          <a:bodyPr rtlCol="0" anchor="ctr" wrap="square" tIns="36576" bIns="36576" lIns="54864" rIns="54864"/>
-          <a:lstStyle/>
-          <a:p>
-            <a:pPr algn="ctr">
-              <a:defRPr sz="880" b="1">
-                <a:solidFill>
-                  <a:srgbClr val="692DAF"/>
-                </a:solidFill>
-              </a:defRPr>
-            </a:pPr>
-            <a:r>
-              <a:t>📊 Bi-Temporal Change Engine</a:t>
-            </a:r>
-          </a:p>
-          <a:p>
-            <a:pPr algn="ctr">
-              <a:defRPr sz="780">
-                <a:solidFill>
-                  <a:srgbClr val="212529"/>
-                </a:solidFill>
-              </a:defRPr>
-            </a:pPr>
-            <a:r>
-              <a:t>Radiometric differential raster math</a:t>
-            </a:r>
-            <a:br/>
-            <a:r>
-              <a:t>Pixel anomaly area calculation</a:t>
-            </a:r>
-          </a:p>
-        </p:txBody>
-      </p:sp>
-      <p:sp>
-        <p:nvSpPr>
-          <p:cNvPr id="26" name="TextBox 25"/>
+              <a:t>[🧠 BLIP RS-VQA &amp; Grounder (BigEarthNet)] ◀▶ [🛰️ Optical+SAR Fusion] ◀▶ [📊 Bi-Temporal Change Engine]</a:t>
+            </a:r>
+          </a:p>
+        </p:txBody>
+      </p:sp>
+      <p:sp>
+        <p:nvSpPr>
+          <p:cNvPr id="17" name="TextBox 16"/>
           <p:cNvSpPr txBox="1"/>
           <p:nvPr/>
         </p:nvSpPr>
         <p:spPr>
           <a:xfrm>
-            <a:off x="3328416" y="3566160"/>
-            <a:ext cx="274320" cy="274320"/>
+            <a:off x="8046720" y="4535424"/>
+            <a:ext cx="548640" cy="164592"/>
           </a:xfrm>
           <a:prstGeom prst="rect">
             <a:avLst/>
@@ -5792,64 +5226,29 @@
           </a:bodyPr>
           <a:lstStyle/>
           <a:p>
-            <a:pPr>
-              <a:defRPr sz="900">
-                <a:solidFill>
-                  <a:srgbClr val="692DAF"/>
-                </a:solidFill>
-              </a:defRPr>
-            </a:pPr>
-            <a:r>
-              <a:t>◀▶</a:t>
-            </a:r>
-          </a:p>
-        </p:txBody>
-      </p:sp>
-      <p:sp>
-        <p:nvSpPr>
-          <p:cNvPr id="27" name="TextBox 26"/>
-          <p:cNvSpPr txBox="1"/>
-          <p:nvPr/>
-        </p:nvSpPr>
-        <p:spPr>
-          <a:xfrm>
-            <a:off x="6327648" y="3566160"/>
-            <a:ext cx="274320" cy="274320"/>
-          </a:xfrm>
-          <a:prstGeom prst="rect">
-            <a:avLst/>
-          </a:prstGeom>
-          <a:noFill/>
-        </p:spPr>
-        <p:txBody>
-          <a:bodyPr wrap="none">
-            <a:spAutoFit/>
-          </a:bodyPr>
-          <a:lstStyle/>
-          <a:p>
-            <a:pPr>
-              <a:defRPr sz="900">
-                <a:solidFill>
-                  <a:srgbClr val="692DAF"/>
-                </a:solidFill>
-              </a:defRPr>
-            </a:pPr>
-            <a:r>
-              <a:t>◀▶</a:t>
-            </a:r>
-          </a:p>
-        </p:txBody>
-      </p:sp>
-      <p:sp>
-        <p:nvSpPr>
-          <p:cNvPr id="28" name="Rounded Rectangle 27"/>
+            <a:pPr algn="ctr">
+              <a:defRPr sz="800">
+                <a:solidFill>
+                  <a:srgbClr val="1877F2"/>
+                </a:solidFill>
+              </a:defRPr>
+            </a:pPr>
+            <a:r>
+              <a:t>▼</a:t>
+            </a:r>
+          </a:p>
+        </p:txBody>
+      </p:sp>
+      <p:sp>
+        <p:nvSpPr>
+          <p:cNvPr id="18" name="Rounded Rectangle 17"/>
           <p:cNvSpPr/>
           <p:nvPr/>
         </p:nvSpPr>
         <p:spPr>
           <a:xfrm>
-            <a:off x="457200" y="4160520"/>
-            <a:ext cx="4343400" cy="841248"/>
+            <a:off x="5074920" y="4700016"/>
+            <a:ext cx="3154680" cy="640080"/>
           </a:xfrm>
           <a:prstGeom prst="roundRect">
             <a:avLst/>
@@ -5857,7 +5256,7 @@
           <a:solidFill>
             <a:srgbClr val="F3FCF6"/>
           </a:solidFill>
-          <a:ln w="19050">
+          <a:ln w="12700">
             <a:solidFill>
               <a:srgbClr val="AAE1BE"/>
             </a:solidFill>
@@ -5878,207 +5277,48 @@
           </a:fontRef>
         </p:style>
         <p:txBody>
-          <a:bodyPr rtlCol="0" anchor="ctr"/>
-          <a:lstStyle/>
-          <a:p>
-            <a:pPr algn="ctr"/>
-          </a:p>
-        </p:txBody>
-      </p:sp>
-      <p:sp>
-        <p:nvSpPr>
-          <p:cNvPr id="29" name="Rounded Rectangle 28"/>
+          <a:bodyPr rtlCol="0" anchor="ctr" wrap="square" tIns="36576"/>
+          <a:lstStyle/>
+          <a:p>
+            <a:pPr algn="ctr">
+              <a:defRPr sz="819" b="1">
+                <a:solidFill>
+                  <a:srgbClr val="147D3C"/>
+                </a:solidFill>
+              </a:defRPr>
+            </a:pPr>
+            <a:r>
+              <a:t>4. PERSISTENCE LAYER</a:t>
+            </a:r>
+          </a:p>
+          <a:p>
+            <a:pPr>
+              <a:defRPr sz="740">
+                <a:solidFill>
+                  <a:srgbClr val="212529"/>
+                </a:solidFill>
+              </a:defRPr>
+            </a:pPr>
+            <a:r>
+              <a:t>• Local GeoTIFF Store (C-SAR/Optical)</a:t>
+            </a:r>
+            <a:br/>
+            <a:r>
+              <a:t>• Tile Cache &amp; Spatio-Temporal Queries</a:t>
+            </a:r>
+          </a:p>
+        </p:txBody>
+      </p:sp>
+      <p:sp>
+        <p:nvSpPr>
+          <p:cNvPr id="19" name="Rounded Rectangle 18"/>
           <p:cNvSpPr/>
           <p:nvPr/>
         </p:nvSpPr>
         <p:spPr>
           <a:xfrm>
-            <a:off x="731520" y="4187952"/>
-            <a:ext cx="3794760" cy="201168"/>
-          </a:xfrm>
-          <a:prstGeom prst="roundRect">
-            <a:avLst/>
-          </a:prstGeom>
-          <a:solidFill>
-            <a:srgbClr val="147D3C"/>
-          </a:solidFill>
-          <a:ln>
-            <a:noFill/>
-          </a:ln>
-        </p:spPr>
-        <p:style>
-          <a:lnRef idx="1">
-            <a:schemeClr val="accent1"/>
-          </a:lnRef>
-          <a:fillRef idx="3">
-            <a:schemeClr val="accent1"/>
-          </a:fillRef>
-          <a:effectRef idx="2">
-            <a:schemeClr val="accent1"/>
-          </a:effectRef>
-          <a:fontRef idx="minor">
-            <a:schemeClr val="lt1"/>
-          </a:fontRef>
-        </p:style>
-        <p:txBody>
-          <a:bodyPr rtlCol="0" anchor="ctr"/>
-          <a:lstStyle/>
-          <a:p>
-            <a:pPr algn="ctr">
-              <a:defRPr sz="900" b="1">
-                <a:solidFill>
-                  <a:srgbClr val="FFFFFF"/>
-                </a:solidFill>
-              </a:defRPr>
-            </a:pPr>
-            <a:r>
-              <a:t>4. PERSISTENCE LAYER (Hybrid Storage)</a:t>
-            </a:r>
-          </a:p>
-        </p:txBody>
-      </p:sp>
-      <p:sp>
-        <p:nvSpPr>
-          <p:cNvPr id="30" name="Rounded Rectangle 29"/>
-          <p:cNvSpPr/>
-          <p:nvPr/>
-        </p:nvSpPr>
-        <p:spPr>
-          <a:xfrm>
-            <a:off x="566928" y="4425696"/>
-            <a:ext cx="2011680" cy="521207"/>
-          </a:xfrm>
-          <a:prstGeom prst="roundRect">
-            <a:avLst/>
-          </a:prstGeom>
-          <a:solidFill>
-            <a:srgbClr val="FFFFFF"/>
-          </a:solidFill>
-          <a:ln w="12700">
-            <a:solidFill>
-              <a:srgbClr val="B4E1C8"/>
-            </a:solidFill>
-          </a:ln>
-        </p:spPr>
-        <p:style>
-          <a:lnRef idx="1">
-            <a:schemeClr val="accent1"/>
-          </a:lnRef>
-          <a:fillRef idx="3">
-            <a:schemeClr val="accent1"/>
-          </a:fillRef>
-          <a:effectRef idx="2">
-            <a:schemeClr val="accent1"/>
-          </a:effectRef>
-          <a:fontRef idx="minor">
-            <a:schemeClr val="lt1"/>
-          </a:fontRef>
-        </p:style>
-        <p:txBody>
-          <a:bodyPr rtlCol="0" anchor="ctr" wrap="square" tIns="36576"/>
-          <a:lstStyle/>
-          <a:p>
-            <a:pPr algn="ctr">
-              <a:defRPr sz="850" b="1">
-                <a:solidFill>
-                  <a:srgbClr val="147D3C"/>
-                </a:solidFill>
-              </a:defRPr>
-            </a:pPr>
-            <a:r>
-              <a:t>🗄️ Local GeoTIFF Store</a:t>
-            </a:r>
-          </a:p>
-          <a:p>
-            <a:pPr algn="ctr">
-              <a:defRPr sz="750">
-                <a:solidFill>
-                  <a:srgbClr val="212529"/>
-                </a:solidFill>
-              </a:defRPr>
-            </a:pPr>
-            <a:r>
-              <a:t>Multispectral &amp; SAR Rasters</a:t>
-            </a:r>
-          </a:p>
-        </p:txBody>
-      </p:sp>
-      <p:sp>
-        <p:nvSpPr>
-          <p:cNvPr id="31" name="Rounded Rectangle 30"/>
-          <p:cNvSpPr/>
-          <p:nvPr/>
-        </p:nvSpPr>
-        <p:spPr>
-          <a:xfrm>
-            <a:off x="2670048" y="4425696"/>
-            <a:ext cx="2011680" cy="521207"/>
-          </a:xfrm>
-          <a:prstGeom prst="roundRect">
-            <a:avLst/>
-          </a:prstGeom>
-          <a:solidFill>
-            <a:srgbClr val="FFFFFF"/>
-          </a:solidFill>
-          <a:ln w="12700">
-            <a:solidFill>
-              <a:srgbClr val="B4E1C8"/>
-            </a:solidFill>
-          </a:ln>
-        </p:spPr>
-        <p:style>
-          <a:lnRef idx="1">
-            <a:schemeClr val="accent1"/>
-          </a:lnRef>
-          <a:fillRef idx="3">
-            <a:schemeClr val="accent1"/>
-          </a:fillRef>
-          <a:effectRef idx="2">
-            <a:schemeClr val="accent1"/>
-          </a:effectRef>
-          <a:fontRef idx="minor">
-            <a:schemeClr val="lt1"/>
-          </a:fontRef>
-        </p:style>
-        <p:txBody>
-          <a:bodyPr rtlCol="0" anchor="ctr" wrap="square" tIns="36576"/>
-          <a:lstStyle/>
-          <a:p>
-            <a:pPr algn="ctr">
-              <a:defRPr sz="850" b="1">
-                <a:solidFill>
-                  <a:srgbClr val="147D3C"/>
-                </a:solidFill>
-              </a:defRPr>
-            </a:pPr>
-            <a:r>
-              <a:t>⚡ Tile Cache &amp; Audit DB</a:t>
-            </a:r>
-          </a:p>
-          <a:p>
-            <a:pPr algn="ctr">
-              <a:defRPr sz="750">
-                <a:solidFill>
-                  <a:srgbClr val="212529"/>
-                </a:solidFill>
-              </a:defRPr>
-            </a:pPr>
-            <a:r>
-              <a:t>Indexed Spatial Queries</a:t>
-            </a:r>
-          </a:p>
-        </p:txBody>
-      </p:sp>
-      <p:sp>
-        <p:nvSpPr>
-          <p:cNvPr id="32" name="Rounded Rectangle 31"/>
-          <p:cNvSpPr/>
-          <p:nvPr/>
-        </p:nvSpPr>
-        <p:spPr>
-          <a:xfrm>
-            <a:off x="5074920" y="4160520"/>
-            <a:ext cx="4343400" cy="841248"/>
+            <a:off x="8412480" y="4700016"/>
+            <a:ext cx="3154680" cy="640080"/>
           </a:xfrm>
           <a:prstGeom prst="roundRect">
             <a:avLst/>
@@ -6086,7 +5326,7 @@
           <a:solidFill>
             <a:srgbClr val="FFF9F3"/>
           </a:solidFill>
-          <a:ln w="19050">
+          <a:ln w="12700">
             <a:solidFill>
               <a:srgbClr val="FAC8A0"/>
             </a:solidFill>
@@ -6107,537 +5347,48 @@
           </a:fontRef>
         </p:style>
         <p:txBody>
-          <a:bodyPr rtlCol="0" anchor="ctr"/>
-          <a:lstStyle/>
-          <a:p>
-            <a:pPr algn="ctr"/>
-          </a:p>
-        </p:txBody>
-      </p:sp>
-      <p:sp>
-        <p:nvSpPr>
-          <p:cNvPr id="33" name="Rounded Rectangle 32"/>
+          <a:bodyPr rtlCol="0" anchor="ctr" wrap="square" tIns="36576"/>
+          <a:lstStyle/>
+          <a:p>
+            <a:pPr algn="ctr">
+              <a:defRPr sz="819" b="1">
+                <a:solidFill>
+                  <a:srgbClr val="D75F14"/>
+                </a:solidFill>
+              </a:defRPr>
+            </a:pPr>
+            <a:r>
+              <a:t>5. SPACE INTEROPERABILITY</a:t>
+            </a:r>
+          </a:p>
+          <a:p>
+            <a:pPr>
+              <a:defRPr sz="740">
+                <a:solidFill>
+                  <a:srgbClr val="212529"/>
+                </a:solidFill>
+              </a:defRPr>
+            </a:pPr>
+            <a:r>
+              <a:t>• ISRO Bhuvan &amp; Bhoonidhi (LISS/RISAT)</a:t>
+            </a:r>
+            <a:br/>
+            <a:r>
+              <a:t>• Copernicus CDSE (Sentinel-1/2 OData)</a:t>
+            </a:r>
+          </a:p>
+        </p:txBody>
+      </p:sp>
+      <p:sp>
+        <p:nvSpPr>
+          <p:cNvPr id="20" name="Rounded Rectangle 19"/>
           <p:cNvSpPr/>
           <p:nvPr/>
         </p:nvSpPr>
         <p:spPr>
           <a:xfrm>
-            <a:off x="5349240" y="4187952"/>
-            <a:ext cx="3794760" cy="201168"/>
-          </a:xfrm>
-          <a:prstGeom prst="roundRect">
-            <a:avLst/>
-          </a:prstGeom>
-          <a:solidFill>
-            <a:srgbClr val="D75F14"/>
-          </a:solidFill>
-          <a:ln>
-            <a:noFill/>
-          </a:ln>
-        </p:spPr>
-        <p:style>
-          <a:lnRef idx="1">
-            <a:schemeClr val="accent1"/>
-          </a:lnRef>
-          <a:fillRef idx="3">
-            <a:schemeClr val="accent1"/>
-          </a:fillRef>
-          <a:effectRef idx="2">
-            <a:schemeClr val="accent1"/>
-          </a:effectRef>
-          <a:fontRef idx="minor">
-            <a:schemeClr val="lt1"/>
-          </a:fontRef>
-        </p:style>
-        <p:txBody>
-          <a:bodyPr rtlCol="0" anchor="ctr"/>
-          <a:lstStyle/>
-          <a:p>
-            <a:pPr algn="ctr">
-              <a:defRPr sz="900" b="1">
-                <a:solidFill>
-                  <a:srgbClr val="FFFFFF"/>
-                </a:solidFill>
-              </a:defRPr>
-            </a:pPr>
-            <a:r>
-              <a:t>5. INTEROPERABILITY LAYER (Standardized Exchange)</a:t>
-            </a:r>
-          </a:p>
-        </p:txBody>
-      </p:sp>
-      <p:sp>
-        <p:nvSpPr>
-          <p:cNvPr id="34" name="Rounded Rectangle 33"/>
-          <p:cNvSpPr/>
-          <p:nvPr/>
-        </p:nvSpPr>
-        <p:spPr>
-          <a:xfrm>
-            <a:off x="5184648" y="4425696"/>
-            <a:ext cx="2011680" cy="521207"/>
-          </a:xfrm>
-          <a:prstGeom prst="roundRect">
-            <a:avLst/>
-          </a:prstGeom>
-          <a:solidFill>
-            <a:srgbClr val="FFFFFF"/>
-          </a:solidFill>
-          <a:ln w="12700">
-            <a:solidFill>
-              <a:srgbClr val="F5D2B4"/>
-            </a:solidFill>
-          </a:ln>
-        </p:spPr>
-        <p:style>
-          <a:lnRef idx="1">
-            <a:schemeClr val="accent1"/>
-          </a:lnRef>
-          <a:fillRef idx="3">
-            <a:schemeClr val="accent1"/>
-          </a:fillRef>
-          <a:effectRef idx="2">
-            <a:schemeClr val="accent1"/>
-          </a:effectRef>
-          <a:fontRef idx="minor">
-            <a:schemeClr val="lt1"/>
-          </a:fontRef>
-        </p:style>
-        <p:txBody>
-          <a:bodyPr rtlCol="0" anchor="ctr" wrap="square" tIns="36576"/>
-          <a:lstStyle/>
-          <a:p>
-            <a:pPr algn="ctr">
-              <a:defRPr sz="850" b="1">
-                <a:solidFill>
-                  <a:srgbClr val="D75F14"/>
-                </a:solidFill>
-              </a:defRPr>
-            </a:pPr>
-            <a:r>
-              <a:t>🛰️ ISRO Bhuvan / Bhoonidhi</a:t>
-            </a:r>
-          </a:p>
-          <a:p>
-            <a:pPr algn="ctr">
-              <a:defRPr sz="750">
-                <a:solidFill>
-                  <a:srgbClr val="212529"/>
-                </a:solidFill>
-              </a:defRPr>
-            </a:pPr>
-            <a:r>
-              <a:t>Resourcesat, Cartosat, RISAT</a:t>
-            </a:r>
-          </a:p>
-        </p:txBody>
-      </p:sp>
-      <p:sp>
-        <p:nvSpPr>
-          <p:cNvPr id="35" name="Rounded Rectangle 34"/>
-          <p:cNvSpPr/>
-          <p:nvPr/>
-        </p:nvSpPr>
-        <p:spPr>
-          <a:xfrm>
-            <a:off x="7287768" y="4425696"/>
-            <a:ext cx="2011680" cy="521207"/>
-          </a:xfrm>
-          <a:prstGeom prst="roundRect">
-            <a:avLst/>
-          </a:prstGeom>
-          <a:solidFill>
-            <a:srgbClr val="FFFFFF"/>
-          </a:solidFill>
-          <a:ln w="12700">
-            <a:solidFill>
-              <a:srgbClr val="F5D2B4"/>
-            </a:solidFill>
-          </a:ln>
-        </p:spPr>
-        <p:style>
-          <a:lnRef idx="1">
-            <a:schemeClr val="accent1"/>
-          </a:lnRef>
-          <a:fillRef idx="3">
-            <a:schemeClr val="accent1"/>
-          </a:fillRef>
-          <a:effectRef idx="2">
-            <a:schemeClr val="accent1"/>
-          </a:effectRef>
-          <a:fontRef idx="minor">
-            <a:schemeClr val="lt1"/>
-          </a:fontRef>
-        </p:style>
-        <p:txBody>
-          <a:bodyPr rtlCol="0" anchor="ctr" wrap="square" tIns="36576"/>
-          <a:lstStyle/>
-          <a:p>
-            <a:pPr algn="ctr">
-              <a:defRPr sz="850" b="1">
-                <a:solidFill>
-                  <a:srgbClr val="D75F14"/>
-                </a:solidFill>
-              </a:defRPr>
-            </a:pPr>
-            <a:r>
-              <a:t>🌍 Copernicus CDSE Gateway</a:t>
-            </a:r>
-          </a:p>
-          <a:p>
-            <a:pPr algn="ctr">
-              <a:defRPr sz="750">
-                <a:solidFill>
-                  <a:srgbClr val="212529"/>
-                </a:solidFill>
-              </a:defRPr>
-            </a:pPr>
-            <a:r>
-              <a:t>Sentinel-1 SAR, Sentinel-2 MSI</a:t>
-            </a:r>
-          </a:p>
-        </p:txBody>
-      </p:sp>
-      <p:sp>
-        <p:nvSpPr>
-          <p:cNvPr id="36" name="Rounded Rectangle 35"/>
-          <p:cNvSpPr/>
-          <p:nvPr/>
-        </p:nvSpPr>
-        <p:spPr>
-          <a:xfrm>
-            <a:off x="548640" y="5056632"/>
-            <a:ext cx="1682496" cy="365760"/>
-          </a:xfrm>
-          <a:prstGeom prst="roundRect">
-            <a:avLst/>
-          </a:prstGeom>
-          <a:solidFill>
-            <a:srgbClr val="FFFFFF"/>
-          </a:solidFill>
-          <a:ln w="12700">
-            <a:solidFill>
-              <a:srgbClr val="C8D7EB"/>
-            </a:solidFill>
-          </a:ln>
-        </p:spPr>
-        <p:style>
-          <a:lnRef idx="1">
-            <a:schemeClr val="accent1"/>
-          </a:lnRef>
-          <a:fillRef idx="3">
-            <a:schemeClr val="accent1"/>
-          </a:fillRef>
-          <a:effectRef idx="2">
-            <a:schemeClr val="accent1"/>
-          </a:effectRef>
-          <a:fontRef idx="minor">
-            <a:schemeClr val="lt1"/>
-          </a:fontRef>
-        </p:style>
-        <p:txBody>
-          <a:bodyPr rtlCol="0" anchor="ctr" wrap="square" tIns="18288" bIns="18288"/>
-          <a:lstStyle/>
-          <a:p>
-            <a:pPr algn="ctr">
-              <a:defRPr sz="819" b="1">
-                <a:solidFill>
-                  <a:srgbClr val="0F3C82"/>
-                </a:solidFill>
-              </a:defRPr>
-            </a:pPr>
-            <a:r>
-              <a:t>🌐 Unified Access</a:t>
-            </a:r>
-          </a:p>
-          <a:p>
-            <a:pPr algn="ctr">
-              <a:defRPr sz="720">
-                <a:solidFill>
-                  <a:srgbClr val="646E78"/>
-                </a:solidFill>
-              </a:defRPr>
-            </a:pPr>
-            <a:r>
-              <a:t>Cross-departmental GIS</a:t>
-            </a:r>
-          </a:p>
-        </p:txBody>
-      </p:sp>
-      <p:sp>
-        <p:nvSpPr>
-          <p:cNvPr id="37" name="Rounded Rectangle 36"/>
-          <p:cNvSpPr/>
-          <p:nvPr/>
-        </p:nvSpPr>
-        <p:spPr>
-          <a:xfrm>
-            <a:off x="2304288" y="5056632"/>
-            <a:ext cx="1682496" cy="365760"/>
-          </a:xfrm>
-          <a:prstGeom prst="roundRect">
-            <a:avLst/>
-          </a:prstGeom>
-          <a:solidFill>
-            <a:srgbClr val="FFFFFF"/>
-          </a:solidFill>
-          <a:ln w="12700">
-            <a:solidFill>
-              <a:srgbClr val="C8D7EB"/>
-            </a:solidFill>
-          </a:ln>
-        </p:spPr>
-        <p:style>
-          <a:lnRef idx="1">
-            <a:schemeClr val="accent1"/>
-          </a:lnRef>
-          <a:fillRef idx="3">
-            <a:schemeClr val="accent1"/>
-          </a:fillRef>
-          <a:effectRef idx="2">
-            <a:schemeClr val="accent1"/>
-          </a:effectRef>
-          <a:fontRef idx="minor">
-            <a:schemeClr val="lt1"/>
-          </a:fontRef>
-        </p:style>
-        <p:txBody>
-          <a:bodyPr rtlCol="0" anchor="ctr" wrap="square" tIns="18288" bIns="18288"/>
-          <a:lstStyle/>
-          <a:p>
-            <a:pPr algn="ctr">
-              <a:defRPr sz="819" b="1">
-                <a:solidFill>
-                  <a:srgbClr val="0F3C82"/>
-                </a:solidFill>
-              </a:defRPr>
-            </a:pPr>
-            <a:r>
-              <a:t>🧠 Zero Hallucination</a:t>
-            </a:r>
-          </a:p>
-          <a:p>
-            <a:pPr algn="ctr">
-              <a:defRPr sz="720">
-                <a:solidFill>
-                  <a:srgbClr val="646E78"/>
-                </a:solidFill>
-              </a:defRPr>
-            </a:pPr>
-            <a:r>
-              <a:t>Strict deterministic routing</a:t>
-            </a:r>
-          </a:p>
-        </p:txBody>
-      </p:sp>
-      <p:sp>
-        <p:nvSpPr>
-          <p:cNvPr id="38" name="Rounded Rectangle 37"/>
-          <p:cNvSpPr/>
-          <p:nvPr/>
-        </p:nvSpPr>
-        <p:spPr>
-          <a:xfrm>
-            <a:off x="4059936" y="5056632"/>
-            <a:ext cx="1682496" cy="365760"/>
-          </a:xfrm>
-          <a:prstGeom prst="roundRect">
-            <a:avLst/>
-          </a:prstGeom>
-          <a:solidFill>
-            <a:srgbClr val="FFFFFF"/>
-          </a:solidFill>
-          <a:ln w="12700">
-            <a:solidFill>
-              <a:srgbClr val="C8D7EB"/>
-            </a:solidFill>
-          </a:ln>
-        </p:spPr>
-        <p:style>
-          <a:lnRef idx="1">
-            <a:schemeClr val="accent1"/>
-          </a:lnRef>
-          <a:fillRef idx="3">
-            <a:schemeClr val="accent1"/>
-          </a:fillRef>
-          <a:effectRef idx="2">
-            <a:schemeClr val="accent1"/>
-          </a:effectRef>
-          <a:fontRef idx="minor">
-            <a:schemeClr val="lt1"/>
-          </a:fontRef>
-        </p:style>
-        <p:txBody>
-          <a:bodyPr rtlCol="0" anchor="ctr" wrap="square" tIns="18288" bIns="18288"/>
-          <a:lstStyle/>
-          <a:p>
-            <a:pPr algn="ctr">
-              <a:defRPr sz="819" b="1">
-                <a:solidFill>
-                  <a:srgbClr val="0F3C82"/>
-                </a:solidFill>
-              </a:defRPr>
-            </a:pPr>
-            <a:r>
-              <a:t>🔒 Air-Gapped Secure</a:t>
-            </a:r>
-          </a:p>
-          <a:p>
-            <a:pPr algn="ctr">
-              <a:defRPr sz="720">
-                <a:solidFill>
-                  <a:srgbClr val="646E78"/>
-                </a:solidFill>
-              </a:defRPr>
-            </a:pPr>
-            <a:r>
-              <a:t>100% on-premise execution</a:t>
-            </a:r>
-          </a:p>
-        </p:txBody>
-      </p:sp>
-      <p:sp>
-        <p:nvSpPr>
-          <p:cNvPr id="39" name="Rounded Rectangle 38"/>
-          <p:cNvSpPr/>
-          <p:nvPr/>
-        </p:nvSpPr>
-        <p:spPr>
-          <a:xfrm>
-            <a:off x="5815584" y="5056632"/>
-            <a:ext cx="1682496" cy="365760"/>
-          </a:xfrm>
-          <a:prstGeom prst="roundRect">
-            <a:avLst/>
-          </a:prstGeom>
-          <a:solidFill>
-            <a:srgbClr val="FFFFFF"/>
-          </a:solidFill>
-          <a:ln w="12700">
-            <a:solidFill>
-              <a:srgbClr val="C8D7EB"/>
-            </a:solidFill>
-          </a:ln>
-        </p:spPr>
-        <p:style>
-          <a:lnRef idx="1">
-            <a:schemeClr val="accent1"/>
-          </a:lnRef>
-          <a:fillRef idx="3">
-            <a:schemeClr val="accent1"/>
-          </a:fillRef>
-          <a:effectRef idx="2">
-            <a:schemeClr val="accent1"/>
-          </a:effectRef>
-          <a:fontRef idx="minor">
-            <a:schemeClr val="lt1"/>
-          </a:fontRef>
-        </p:style>
-        <p:txBody>
-          <a:bodyPr rtlCol="0" anchor="ctr" wrap="square" tIns="18288" bIns="18288"/>
-          <a:lstStyle/>
-          <a:p>
-            <a:pPr algn="ctr">
-              <a:defRPr sz="819" b="1">
-                <a:solidFill>
-                  <a:srgbClr val="0F3C82"/>
-                </a:solidFill>
-              </a:defRPr>
-            </a:pPr>
-            <a:r>
-              <a:t>🛰️ Multi-Sensor Fusion</a:t>
-            </a:r>
-          </a:p>
-          <a:p>
-            <a:pPr algn="ctr">
-              <a:defRPr sz="720">
-                <a:solidFill>
-                  <a:srgbClr val="646E78"/>
-                </a:solidFill>
-              </a:defRPr>
-            </a:pPr>
-            <a:r>
-              <a:t>Optical + SAR co-analysis</a:t>
-            </a:r>
-          </a:p>
-        </p:txBody>
-      </p:sp>
-      <p:sp>
-        <p:nvSpPr>
-          <p:cNvPr id="40" name="Rounded Rectangle 39"/>
-          <p:cNvSpPr/>
-          <p:nvPr/>
-        </p:nvSpPr>
-        <p:spPr>
-          <a:xfrm>
-            <a:off x="7571232" y="5056632"/>
-            <a:ext cx="1682496" cy="365760"/>
-          </a:xfrm>
-          <a:prstGeom prst="roundRect">
-            <a:avLst/>
-          </a:prstGeom>
-          <a:solidFill>
-            <a:srgbClr val="FFFFFF"/>
-          </a:solidFill>
-          <a:ln w="12700">
-            <a:solidFill>
-              <a:srgbClr val="C8D7EB"/>
-            </a:solidFill>
-          </a:ln>
-        </p:spPr>
-        <p:style>
-          <a:lnRef idx="1">
-            <a:schemeClr val="accent1"/>
-          </a:lnRef>
-          <a:fillRef idx="3">
-            <a:schemeClr val="accent1"/>
-          </a:fillRef>
-          <a:effectRef idx="2">
-            <a:schemeClr val="accent1"/>
-          </a:effectRef>
-          <a:fontRef idx="minor">
-            <a:schemeClr val="lt1"/>
-          </a:fontRef>
-        </p:style>
-        <p:txBody>
-          <a:bodyPr rtlCol="0" anchor="ctr" wrap="square" tIns="18288" bIns="18288"/>
-          <a:lstStyle/>
-          <a:p>
-            <a:pPr algn="ctr">
-              <a:defRPr sz="819" b="1">
-                <a:solidFill>
-                  <a:srgbClr val="0F3C82"/>
-                </a:solidFill>
-              </a:defRPr>
-            </a:pPr>
-            <a:r>
-              <a:t>⚡ &lt;300ms Latency</a:t>
-            </a:r>
-          </a:p>
-          <a:p>
-            <a:pPr algn="ctr">
-              <a:defRPr sz="720">
-                <a:solidFill>
-                  <a:srgbClr val="646E78"/>
-                </a:solidFill>
-              </a:defRPr>
-            </a:pPr>
-            <a:r>
-              <a:t>Standard CPU inference</a:t>
-            </a:r>
-          </a:p>
-        </p:txBody>
-      </p:sp>
-      <p:sp>
-        <p:nvSpPr>
-          <p:cNvPr id="41" name="Rounded Rectangle 40"/>
-          <p:cNvSpPr/>
-          <p:nvPr/>
-        </p:nvSpPr>
-        <p:spPr>
-          <a:xfrm>
-            <a:off x="457200" y="5486400"/>
-            <a:ext cx="8961120" cy="329184"/>
+            <a:off x="5074920" y="5440680"/>
+            <a:ext cx="6492240" cy="594360"/>
           </a:xfrm>
           <a:prstGeom prst="roundRect">
             <a:avLst/>
@@ -6670,629 +5421,33 @@
           <a:lstStyle/>
           <a:p>
             <a:pPr algn="ctr">
-              <a:defRPr sz="950" b="1">
+              <a:defRPr sz="850" b="1">
                 <a:solidFill>
                   <a:srgbClr val="0B2C5B"/>
                 </a:solidFill>
               </a:defRPr>
             </a:pPr>
             <a:r>
-              <a:t>🎯 OUR GOAL: Democratize satellite Earth observation intelligence with zero hallucination and 24/7 all-weather situational awareness.</a:t>
-            </a:r>
-          </a:p>
-        </p:txBody>
-      </p:sp>
-      <p:sp>
-        <p:nvSpPr>
-          <p:cNvPr id="42" name="Rounded Rectangle 41"/>
-          <p:cNvSpPr/>
-          <p:nvPr/>
-        </p:nvSpPr>
-        <p:spPr>
-          <a:xfrm>
-            <a:off x="9646920" y="868680"/>
-            <a:ext cx="2103120" cy="4946904"/>
-          </a:xfrm>
-          <a:prstGeom prst="roundRect">
-            <a:avLst/>
-          </a:prstGeom>
-          <a:solidFill>
-            <a:srgbClr val="FFFFFF"/>
-          </a:solidFill>
-          <a:ln w="19050">
-            <a:solidFill>
-              <a:srgbClr val="D7E1EE"/>
-            </a:solidFill>
-          </a:ln>
-        </p:spPr>
-        <p:style>
-          <a:lnRef idx="1">
-            <a:schemeClr val="accent1"/>
-          </a:lnRef>
-          <a:fillRef idx="3">
-            <a:schemeClr val="accent1"/>
-          </a:fillRef>
-          <a:effectRef idx="2">
-            <a:schemeClr val="accent1"/>
-          </a:effectRef>
-          <a:fontRef idx="minor">
-            <a:schemeClr val="lt1"/>
-          </a:fontRef>
-        </p:style>
-        <p:txBody>
-          <a:bodyPr rtlCol="0" anchor="ctr"/>
-          <a:lstStyle/>
-          <a:p>
-            <a:pPr algn="ctr"/>
-          </a:p>
-        </p:txBody>
-      </p:sp>
-      <p:sp>
-        <p:nvSpPr>
-          <p:cNvPr id="43" name="TextBox 42"/>
-          <p:cNvSpPr txBox="1"/>
-          <p:nvPr/>
-        </p:nvSpPr>
-        <p:spPr>
-          <a:xfrm>
-            <a:off x="9692640" y="932688"/>
-            <a:ext cx="2011680" cy="347472"/>
-          </a:xfrm>
-          <a:prstGeom prst="rect">
-            <a:avLst/>
-          </a:prstGeom>
-          <a:noFill/>
-        </p:spPr>
-        <p:txBody>
-          <a:bodyPr wrap="none">
-            <a:spAutoFit/>
-          </a:bodyPr>
-          <a:lstStyle/>
+              <a:t>🎯 Verification &amp; Evidence Flow: Zero Hallucination Guarantee</a:t>
+            </a:r>
+          </a:p>
           <a:p>
             <a:pPr algn="ctr">
-              <a:defRPr sz="1500" b="1">
-                <a:solidFill>
-                  <a:srgbClr val="212529"/>
-                </a:solidFill>
-              </a:defRPr>
-            </a:pPr>
-            <a:r>
-              <a:t>Techstacks Used</a:t>
-            </a:r>
-          </a:p>
-        </p:txBody>
-      </p:sp>
-      <p:sp>
-        <p:nvSpPr>
-          <p:cNvPr id="44" name="Rounded Rectangle 43"/>
-          <p:cNvSpPr/>
-          <p:nvPr/>
-        </p:nvSpPr>
-        <p:spPr>
-          <a:xfrm>
-            <a:off x="9784080" y="1353312"/>
-            <a:ext cx="1828800" cy="457200"/>
-          </a:xfrm>
-          <a:prstGeom prst="roundRect">
-            <a:avLst/>
-          </a:prstGeom>
-          <a:solidFill>
-            <a:srgbClr val="FAFCFF"/>
-          </a:solidFill>
-          <a:ln w="12700">
-            <a:solidFill>
-              <a:srgbClr val="3572A5"/>
-            </a:solidFill>
-          </a:ln>
-        </p:spPr>
-        <p:style>
-          <a:lnRef idx="1">
-            <a:schemeClr val="accent1"/>
-          </a:lnRef>
-          <a:fillRef idx="3">
-            <a:schemeClr val="accent1"/>
-          </a:fillRef>
-          <a:effectRef idx="2">
-            <a:schemeClr val="accent1"/>
-          </a:effectRef>
-          <a:fontRef idx="minor">
-            <a:schemeClr val="lt1"/>
-          </a:fontRef>
-        </p:style>
-        <p:txBody>
-          <a:bodyPr rtlCol="0" anchor="ctr" wrap="square" tIns="36576" bIns="18288" lIns="54864" rIns="54864"/>
-          <a:lstStyle/>
-          <a:p>
-            <a:pPr algn="ctr">
-              <a:defRPr sz="950" b="1">
-                <a:solidFill>
-                  <a:srgbClr val="212529"/>
-                </a:solidFill>
-              </a:defRPr>
-            </a:pPr>
-            <a:r>
-              <a:t>🐍 Python 3.11</a:t>
-            </a:r>
-          </a:p>
-          <a:p>
-            <a:pPr>
               <a:defRPr sz="750">
                 <a:solidFill>
-                  <a:srgbClr val="646E78"/>
-                </a:solidFill>
-              </a:defRPr>
-            </a:pPr>
-            <a:r>
-              <a:t>Backend AI &amp; Engines</a:t>
-            </a:r>
-          </a:p>
-        </p:txBody>
-      </p:sp>
-      <p:sp>
-        <p:nvSpPr>
-          <p:cNvPr id="45" name="Rounded Rectangle 44"/>
-          <p:cNvSpPr/>
-          <p:nvPr/>
-        </p:nvSpPr>
-        <p:spPr>
-          <a:xfrm>
-            <a:off x="9784080" y="1892808"/>
-            <a:ext cx="1828800" cy="457200"/>
-          </a:xfrm>
-          <a:prstGeom prst="roundRect">
-            <a:avLst/>
-          </a:prstGeom>
-          <a:solidFill>
-            <a:srgbClr val="FAFCFF"/>
-          </a:solidFill>
-          <a:ln w="12700">
-            <a:solidFill>
-              <a:srgbClr val="05998A"/>
-            </a:solidFill>
-          </a:ln>
-        </p:spPr>
-        <p:style>
-          <a:lnRef idx="1">
-            <a:schemeClr val="accent1"/>
-          </a:lnRef>
-          <a:fillRef idx="3">
-            <a:schemeClr val="accent1"/>
-          </a:fillRef>
-          <a:effectRef idx="2">
-            <a:schemeClr val="accent1"/>
-          </a:effectRef>
-          <a:fontRef idx="minor">
-            <a:schemeClr val="lt1"/>
-          </a:fontRef>
-        </p:style>
-        <p:txBody>
-          <a:bodyPr rtlCol="0" anchor="ctr" wrap="square" tIns="36576" bIns="18288" lIns="54864" rIns="54864"/>
-          <a:lstStyle/>
-          <a:p>
-            <a:pPr algn="ctr">
-              <a:defRPr sz="950" b="1">
-                <a:solidFill>
-                  <a:srgbClr val="212529"/>
-                </a:solidFill>
-              </a:defRPr>
-            </a:pPr>
-            <a:r>
-              <a:t>⚡ FastAPI</a:t>
-            </a:r>
-          </a:p>
-          <a:p>
-            <a:pPr>
-              <a:defRPr sz="750">
-                <a:solidFill>
-                  <a:srgbClr val="646E78"/>
-                </a:solidFill>
-              </a:defRPr>
-            </a:pPr>
-            <a:r>
-              <a:t>Async RESTful Framework</a:t>
-            </a:r>
-          </a:p>
-        </p:txBody>
-      </p:sp>
-      <p:sp>
-        <p:nvSpPr>
-          <p:cNvPr id="46" name="Rounded Rectangle 45"/>
-          <p:cNvSpPr/>
-          <p:nvPr/>
-        </p:nvSpPr>
-        <p:spPr>
-          <a:xfrm>
-            <a:off x="9784080" y="2432304"/>
-            <a:ext cx="1828800" cy="457200"/>
-          </a:xfrm>
-          <a:prstGeom prst="roundRect">
-            <a:avLst/>
-          </a:prstGeom>
-          <a:solidFill>
-            <a:srgbClr val="FAFCFF"/>
-          </a:solidFill>
-          <a:ln w="12700">
-            <a:solidFill>
-              <a:srgbClr val="00B4D8"/>
-            </a:solidFill>
-          </a:ln>
-        </p:spPr>
-        <p:style>
-          <a:lnRef idx="1">
-            <a:schemeClr val="accent1"/>
-          </a:lnRef>
-          <a:fillRef idx="3">
-            <a:schemeClr val="accent1"/>
-          </a:fillRef>
-          <a:effectRef idx="2">
-            <a:schemeClr val="accent1"/>
-          </a:effectRef>
-          <a:fontRef idx="minor">
-            <a:schemeClr val="lt1"/>
-          </a:fontRef>
-        </p:style>
-        <p:txBody>
-          <a:bodyPr rtlCol="0" anchor="ctr" wrap="square" tIns="36576" bIns="18288" lIns="54864" rIns="54864"/>
-          <a:lstStyle/>
-          <a:p>
-            <a:pPr algn="ctr">
-              <a:defRPr sz="950" b="1">
-                <a:solidFill>
-                  <a:srgbClr val="212529"/>
-                </a:solidFill>
-              </a:defRPr>
-            </a:pPr>
-            <a:r>
-              <a:t>⚛️ React 19</a:t>
-            </a:r>
-          </a:p>
-          <a:p>
-            <a:pPr>
-              <a:defRPr sz="750">
-                <a:solidFill>
-                  <a:srgbClr val="646E78"/>
-                </a:solidFill>
-              </a:defRPr>
-            </a:pPr>
-            <a:r>
-              <a:t>Modern Interactive UI</a:t>
-            </a:r>
-          </a:p>
-        </p:txBody>
-      </p:sp>
-      <p:sp>
-        <p:nvSpPr>
-          <p:cNvPr id="47" name="Rounded Rectangle 46"/>
-          <p:cNvSpPr/>
-          <p:nvPr/>
-        </p:nvSpPr>
-        <p:spPr>
-          <a:xfrm>
-            <a:off x="9784080" y="2971800"/>
-            <a:ext cx="1828800" cy="457200"/>
-          </a:xfrm>
-          <a:prstGeom prst="roundRect">
-            <a:avLst/>
-          </a:prstGeom>
-          <a:solidFill>
-            <a:srgbClr val="FAFCFF"/>
-          </a:solidFill>
-          <a:ln w="12700">
-            <a:solidFill>
-              <a:srgbClr val="1E90FF"/>
-            </a:solidFill>
-          </a:ln>
-        </p:spPr>
-        <p:style>
-          <a:lnRef idx="1">
-            <a:schemeClr val="accent1"/>
-          </a:lnRef>
-          <a:fillRef idx="3">
-            <a:schemeClr val="accent1"/>
-          </a:fillRef>
-          <a:effectRef idx="2">
-            <a:schemeClr val="accent1"/>
-          </a:effectRef>
-          <a:fontRef idx="minor">
-            <a:schemeClr val="lt1"/>
-          </a:fontRef>
-        </p:style>
-        <p:txBody>
-          <a:bodyPr rtlCol="0" anchor="ctr" wrap="square" tIns="36576" bIns="18288" lIns="54864" rIns="54864"/>
-          <a:lstStyle/>
-          <a:p>
-            <a:pPr algn="ctr">
-              <a:defRPr sz="950" b="1">
-                <a:solidFill>
-                  <a:srgbClr val="212529"/>
-                </a:solidFill>
-              </a:defRPr>
-            </a:pPr>
-            <a:r>
-              <a:t>🗺️ MapLibre GL</a:t>
-            </a:r>
-          </a:p>
-          <a:p>
-            <a:pPr>
-              <a:defRPr sz="750">
-                <a:solidFill>
-                  <a:srgbClr val="646E78"/>
-                </a:solidFill>
-              </a:defRPr>
-            </a:pPr>
-            <a:r>
-              <a:t>WebGL Vector Map Engine</a:t>
-            </a:r>
-          </a:p>
-        </p:txBody>
-      </p:sp>
-      <p:sp>
-        <p:nvSpPr>
-          <p:cNvPr id="48" name="Rounded Rectangle 47"/>
-          <p:cNvSpPr/>
-          <p:nvPr/>
-        </p:nvSpPr>
-        <p:spPr>
-          <a:xfrm>
-            <a:off x="9784080" y="3511296"/>
-            <a:ext cx="1828800" cy="457200"/>
-          </a:xfrm>
-          <a:prstGeom prst="roundRect">
-            <a:avLst/>
-          </a:prstGeom>
-          <a:solidFill>
-            <a:srgbClr val="FAFCFF"/>
-          </a:solidFill>
-          <a:ln w="12700">
-            <a:solidFill>
-              <a:srgbClr val="0EA5E9"/>
-            </a:solidFill>
-          </a:ln>
-        </p:spPr>
-        <p:style>
-          <a:lnRef idx="1">
-            <a:schemeClr val="accent1"/>
-          </a:lnRef>
-          <a:fillRef idx="3">
-            <a:schemeClr val="accent1"/>
-          </a:fillRef>
-          <a:effectRef idx="2">
-            <a:schemeClr val="accent1"/>
-          </a:effectRef>
-          <a:fontRef idx="minor">
-            <a:schemeClr val="lt1"/>
-          </a:fontRef>
-        </p:style>
-        <p:txBody>
-          <a:bodyPr rtlCol="0" anchor="ctr" wrap="square" tIns="36576" bIns="18288" lIns="54864" rIns="54864"/>
-          <a:lstStyle/>
-          <a:p>
-            <a:pPr algn="ctr">
-              <a:defRPr sz="950" b="1">
-                <a:solidFill>
-                  <a:srgbClr val="212529"/>
-                </a:solidFill>
-              </a:defRPr>
-            </a:pPr>
-            <a:r>
-              <a:t>🎨 Tailwind CSS</a:t>
-            </a:r>
-          </a:p>
-          <a:p>
-            <a:pPr>
-              <a:defRPr sz="750">
-                <a:solidFill>
-                  <a:srgbClr val="646E78"/>
-                </a:solidFill>
-              </a:defRPr>
-            </a:pPr>
-            <a:r>
-              <a:t>Utility-First Design</a:t>
-            </a:r>
-          </a:p>
-        </p:txBody>
-      </p:sp>
-      <p:sp>
-        <p:nvSpPr>
-          <p:cNvPr id="49" name="Rounded Rectangle 48"/>
-          <p:cNvSpPr/>
-          <p:nvPr/>
-        </p:nvSpPr>
-        <p:spPr>
-          <a:xfrm>
-            <a:off x="9784080" y="4050792"/>
-            <a:ext cx="1828800" cy="457200"/>
-          </a:xfrm>
-          <a:prstGeom prst="roundRect">
-            <a:avLst/>
-          </a:prstGeom>
-          <a:solidFill>
-            <a:srgbClr val="FAFCFF"/>
-          </a:solidFill>
-          <a:ln w="12700">
-            <a:solidFill>
-              <a:srgbClr val="EE4C2C"/>
-            </a:solidFill>
-          </a:ln>
-        </p:spPr>
-        <p:style>
-          <a:lnRef idx="1">
-            <a:schemeClr val="accent1"/>
-          </a:lnRef>
-          <a:fillRef idx="3">
-            <a:schemeClr val="accent1"/>
-          </a:fillRef>
-          <a:effectRef idx="2">
-            <a:schemeClr val="accent1"/>
-          </a:effectRef>
-          <a:fontRef idx="minor">
-            <a:schemeClr val="lt1"/>
-          </a:fontRef>
-        </p:style>
-        <p:txBody>
-          <a:bodyPr rtlCol="0" anchor="ctr" wrap="square" tIns="36576" bIns="18288" lIns="54864" rIns="54864"/>
-          <a:lstStyle/>
-          <a:p>
-            <a:pPr algn="ctr">
-              <a:defRPr sz="950" b="1">
-                <a:solidFill>
-                  <a:srgbClr val="212529"/>
-                </a:solidFill>
-              </a:defRPr>
-            </a:pPr>
-            <a:r>
-              <a:t>🔥 PyTorch</a:t>
-            </a:r>
-          </a:p>
-          <a:p>
-            <a:pPr>
-              <a:defRPr sz="750">
-                <a:solidFill>
-                  <a:srgbClr val="646E78"/>
-                </a:solidFill>
-              </a:defRPr>
-            </a:pPr>
-            <a:r>
-              <a:t>Deep Learning &amp; VLM</a:t>
-            </a:r>
-          </a:p>
-        </p:txBody>
-      </p:sp>
-      <p:sp>
-        <p:nvSpPr>
-          <p:cNvPr id="50" name="Rounded Rectangle 49"/>
-          <p:cNvSpPr/>
-          <p:nvPr/>
-        </p:nvSpPr>
-        <p:spPr>
-          <a:xfrm>
-            <a:off x="9784080" y="4590288"/>
-            <a:ext cx="1828800" cy="457200"/>
-          </a:xfrm>
-          <a:prstGeom prst="roundRect">
-            <a:avLst/>
-          </a:prstGeom>
-          <a:solidFill>
-            <a:srgbClr val="FAFCFF"/>
-          </a:solidFill>
-          <a:ln w="12700">
-            <a:solidFill>
-              <a:srgbClr val="4CAF50"/>
-            </a:solidFill>
-          </a:ln>
-        </p:spPr>
-        <p:style>
-          <a:lnRef idx="1">
-            <a:schemeClr val="accent1"/>
-          </a:lnRef>
-          <a:fillRef idx="3">
-            <a:schemeClr val="accent1"/>
-          </a:fillRef>
-          <a:effectRef idx="2">
-            <a:schemeClr val="accent1"/>
-          </a:effectRef>
-          <a:fontRef idx="minor">
-            <a:schemeClr val="lt1"/>
-          </a:fontRef>
-        </p:style>
-        <p:txBody>
-          <a:bodyPr rtlCol="0" anchor="ctr" wrap="square" tIns="36576" bIns="18288" lIns="54864" rIns="54864"/>
-          <a:lstStyle/>
-          <a:p>
-            <a:pPr algn="ctr">
-              <a:defRPr sz="950" b="1">
-                <a:solidFill>
-                  <a:srgbClr val="212529"/>
-                </a:solidFill>
-              </a:defRPr>
-            </a:pPr>
-            <a:r>
-              <a:t>🌐 GDAL / Rasterio</a:t>
-            </a:r>
-          </a:p>
-          <a:p>
-            <a:pPr>
-              <a:defRPr sz="750">
-                <a:solidFill>
-                  <a:srgbClr val="646E78"/>
-                </a:solidFill>
-              </a:defRPr>
-            </a:pPr>
-            <a:r>
-              <a:t>Geospatial Raster Math</a:t>
-            </a:r>
-          </a:p>
-        </p:txBody>
-      </p:sp>
-      <p:sp>
-        <p:nvSpPr>
-          <p:cNvPr id="51" name="Rounded Rectangle 50"/>
-          <p:cNvSpPr/>
-          <p:nvPr/>
-        </p:nvSpPr>
-        <p:spPr>
-          <a:xfrm>
-            <a:off x="9784080" y="5129784"/>
-            <a:ext cx="1828800" cy="457200"/>
-          </a:xfrm>
-          <a:prstGeom prst="roundRect">
-            <a:avLst/>
-          </a:prstGeom>
-          <a:solidFill>
-            <a:srgbClr val="FAFCFF"/>
-          </a:solidFill>
-          <a:ln w="12700">
-            <a:solidFill>
-              <a:srgbClr val="FFB300"/>
-            </a:solidFill>
-          </a:ln>
-        </p:spPr>
-        <p:style>
-          <a:lnRef idx="1">
-            <a:schemeClr val="accent1"/>
-          </a:lnRef>
-          <a:fillRef idx="3">
-            <a:schemeClr val="accent1"/>
-          </a:fillRef>
-          <a:effectRef idx="2">
-            <a:schemeClr val="accent1"/>
-          </a:effectRef>
-          <a:fontRef idx="minor">
-            <a:schemeClr val="lt1"/>
-          </a:fontRef>
-        </p:style>
-        <p:txBody>
-          <a:bodyPr rtlCol="0" anchor="ctr" wrap="square" tIns="36576" bIns="18288" lIns="54864" rIns="54864"/>
-          <a:lstStyle/>
-          <a:p>
-            <a:pPr algn="ctr">
-              <a:defRPr sz="950" b="1">
-                <a:solidFill>
-                  <a:srgbClr val="212529"/>
-                </a:solidFill>
-              </a:defRPr>
-            </a:pPr>
-            <a:r>
-              <a:t>🤗 Transformers</a:t>
-            </a:r>
-          </a:p>
-          <a:p>
-            <a:pPr>
-              <a:defRPr sz="750">
-                <a:solidFill>
-                  <a:srgbClr val="646E78"/>
-                </a:solidFill>
-              </a:defRPr>
-            </a:pPr>
-            <a:r>
-              <a:t>BLIP VQA &amp; Grounding</a:t>
-            </a:r>
-          </a:p>
-        </p:txBody>
-      </p:sp>
-      <p:sp>
-        <p:nvSpPr>
-          <p:cNvPr id="52" name="Rectangle 51"/>
+                  <a:srgbClr val="212529"/>
+                </a:solidFill>
+              </a:defRPr>
+            </a:pPr>
+            <a:r>
+              <a:t>Deterministic capability router maps queries to specialist engines -&gt; Pairs all answers with spatial GeoJSON masks, calibrated confidence scores (84-98%), and exportable audit logs.</a:t>
+            </a:r>
+          </a:p>
+        </p:txBody>
+      </p:sp>
+      <p:sp>
+        <p:nvSpPr>
+          <p:cNvPr id="21" name="Rectangle 20"/>
           <p:cNvSpPr/>
           <p:nvPr/>
         </p:nvSpPr>
@@ -7335,7 +5490,7 @@
       </p:sp>
       <p:sp>
         <p:nvSpPr>
-          <p:cNvPr id="53" name="TextBox 52"/>
+          <p:cNvPr id="22" name="TextBox 21"/>
           <p:cNvSpPr txBox="1"/>
           <p:nvPr/>
         </p:nvSpPr>
@@ -7370,7 +5525,7 @@
       </p:sp>
       <p:sp>
         <p:nvSpPr>
-          <p:cNvPr id="54" name="TextBox 53"/>
+          <p:cNvPr id="23" name="TextBox 22"/>
           <p:cNvSpPr txBox="1"/>
           <p:nvPr/>
         </p:nvSpPr>

</xml_diff>